<commit_message>
Desaladora: punch consolidado al 13-09-2026
Entra el Listado_Puntos_Punch_Consolidado del 13-09 sobre el REPORTE que
sigue declarando el 01-09, así que la pestaña conserva ese corte y el punch
se apoya en el archivo nuevo, como está definido.

El punch pasa de 1.855 a 2.186 ítems. Se cerraron 114 y entraron 331, así
que los abiertos suben de 561 a 778 y el cierre P1 baja de 69,3% a 67,6%
aunque se haya avanzado. Los atrasados bajan de 318 a 293.

131 de los ítems nuevos entran SIN categoría y sin fecha requerida: son
todos del subsistema 4511-WW-201, caminata 2, detectados en septiembre. Es
una caminata recién levantada y todavía sin priorizar. Quedan fuera del
conteo por prioridad —no se puede contar un ítem en una prioridad que no
tiene— y el panel los declara.

102 comprobaciones OK · suite verificada en 1366/1920/2560.

Co-Authored-By: Claude Opus 5 <noreply@anthropic.com>
Claude-Session: https://claude.ai/code/session_011SHyPcub1TtjA2kTAsaPFu
</commit_message>
<xml_diff>
--- a/panel_control_TOP_P1/Panel_Control_TOP_P1.pptx
+++ b/panel_control_TOP_P1/Panel_Control_TOP_P1.pptx
@@ -828,16 +828,16 @@
                     <c:v>Piping</c:v>
                   </c:pt>
                   <c:pt idx="2">
+                    <c:v>Mecánica</c:v>
+                  </c:pt>
+                  <c:pt idx="3">
                     <c:v>Obras Civiles</c:v>
                   </c:pt>
-                  <c:pt idx="3">
-                    <c:v>Estructura</c:v>
-                  </c:pt>
                   <c:pt idx="4">
-                    <c:v>Mecánica</c:v>
+                    <c:v>Instr. y Control</c:v>
                   </c:pt>
                   <c:pt idx="5">
-                    <c:v>Instr. y Control</c:v>
+                    <c:v>Estructura</c:v>
                   </c:pt>
                 </c:lvl>
               </c:multiLvlStrCache>
@@ -850,22 +850,22 @@
                 <c:formatCode>General</c:formatCode>
                 <c:ptCount val="6"/>
                 <c:pt idx="0">
-                  <c:v>119</c:v>
+                  <c:v>109</c:v>
                 </c:pt>
                 <c:pt idx="1">
-                  <c:v>35</c:v>
+                  <c:v>31</c:v>
                 </c:pt>
                 <c:pt idx="2">
-                  <c:v>13</c:v>
+                  <c:v>10</c:v>
                 </c:pt>
                 <c:pt idx="3">
-                  <c:v>7</c:v>
+                  <c:v>12</c:v>
                 </c:pt>
                 <c:pt idx="4">
-                  <c:v>10</c:v>
+                  <c:v/>
                 </c:pt>
                 <c:pt idx="5">
-                  <c:v/>
+                  <c:v>6</c:v>
                 </c:pt>
               </c:numCache>
             </c:numRef>
@@ -930,16 +930,16 @@
                     <c:v>Piping</c:v>
                   </c:pt>
                   <c:pt idx="2">
+                    <c:v>Mecánica</c:v>
+                  </c:pt>
+                  <c:pt idx="3">
                     <c:v>Obras Civiles</c:v>
                   </c:pt>
-                  <c:pt idx="3">
-                    <c:v>Estructura</c:v>
-                  </c:pt>
                   <c:pt idx="4">
-                    <c:v>Mecánica</c:v>
+                    <c:v>Instr. y Control</c:v>
                   </c:pt>
                   <c:pt idx="5">
-                    <c:v>Instr. y Control</c:v>
+                    <c:v>Estructura</c:v>
                   </c:pt>
                 </c:lvl>
               </c:multiLvlStrCache>
@@ -952,19 +952,19 @@
                 <c:formatCode>General</c:formatCode>
                 <c:ptCount val="6"/>
                 <c:pt idx="0">
-                  <c:v>52</c:v>
+                  <c:v>81</c:v>
                 </c:pt>
                 <c:pt idx="1">
-                  <c:v>91</c:v>
+                  <c:v>120</c:v>
                 </c:pt>
                 <c:pt idx="2">
-                  <c:v>8</c:v>
+                  <c:v>20</c:v>
                 </c:pt>
                 <c:pt idx="3">
-                  <c:v>7</c:v>
+                  <c:v>9</c:v>
                 </c:pt>
                 <c:pt idx="4">
-                  <c:v>1</c:v>
+                  <c:v>17</c:v>
                 </c:pt>
                 <c:pt idx="5">
                   <c:v>8</c:v>
@@ -1340,13 +1340,13 @@
               <c:numCache>
                 <c:ptCount val="3"/>
                 <c:pt idx="0">
-                  <c:v>794</c:v>
+                  <c:v>881</c:v>
                 </c:pt>
                 <c:pt idx="1">
-                  <c:v>184</c:v>
+                  <c:v>168</c:v>
                 </c:pt>
                 <c:pt idx="2">
-                  <c:v>167</c:v>
+                  <c:v>255</c:v>
                 </c:pt>
               </c:numCache>
             </c:numRef>
@@ -7141,7 +7141,7 @@
                 <a:ea typeface="Cambria" pitchFamily="34" charset="-122"/>
                 <a:cs typeface="Cambria" pitchFamily="34" charset="-120"/>
               </a:rPr>
-              <a:t>69,3%</a:t>
+              <a:t>67,6%</a:t>
             </a:r>
             <a:endParaRPr lang="en-US" sz="3400" dirty="0"/>
           </a:p>
@@ -7258,7 +7258,7 @@
                 <a:ea typeface="Calibri" pitchFamily="34" charset="-122"/>
                 <a:cs typeface="Calibri" pitchFamily="34" charset="-120"/>
               </a:rPr>
-              <a:t>Fuente: REPORTE_GERENCIAL + Listado de Puntos Punch Consolidado · Corte 01-09-2026 · Atrasos al 07-09-2026</a:t>
+              <a:t>Fuente: REPORTE_GERENCIAL + Listado de Puntos Punch Consolidado · Corte 01-09-2026 · Atrasos al 13-09-2026</a:t>
             </a:r>
             <a:endParaRPr lang="en-US" sz="850" dirty="0"/>
           </a:p>
@@ -16713,7 +16713,7 @@
                 <a:ea typeface="Cambria" pitchFamily="34" charset="-122"/>
                 <a:cs typeface="Cambria" pitchFamily="34" charset="-120"/>
               </a:rPr>
-              <a:t>69,3%</a:t>
+              <a:t>67,6%</a:t>
             </a:r>
             <a:endParaRPr lang="en-US" sz="3800" dirty="0"/>
           </a:p>
@@ -16752,7 +16752,7 @@
                 <a:ea typeface="Calibri" pitchFamily="34" charset="-122"/>
                 <a:cs typeface="Calibri" pitchFamily="34" charset="-120"/>
               </a:rPr>
-              <a:t>794/1.145</a:t>
+              <a:t>881/1.304</a:t>
             </a:r>
             <a:endParaRPr lang="en-US" sz="1400" dirty="0"/>
           </a:p>
@@ -16833,7 +16833,7 @@
                 <a:ea typeface="Calibri" pitchFamily="34" charset="-122"/>
                 <a:cs typeface="Calibri" pitchFamily="34" charset="-120"/>
               </a:rPr>
-              <a:t>351 abiertos · 184 atrasados</a:t>
+              <a:t>423 abiertos · 168 atrasados</a:t>
             </a:r>
             <a:endParaRPr lang="en-US" sz="950" dirty="0"/>
           </a:p>
@@ -16973,7 +16973,7 @@
                 <a:ea typeface="Calibri" pitchFamily="34" charset="-122"/>
                 <a:cs typeface="Calibri" pitchFamily="34" charset="-120"/>
               </a:rPr>
-              <a:t>1.294 de 1.855 ítems cerrados (69,8%); de los 561 abiertos, 318 ya pasaron su fecha requerida de cierre (56,7%).</a:t>
+              <a:t>1.408 de 2.186 ítems cerrados (64,4%); de los 778 abiertos, 293 ya pasaron su fecha requerida de cierre (37,7%).</a:t>
             </a:r>
             <a:endParaRPr lang="en-US" sz="1150" dirty="0"/>
           </a:p>
@@ -17210,7 +17210,7 @@
                 <a:ea typeface="Calibri" pitchFamily="34" charset="-122"/>
                 <a:cs typeface="Calibri" pitchFamily="34" charset="-120"/>
               </a:rPr>
-              <a:t>171 de los 351 P1 abiertos (48,7%), con 119 atrasados.</a:t>
+              <a:t>190 de los 423 P1 abiertos (44,9%), con 109 atrasados.</a:t>
             </a:r>
             <a:endParaRPr lang="en-US" sz="1150" dirty="0"/>
           </a:p>
@@ -17249,7 +17249,7 @@
                 <a:ea typeface="Calibri" pitchFamily="34" charset="-122"/>
                 <a:cs typeface="Calibri" pitchFamily="34" charset="-120"/>
               </a:rPr>
-              <a:t>Fuente: REPORTE_GERENCIAL + Listado de Puntos Punch Consolidado · Corte 01-09-2026 · Atrasos al 07-09-2026</a:t>
+              <a:t>Fuente: REPORTE_GERENCIAL + Listado de Puntos Punch Consolidado · Corte 01-09-2026 · Atrasos al 13-09-2026</a:t>
             </a:r>
             <a:endParaRPr lang="en-US" sz="850" dirty="0"/>
           </a:p>
@@ -18458,7 +18458,7 @@
                 <a:ea typeface="Calibri" pitchFamily="34" charset="-122"/>
                 <a:cs typeface="Calibri" pitchFamily="34" charset="-120"/>
               </a:rPr>
-              <a:t>Fuente: REPORTE_GERENCIAL + Listado de Puntos Punch Consolidado · Corte 01-09-2026 · Atrasos al 07-09-2026</a:t>
+              <a:t>Fuente: REPORTE_GERENCIAL + Listado de Puntos Punch Consolidado · Corte 01-09-2026 · Atrasos al 13-09-2026</a:t>
             </a:r>
             <a:endParaRPr lang="en-US" sz="850" dirty="0"/>
           </a:p>
@@ -18709,7 +18709,7 @@
                 <a:ea typeface="Calibri" pitchFamily="34" charset="-122"/>
                 <a:cs typeface="Calibri" pitchFamily="34" charset="-120"/>
               </a:rPr>
-              <a:t>1.145 P1 levantados; 69,3% cerrados. Atrasado = ítem abierto cuya fecha requerida de cierre ya venció al 07-09-2026.</a:t>
+              <a:t>1.304 P1 levantados; 67,6% cerrados. Atrasado = ítem abierto cuya fecha requerida de cierre ya venció al 13-09-2026.</a:t>
             </a:r>
             <a:endParaRPr lang="en-US" sz="1350" dirty="0"/>
           </a:p>
@@ -18841,7 +18841,7 @@
                 <a:ea typeface="Cambria" pitchFamily="34" charset="-122"/>
                 <a:cs typeface="Cambria" pitchFamily="34" charset="-120"/>
               </a:rPr>
-              <a:t>69,3%</a:t>
+              <a:t>67,6%</a:t>
             </a:r>
             <a:endParaRPr lang="en-US" sz="1900" dirty="0"/>
           </a:p>
@@ -18956,7 +18956,7 @@
                 <a:ea typeface="Calibri" pitchFamily="34" charset="-122"/>
                 <a:cs typeface="Calibri" pitchFamily="34" charset="-120"/>
               </a:rPr>
-              <a:t>794</a:t>
+              <a:t>881</a:t>
             </a:r>
             <a:endParaRPr lang="en-US" sz="1100" dirty="0"/>
           </a:p>
@@ -19054,7 +19054,7 @@
                 <a:ea typeface="Calibri" pitchFamily="34" charset="-122"/>
                 <a:cs typeface="Calibri" pitchFamily="34" charset="-120"/>
               </a:rPr>
-              <a:t>184</a:t>
+              <a:t>168</a:t>
             </a:r>
             <a:endParaRPr lang="en-US" sz="1100" dirty="0"/>
           </a:p>
@@ -19152,7 +19152,7 @@
                 <a:ea typeface="Calibri" pitchFamily="34" charset="-122"/>
                 <a:cs typeface="Calibri" pitchFamily="34" charset="-120"/>
               </a:rPr>
-              <a:t>167</a:t>
+              <a:t>255</a:t>
             </a:r>
             <a:endParaRPr lang="en-US" sz="1100" dirty="0"/>
           </a:p>
@@ -19235,7 +19235,7 @@
                 <a:ea typeface="Calibri" pitchFamily="34" charset="-122"/>
                 <a:cs typeface="Calibri" pitchFamily="34" charset="-120"/>
               </a:rPr>
-              <a:t>Mediana de 7 días vencidos; el más antiguo lleva 120. 192 entre 1-30 días, 112 entre 31-90 días, 14 entre 91-180 días.</a:t>
+              <a:t>Mediana de 13 días vencidos; el más antiguo lleva 126. 171 entre 1-30 días, 108 entre 31-90 días, 14 entre 91-180 días.</a:t>
             </a:r>
             <a:endParaRPr lang="en-US" sz="1150" dirty="0"/>
           </a:p>
@@ -19274,7 +19274,7 @@
                 <a:ea typeface="Calibri" pitchFamily="34" charset="-122"/>
                 <a:cs typeface="Calibri" pitchFamily="34" charset="-120"/>
               </a:rPr>
-              <a:t>Fuente: REPORTE_GERENCIAL + Listado de Puntos Punch Consolidado · Corte 01-09-2026 · Atrasos al 07-09-2026</a:t>
+              <a:t>Fuente: REPORTE_GERENCIAL + Listado de Puntos Punch Consolidado · Corte 01-09-2026 · Atrasos al 13-09-2026</a:t>
             </a:r>
             <a:endParaRPr lang="en-US" sz="850" dirty="0"/>
           </a:p>
@@ -19606,7 +19606,7 @@
                 <a:ea typeface="Calibri" pitchFamily="34" charset="-122"/>
                 <a:cs typeface="Calibri" pitchFamily="34" charset="-120"/>
               </a:rPr>
-              <a:t>Recuperar los 318 ítems atrasados</a:t>
+              <a:t>Recuperar los 293 ítems atrasados</a:t>
             </a:r>
             <a:endParaRPr lang="en-US" sz="1400" dirty="0"/>
           </a:p>
@@ -19648,7 +19648,7 @@
                 <a:ea typeface="Calibri" pitchFamily="34" charset="-122"/>
                 <a:cs typeface="Calibri" pitchFamily="34" charset="-120"/>
               </a:rPr>
-              <a:t>56,7% de los 561 abiertos ya venció su fecha requerida. Foco en Eléctrica (119), Piping (35), Obras Civiles (13).</a:t>
+              <a:t>37,7% de los 778 abiertos ya venció su fecha requerida. Foco en Eléctrica (109), Piping (31), Mecánica (10).</a:t>
             </a:r>
             <a:endParaRPr lang="en-US" sz="1100" dirty="0"/>
           </a:p>
@@ -20074,7 +20074,7 @@
                 <a:ea typeface="Calibri" pitchFamily="34" charset="-122"/>
                 <a:cs typeface="Calibri" pitchFamily="34" charset="-120"/>
               </a:rPr>
-              <a:t>Concentra 287 P1 abiertos y 138 atrasados sobre 74 subsistemas. Es la ruta crítica del proyecto.</a:t>
+              <a:t>Concentra 369 P1 abiertos y 125 atrasados sobre 74 subsistemas. Es la ruta crítica del proyecto.</a:t>
             </a:r>
             <a:endParaRPr lang="en-US" sz="1100" dirty="0"/>
           </a:p>
@@ -20113,7 +20113,7 @@
                 <a:ea typeface="Calibri" pitchFamily="34" charset="-122"/>
                 <a:cs typeface="Calibri" pitchFamily="34" charset="-120"/>
               </a:rPr>
-              <a:t>Fuente: REPORTE_GERENCIAL + Listado de Puntos Punch Consolidado · Corte 01-09-2026 · Atrasos al 07-09-2026</a:t>
+              <a:t>Fuente: REPORTE_GERENCIAL + Listado de Puntos Punch Consolidado · Corte 01-09-2026 · Atrasos al 13-09-2026</a:t>
             </a:r>
             <a:endParaRPr lang="en-US" sz="850" dirty="0"/>
           </a:p>

</xml_diff>

<commit_message>
Arqueros: mientras no diga «Cerrado», el detalle está abierto
El panel mostraba menos abiertos que el propio Excel del cliente: en el área
2000, 3 contra los 5 que declara su hoja Resumen. La causa era un tercer grupo
propio, «en trámite», que sacaba del conteo los estatus «Listo para revisión» y
«Listo para cerrar».

Pasan a contar como abiertos, que es la regla del proyecto. Los P1 abiertos
cuadran ahora área por área con MASA: 5 · 586 · 49 · 0 = 663. Los vencidos suben
de 508 a 533, porque esos detalles también arrastraban fecha vencida.

Cuántos esperan revisión del cliente se sigue informando —54 al corte—, pero
como subconjunto de los abiertos: esa pelota no es nuestra, y aun así el detalle
está abierto.

132 comprobaciones OK · 0 fallan.

Co-Authored-By: Claude Opus 5 <noreply@anthropic.com>
Claude-Session: https://claude.ai/code/session_011SHyPcub1TtjA2kTAsaPFu
</commit_message>
<xml_diff>
--- a/panel_control_TOP_P1/Panel_Control_TOP_P1.pptx
+++ b/panel_control_TOP_P1/Panel_Control_TOP_P1.pptx
@@ -690,10 +690,10 @@
                   <c:v>1362</c:v>
                 </c:pt>
                 <c:pt idx="1">
-                  <c:v>633</c:v>
+                  <c:v>663</c:v>
                 </c:pt>
                 <c:pt idx="2">
-                  <c:v>30</c:v>
+                  <c:v>0</c:v>
                 </c:pt>
               </c:numCache>
             </c:numRef>
@@ -4007,10 +4007,10 @@
                 <c:ptCount val="6"/>
                 <c:lvl>
                   <c:pt idx="0">
-                    <c:v>Eléctrica</c:v>
+                    <c:v>Piping</c:v>
                   </c:pt>
                   <c:pt idx="1">
-                    <c:v>Piping</c:v>
+                    <c:v>Eléctrica</c:v>
                   </c:pt>
                   <c:pt idx="2">
                     <c:v>Instrum. y Control</c:v>
@@ -4035,13 +4035,13 @@
                 <c:formatCode>General</c:formatCode>
                 <c:ptCount val="6"/>
                 <c:pt idx="0">
-                  <c:v>153</c:v>
+                  <c:v>156</c:v>
                 </c:pt>
                 <c:pt idx="1">
-                  <c:v>135</c:v>
+                  <c:v>155</c:v>
                 </c:pt>
                 <c:pt idx="2">
-                  <c:v>138</c:v>
+                  <c:v>139</c:v>
                 </c:pt>
                 <c:pt idx="3">
                   <c:v>78</c:v>
@@ -4050,7 +4050,7 @@
                   <c:v/>
                 </c:pt>
                 <c:pt idx="5">
-                  <c:v>4</c:v>
+                  <c:v>5</c:v>
                 </c:pt>
               </c:numCache>
             </c:numRef>
@@ -4109,10 +4109,10 @@
                 <c:ptCount val="6"/>
                 <c:lvl>
                   <c:pt idx="0">
-                    <c:v>Eléctrica</c:v>
+                    <c:v>Piping</c:v>
                   </c:pt>
                   <c:pt idx="1">
-                    <c:v>Piping</c:v>
+                    <c:v>Eléctrica</c:v>
                   </c:pt>
                   <c:pt idx="2">
                     <c:v>Instrum. y Control</c:v>
@@ -4137,10 +4137,10 @@
                 <c:formatCode>General</c:formatCode>
                 <c:ptCount val="6"/>
                 <c:pt idx="0">
-                  <c:v>34</c:v>
+                  <c:v>33</c:v>
                 </c:pt>
                 <c:pt idx="1">
-                  <c:v>30</c:v>
+                  <c:v>34</c:v>
                 </c:pt>
                 <c:pt idx="2">
                   <c:v>24</c:v>
@@ -4152,7 +4152,7 @@
                   <c:v>17</c:v>
                 </c:pt>
                 <c:pt idx="5">
-                  <c:v>5</c:v>
+                  <c:v>7</c:v>
                 </c:pt>
               </c:numCache>
             </c:numRef>
@@ -9792,7 +9792,7 @@
                 <a:ea typeface="Calibri" pitchFamily="34" charset="-122"/>
                 <a:cs typeface="Calibri" pitchFamily="34" charset="-120"/>
               </a:rPr>
-              <a:t>633 abiertos · 508 vencidos · 30 en trámite</a:t>
+              <a:t>663 abiertos · 533 vencidos</a:t>
             </a:r>
             <a:endParaRPr lang="en-US" sz="950" dirty="0"/>
           </a:p>
@@ -10129,7 +10129,7 @@
                 <a:ea typeface="Calibri" pitchFamily="34" charset="-122"/>
                 <a:cs typeface="Calibri" pitchFamily="34" charset="-120"/>
               </a:rPr>
-              <a:t>+46 P1 cerrado desde el corte anterior; 633 abiertos, de los cuales 508 superaron su fecha de vencimiento. El área 3000 concentra 562 (88,8%).</a:t>
+              <a:t>+46 P1 cerrado desde el corte anterior; 663 abiertos, de los cuales 533 superaron su fecha de vencimiento. El área 3000 concentra 586 (88,4%).</a:t>
             </a:r>
             <a:endParaRPr lang="en-US" sz="1250" dirty="0"/>
           </a:p>
@@ -10949,7 +10949,7 @@
                 <a:ea typeface="Calibri" pitchFamily="34" charset="-122"/>
                 <a:cs typeface="Calibri" pitchFamily="34" charset="-120"/>
               </a:rPr>
-              <a:t>3 (1)</a:t>
+              <a:t>5 (3)</a:t>
             </a:r>
             <a:endParaRPr lang="en-US" sz="1300" dirty="0"/>
           </a:p>
@@ -11326,7 +11326,7 @@
                 <a:ea typeface="Calibri" pitchFamily="34" charset="-122"/>
                 <a:cs typeface="Calibri" pitchFamily="34" charset="-120"/>
               </a:rPr>
-              <a:t>562 (481)</a:t>
+              <a:t>586 (503)</a:t>
             </a:r>
             <a:endParaRPr lang="en-US" sz="1300" dirty="0"/>
           </a:p>
@@ -14128,7 +14128,7 @@
                 <a:ea typeface="Calibri" pitchFamily="34" charset="-122"/>
                 <a:cs typeface="Calibri" pitchFamily="34" charset="-120"/>
               </a:rPr>
-              <a:t>2.025 P1 levantados; 67,3% cerrados. El pendiente se concentra en Eléctrica, Piping, Instrumentación y Control, y físicamente en el área 3000.</a:t>
+              <a:t>2.025 P1 levantados; 67,3% cerrados. El pendiente se concentra en Piping, Eléctrica, Instrumentación y Control, y físicamente en el área 3000.</a:t>
             </a:r>
             <a:endParaRPr lang="en-US" sz="1350" dirty="0"/>
           </a:p>
@@ -14473,7 +14473,7 @@
                 <a:ea typeface="Calibri" pitchFamily="34" charset="-122"/>
                 <a:cs typeface="Calibri" pitchFamily="34" charset="-120"/>
               </a:rPr>
-              <a:t>633</a:t>
+              <a:t>663</a:t>
             </a:r>
             <a:endParaRPr lang="en-US" sz="1100" dirty="0"/>
           </a:p>
@@ -14571,7 +14571,7 @@
                 <a:ea typeface="Calibri" pitchFamily="34" charset="-122"/>
                 <a:cs typeface="Calibri" pitchFamily="34" charset="-120"/>
               </a:rPr>
-              <a:t>30</a:t>
+              <a:t>0</a:t>
             </a:r>
             <a:endParaRPr lang="en-US" sz="1100" dirty="0"/>
           </a:p>
@@ -14654,7 +14654,7 @@
                 <a:ea typeface="Calibri" pitchFamily="34" charset="-122"/>
                 <a:cs typeface="Calibri" pitchFamily="34" charset="-120"/>
               </a:rPr>
-              <a:t>562 de 633 P1 abiertos (88,8%) están en el área 3000. Áreas 2000 y 8000 sobre 90% de cierre.</a:t>
+              <a:t>586 de 663 P1 abiertos (88,4%) están en el área 3000. Áreas 2000 y 8000 sobre 90% de cierre.</a:t>
             </a:r>
             <a:endParaRPr lang="en-US" sz="1150" dirty="0"/>
           </a:p>
@@ -15209,7 +15209,7 @@
                 <a:ea typeface="Calibri" pitchFamily="34" charset="-122"/>
                 <a:cs typeface="Calibri" pitchFamily="34" charset="-120"/>
               </a:rPr>
-              <a:t>562 P1 abiertos (88,8% del total) y 32 caminatas 100% pendientes. Es la ruta crítica: sin esta área no mejora ningún indicador global.</a:t>
+              <a:t>586 P1 abiertos (88,4% del total) y 32 caminatas 100% pendientes. Es la ruta crítica: sin esta área no mejora ningún indicador global.</a:t>
             </a:r>
             <a:endParaRPr lang="en-US" sz="1150" dirty="0"/>
           </a:p>
@@ -15309,7 +15309,7 @@
                 <a:ea typeface="Calibri" pitchFamily="34" charset="-122"/>
                 <a:cs typeface="Calibri" pitchFamily="34" charset="-120"/>
               </a:rPr>
-              <a:t>Recuperar los 508 P1 vencidos</a:t>
+              <a:t>Recuperar los 533 P1 vencidos</a:t>
             </a:r>
             <a:endParaRPr lang="en-US" sz="1500" dirty="0"/>
           </a:p>
@@ -15351,7 +15351,7 @@
                 <a:ea typeface="Calibri" pitchFamily="34" charset="-122"/>
                 <a:cs typeface="Calibri" pitchFamily="34" charset="-120"/>
               </a:rPr>
-              <a:t>80,3% de los P1 abiertos superó su fecha de vencimiento. Foco en Eléctrica (153), Instrumentación y Control (138), Piping (135).</a:t>
+              <a:t>80,4% de los P1 abiertos superó su fecha de vencimiento. Foco en Piping (156), Eléctrica (155), Instrumentación y Control (139).</a:t>
             </a:r>
             <a:endParaRPr lang="en-US" sz="1150" dirty="0"/>
           </a:p>

</xml_diff>

<commit_message>
Talabre al 28-09-2026 — la suite queda completa en el corte
DT 2.141 registros, 86,3% cerrado. Atrasados 73 → 57. P1 crece de 409 a 423 y
sus abiertos de 24 a 30, así que el cierre baja de 94,1% a 92,9% pese a sumar 8
cerrados: entraron 14 DT nuevos de prioridad 1.

El extracto de pendientes del archivo de STATUS ya viene al día: declara 296
contra los 294 del registro, frente a los 58 de diferencia del corte anterior.
La última emisión del registro pasó de 15-09 a 25-09.

Corte completo: Protocolos 28-09 · Cierre QAQC con Arqueros y Talabre al 28-09 y
Desaladora con reporte del 22-09 más punch del 28-09 · No Conformidades 28-09.

133 comprobaciones OK · 0 fallan · 2 avisos.

Co-Authored-By: Claude Opus 5 <noreply@anthropic.com>
Claude-Session: https://claude.ai/code/session_011SHyPcub1TtjA2kTAsaPFu
</commit_message>
<xml_diff>
--- a/panel_control_TOP_P1/Panel_Control_TOP_P1.pptx
+++ b/panel_control_TOP_P1/Panel_Control_TOP_P1.pptx
@@ -1512,7 +1512,7 @@
                 <c:formatCode>General</c:formatCode>
                 <c:ptCount val="9"/>
                 <c:pt idx="0">
-                  <c:v/>
+                  <c:v>1</c:v>
                 </c:pt>
                 <c:pt idx="1">
                   <c:v>20</c:v>
@@ -1527,7 +1527,7 @@
                   <c:v>14</c:v>
                 </c:pt>
                 <c:pt idx="5">
-                  <c:v>15</c:v>
+                  <c:v>21</c:v>
                 </c:pt>
                 <c:pt idx="6">
                   <c:v>110</c:v>
@@ -1632,7 +1632,7 @@
                 <c:formatCode>General</c:formatCode>
                 <c:ptCount val="9"/>
                 <c:pt idx="0">
-                  <c:v>3</c:v>
+                  <c:v>2</c:v>
                 </c:pt>
                 <c:pt idx="1">
                   <c:v/>
@@ -1647,7 +1647,7 @@
                   <c:v/>
                 </c:pt>
                 <c:pt idx="5">
-                  <c:v>7</c:v>
+                  <c:v>1</c:v>
                 </c:pt>
                 <c:pt idx="6">
                   <c:v/>
@@ -2619,16 +2619,16 @@
                   <c:v>3</c:v>
                 </c:pt>
                 <c:pt idx="1">
-                  <c:v>33</c:v>
+                  <c:v>24</c:v>
                 </c:pt>
                 <c:pt idx="2">
-                  <c:v>25</c:v>
+                  <c:v>21</c:v>
                 </c:pt>
                 <c:pt idx="3">
-                  <c:v>10</c:v>
+                  <c:v>8</c:v>
                 </c:pt>
                 <c:pt idx="4">
-                  <c:v>2</c:v>
+                  <c:v>1</c:v>
                 </c:pt>
               </c:numCache>
             </c:numRef>
@@ -2712,13 +2712,13 @@
                 <c:formatCode>General</c:formatCode>
                 <c:ptCount val="5"/>
                 <c:pt idx="0">
-                  <c:v>132</c:v>
+                  <c:v>138</c:v>
                 </c:pt>
                 <c:pt idx="1">
-                  <c:v>56</c:v>
+                  <c:v>68</c:v>
                 </c:pt>
                 <c:pt idx="2">
-                  <c:v>8</c:v>
+                  <c:v>15</c:v>
                 </c:pt>
                 <c:pt idx="3">
                   <c:v>13</c:v>
@@ -7431,7 +7431,7 @@
                 <a:ea typeface="Calibri" pitchFamily="34" charset="-122"/>
                 <a:cs typeface="Calibri" pitchFamily="34" charset="-120"/>
               </a:rPr>
-              <a:t>Recuperar los 73 DT atrasados</a:t>
+              <a:t>Recuperar los 57 DT atrasados</a:t>
             </a:r>
             <a:endParaRPr lang="en-US" sz="1350" dirty="0"/>
           </a:p>
@@ -7473,7 +7473,7 @@
                 <a:ea typeface="Calibri" pitchFamily="34" charset="-122"/>
                 <a:cs typeface="Calibri" pitchFamily="34" charset="-120"/>
               </a:rPr>
-              <a:t>47 son P2 y 23 son P1. La mediana de atraso es de 45 días y 8 superan los 90 días.</a:t>
+              <a:t>38 son P2 y 16 son P1. La mediana de atraso es de 53 días y 8 superan los 90 días.</a:t>
             </a:r>
             <a:endParaRPr lang="en-US" sz="1100" dirty="0"/>
           </a:p>
@@ -7615,7 +7615,7 @@
                 <a:ea typeface="Calibri" pitchFamily="34" charset="-122"/>
                 <a:cs typeface="Calibri" pitchFamily="34" charset="-120"/>
               </a:rPr>
-              <a:t>CERRO VERDE/PS2: 0/3 (0%). A nivel proyecto la caminata 2 va 95% con 11 ya agendadas.</a:t>
+              <a:t>CERRO VERDE/PS2: 1/3 (33,3%). A nivel proyecto la caminata 2 va 98,2% con 4 ya agendadas.</a:t>
             </a:r>
             <a:endParaRPr lang="en-US" sz="1100" dirty="0"/>
           </a:p>
@@ -7899,7 +7899,7 @@
                 <a:ea typeface="Calibri" pitchFamily="34" charset="-122"/>
                 <a:cs typeface="Calibri" pitchFamily="34" charset="-120"/>
               </a:rPr>
-              <a:t>Concentra 109 de los 285 DT abiertos (38,2%), con 3 atrasados. Además hay 3 carpetas bajo 80% de avance que conviene cerrar en paralelo.</a:t>
+              <a:t>Concentra 108 de los 294 DT abiertos (36,7%), con 2 atrasados. Además hay 3 carpetas bajo 80% de avance que conviene cerrar en paralelo.</a:t>
             </a:r>
             <a:endParaRPr lang="en-US" sz="1100" dirty="0"/>
           </a:p>
@@ -7938,7 +7938,7 @@
                 <a:ea typeface="Calibri" pitchFamily="34" charset="-122"/>
                 <a:cs typeface="Calibri" pitchFamily="34" charset="-120"/>
               </a:rPr>
-              <a:t>Fuente: STATUS_SUBSISTEMAS_TALABRE + Detalle_de_Terminaciones · 218 subsistemas · 2.115 DT · Atrasos al 21-09-2026</a:t>
+              <a:t>Fuente: STATUS_SUBSISTEMAS_TALABRE + Detalle_de_Terminaciones · 218 subsistemas · 2.141 DT · Atrasos al 28-09-2026</a:t>
             </a:r>
             <a:endParaRPr lang="en-US" sz="850" dirty="0"/>
           </a:p>
@@ -20307,7 +20307,7 @@
                 <a:ea typeface="Calibri" pitchFamily="34" charset="-122"/>
                 <a:cs typeface="Calibri" pitchFamily="34" charset="-120"/>
               </a:rPr>
-              <a:t>Contrato 4600029355 · 218 subsistemas en 9 áreas · 2.115 detalles de terminación levantados.</a:t>
+              <a:t>Contrato 4600029355 · 218 subsistemas en 9 áreas · 2.141 detalles de terminación levantados.</a:t>
             </a:r>
             <a:endParaRPr lang="en-US" sz="1350" dirty="0"/>
           </a:p>
@@ -20580,7 +20580,7 @@
                 <a:ea typeface="Cambria" pitchFamily="34" charset="-122"/>
                 <a:cs typeface="Cambria" pitchFamily="34" charset="-120"/>
               </a:rPr>
-              <a:t>96,1%</a:t>
+              <a:t>95,7%</a:t>
             </a:r>
             <a:endParaRPr lang="en-US" sz="3400" dirty="0"/>
           </a:p>
@@ -20658,7 +20658,7 @@
                 <a:ea typeface="Calibri" pitchFamily="34" charset="-122"/>
                 <a:cs typeface="Calibri" pitchFamily="34" charset="-120"/>
               </a:rPr>
-              <a:t>Atrasos calculados al 21-09-2026</a:t>
+              <a:t>Atrasos calculados al 28-09-2026</a:t>
             </a:r>
             <a:endParaRPr lang="en-US" sz="1100" dirty="0"/>
           </a:p>
@@ -20697,7 +20697,7 @@
                 <a:ea typeface="Calibri" pitchFamily="34" charset="-122"/>
                 <a:cs typeface="Calibri" pitchFamily="34" charset="-120"/>
               </a:rPr>
-              <a:t>Fuente: STATUS_SUBSISTEMAS_TALABRE + Detalle_de_Terminaciones · 218 subsistemas · 2.115 DT · Atrasos al 21-09-2026</a:t>
+              <a:t>Fuente: STATUS_SUBSISTEMAS_TALABRE + Detalle_de_Terminaciones · 218 subsistemas · 2.141 DT · Atrasos al 28-09-2026</a:t>
             </a:r>
             <a:endParaRPr lang="en-US" sz="850" dirty="0"/>
           </a:p>
@@ -21002,7 +21002,7 @@
                 <a:ea typeface="Calibri" pitchFamily="34" charset="-122"/>
                 <a:cs typeface="Calibri" pitchFamily="34" charset="-120"/>
               </a:rPr>
-              <a:t>216/216 exigibles</a:t>
+              <a:t>218/218 exigibles</a:t>
             </a:r>
             <a:endParaRPr lang="en-US" sz="1300" dirty="0"/>
           </a:p>
@@ -21083,7 +21083,7 @@
                 <a:ea typeface="Calibri" pitchFamily="34" charset="-122"/>
                 <a:cs typeface="Calibri" pitchFamily="34" charset="-120"/>
               </a:rPr>
-              <a:t>99,1% del universo · 2 programadas en plazo · 0 sin programar</a:t>
+              <a:t>100% del universo · 0 programadas en plazo · 0 sin programar</a:t>
             </a:r>
             <a:endParaRPr lang="en-US" sz="950" dirty="0"/>
           </a:p>
@@ -21215,7 +21215,7 @@
                 <a:ea typeface="Calibri" pitchFamily="34" charset="-122"/>
                 <a:cs typeface="Calibri" pitchFamily="34" charset="-120"/>
               </a:rPr>
-              <a:t>207/207 exigibles</a:t>
+              <a:t>214/214 exigibles</a:t>
             </a:r>
             <a:endParaRPr lang="en-US" sz="1300" dirty="0"/>
           </a:p>
@@ -21296,7 +21296,7 @@
                 <a:ea typeface="Calibri" pitchFamily="34" charset="-122"/>
                 <a:cs typeface="Calibri" pitchFamily="34" charset="-120"/>
               </a:rPr>
-              <a:t>95% del universo · 11 programadas en plazo · 0 sin programar</a:t>
+              <a:t>98,2% del universo · 4 programadas en plazo · 0 sin programar</a:t>
             </a:r>
             <a:endParaRPr lang="en-US" sz="950" dirty="0"/>
           </a:p>
@@ -21602,7 +21602,7 @@
                 <a:ea typeface="Cambria" pitchFamily="34" charset="-122"/>
                 <a:cs typeface="Cambria" pitchFamily="34" charset="-120"/>
               </a:rPr>
-              <a:t>94,1%</a:t>
+              <a:t>92,9%</a:t>
             </a:r>
             <a:endParaRPr lang="en-US" sz="3800" dirty="0"/>
           </a:p>
@@ -21641,7 +21641,7 @@
                 <a:ea typeface="Calibri" pitchFamily="34" charset="-122"/>
                 <a:cs typeface="Calibri" pitchFamily="34" charset="-120"/>
               </a:rPr>
-              <a:t>385/409</a:t>
+              <a:t>393/423</a:t>
             </a:r>
             <a:endParaRPr lang="en-US" sz="1300" dirty="0"/>
           </a:p>
@@ -21722,7 +21722,7 @@
                 <a:ea typeface="Calibri" pitchFamily="34" charset="-122"/>
                 <a:cs typeface="Calibri" pitchFamily="34" charset="-120"/>
               </a:rPr>
-              <a:t>24 abiertos · 23 atrasados</a:t>
+              <a:t>30 abiertos · 16 atrasados</a:t>
             </a:r>
             <a:endParaRPr lang="en-US" sz="950" dirty="0"/>
           </a:p>
@@ -21862,7 +21862,7 @@
                 <a:ea typeface="Calibri" pitchFamily="34" charset="-122"/>
                 <a:cs typeface="Calibri" pitchFamily="34" charset="-120"/>
               </a:rPr>
-              <a:t>94,1% de cierre en P1 (24 abiertos), pero 261 DT abiertos entre P2, P3 y P4 sobre un total de 285.</a:t>
+              <a:t>92,9% de cierre en P1 (30 abiertos), pero 264 DT abiertos entre P2, P3 y P4 sobre un total de 294.</a:t>
             </a:r>
             <a:endParaRPr lang="en-US" sz="1150" dirty="0"/>
           </a:p>
@@ -21941,7 +21941,7 @@
                 <a:ea typeface="Calibri" pitchFamily="34" charset="-122"/>
                 <a:cs typeface="Calibri" pitchFamily="34" charset="-120"/>
               </a:rPr>
-              <a:t>73 DT con la fecha de compromiso vencida; mediana de 45 días y el más antiguo lleva 186. Los 211 abiertos sin fecha de compromiso no se cuentan como atrasados.</a:t>
+              <a:t>57 DT con la fecha de compromiso vencida; mediana de 53 días y el más antiguo lleva 193. Los 211 abiertos sin fecha de compromiso no se cuentan como atrasados.</a:t>
             </a:r>
             <a:endParaRPr lang="en-US" sz="1150" dirty="0"/>
           </a:p>
@@ -22020,7 +22020,7 @@
                 <a:ea typeface="Calibri" pitchFamily="34" charset="-122"/>
                 <a:cs typeface="Calibri" pitchFamily="34" charset="-120"/>
               </a:rPr>
-              <a:t>Caminata 1: 216/216 exigibles. Caminata 2: 207/207, con 11 agendadas en plazo y 0 sin programar.</a:t>
+              <a:t>Caminata 1: 218/218 exigibles. Caminata 2: 214/214, con 4 agendadas en plazo y 0 sin programar.</a:t>
             </a:r>
             <a:endParaRPr lang="en-US" sz="1150" dirty="0"/>
           </a:p>
@@ -22138,7 +22138,7 @@
                 <a:ea typeface="Calibri" pitchFamily="34" charset="-122"/>
                 <a:cs typeface="Calibri" pitchFamily="34" charset="-120"/>
               </a:rPr>
-              <a:t>Fuente: STATUS_SUBSISTEMAS_TALABRE + Detalle_de_Terminaciones · 218 subsistemas · 2.115 DT · Atrasos al 21-09-2026</a:t>
+              <a:t>Fuente: STATUS_SUBSISTEMAS_TALABRE + Detalle_de_Terminaciones · 218 subsistemas · 2.141 DT · Atrasos al 28-09-2026</a:t>
             </a:r>
             <a:endParaRPr lang="en-US" sz="850" dirty="0"/>
           </a:p>
@@ -22389,7 +22389,7 @@
                 <a:ea typeface="Calibri" pitchFamily="34" charset="-122"/>
                 <a:cs typeface="Calibri" pitchFamily="34" charset="-120"/>
               </a:rPr>
-              <a:t>Caminata 2: 100% de lo exigible (207/207) — se descuentan 11 agendadas a fecha futura, que no son incumplimiento al corte. Talabre mide la carpeta como % de avance (PEC), no como estado de aprobación.</a:t>
+              <a:t>Caminata 2: 100% de lo exigible (214/214) — se descuentan 4 agendadas a fecha futura, que no son incumplimiento al corte. Talabre mide la carpeta como % de avance (PEC), no como estado de aprobación.</a:t>
             </a:r>
             <a:endParaRPr lang="en-US" sz="1350" dirty="0"/>
           </a:p>
@@ -22460,7 +22460,7 @@
                 <a:ea typeface="Calibri" pitchFamily="34" charset="-122"/>
                 <a:cs typeface="Calibri" pitchFamily="34" charset="-120"/>
               </a:rPr>
-              <a:t>Fuente: STATUS_SUBSISTEMAS_TALABRE + Detalle_de_Terminaciones · 218 subsistemas · 2.115 DT · Atrasos al 21-09-2026</a:t>
+              <a:t>Fuente: STATUS_SUBSISTEMAS_TALABRE + Detalle_de_Terminaciones · 218 subsistemas · 2.141 DT · Atrasos al 28-09-2026</a:t>
             </a:r>
             <a:endParaRPr lang="en-US" sz="850" dirty="0"/>
           </a:p>
@@ -22711,7 +22711,7 @@
                 <a:ea typeface="Calibri" pitchFamily="34" charset="-122"/>
                 <a:cs typeface="Calibri" pitchFamily="34" charset="-120"/>
               </a:rPr>
-              <a:t>2.115 DT levantados; 86,5% cerrados. Atrasado = DT abierto cuya fecha de compromiso de cierre ya venció al 21-09-2026.</a:t>
+              <a:t>2.141 DT levantados; 86,3% cerrados. Atrasado = DT abierto cuya fecha de compromiso de cierre ya venció al 28-09-2026.</a:t>
             </a:r>
             <a:endParaRPr lang="en-US" sz="1350" dirty="0"/>
           </a:p>
@@ -22866,7 +22866,7 @@
                 <a:ea typeface="Calibri" pitchFamily="34" charset="-122"/>
                 <a:cs typeface="Calibri" pitchFamily="34" charset="-120"/>
               </a:rPr>
-              <a:t>385/409</a:t>
+              <a:t>393/423</a:t>
             </a:r>
             <a:endParaRPr lang="en-US" sz="1050" dirty="0"/>
           </a:p>
@@ -22905,7 +22905,7 @@
                 <a:ea typeface="Calibri" pitchFamily="34" charset="-122"/>
                 <a:cs typeface="Calibri" pitchFamily="34" charset="-120"/>
               </a:rPr>
-              <a:t>94,1%</a:t>
+              <a:t>92,9%</a:t>
             </a:r>
             <a:endParaRPr lang="en-US" sz="1100" dirty="0"/>
           </a:p>
@@ -22940,7 +22940,7 @@
         <p:spPr>
           <a:xfrm>
             <a:off x="7936992" y="2688336"/>
-            <a:ext cx="3355757" cy="118872"/>
+            <a:ext cx="3312963" cy="118872"/>
           </a:xfrm>
           <a:prstGeom prst="rect">
             <a:avLst/>
@@ -23023,7 +23023,7 @@
                 <a:ea typeface="Calibri" pitchFamily="34" charset="-122"/>
                 <a:cs typeface="Calibri" pitchFamily="34" charset="-120"/>
               </a:rPr>
-              <a:t>1.361/1.408</a:t>
+              <a:t>1.370/1.420</a:t>
             </a:r>
             <a:endParaRPr lang="en-US" sz="1050" dirty="0"/>
           </a:p>
@@ -23062,7 +23062,7 @@
                 <a:ea typeface="Calibri" pitchFamily="34" charset="-122"/>
                 <a:cs typeface="Calibri" pitchFamily="34" charset="-120"/>
               </a:rPr>
-              <a:t>96,7%</a:t>
+              <a:t>96,5%</a:t>
             </a:r>
             <a:endParaRPr lang="en-US" sz="1100" dirty="0"/>
           </a:p>
@@ -23097,7 +23097,7 @@
         <p:spPr>
           <a:xfrm>
             <a:off x="7936992" y="3200400"/>
-            <a:ext cx="3448477" cy="118872"/>
+            <a:ext cx="3441344" cy="118872"/>
           </a:xfrm>
           <a:prstGeom prst="rect">
             <a:avLst/>
@@ -23636,7 +23636,7 @@
                 <a:ea typeface="Calibri" pitchFamily="34" charset="-122"/>
                 <a:cs typeface="Calibri" pitchFamily="34" charset="-120"/>
               </a:rPr>
-              <a:t>Mediana de 45 días vencidos; el más antiguo lleva 186. 25 entre 1-30 días, 40 entre 31-90 días, 7 entre 91-180 días, 1 entre &gt;180 días.</a:t>
+              <a:t>Mediana de 53 días vencidos; el más antiguo lleva 193. 18 entre 1-30 días, 31 entre 31-90 días, 7 entre 91-180 días, 1 entre &gt;180 días.</a:t>
             </a:r>
             <a:endParaRPr lang="en-US" sz="1150" dirty="0"/>
           </a:p>
@@ -23675,7 +23675,7 @@
                 <a:ea typeface="Calibri" pitchFamily="34" charset="-122"/>
                 <a:cs typeface="Calibri" pitchFamily="34" charset="-120"/>
               </a:rPr>
-              <a:t>Fuente: STATUS_SUBSISTEMAS_TALABRE + Detalle_de_Terminaciones · 218 subsistemas · 2.115 DT · Atrasos al 21-09-2026</a:t>
+              <a:t>Fuente: STATUS_SUBSISTEMAS_TALABRE + Detalle_de_Terminaciones · 218 subsistemas · 2.141 DT · Atrasos al 28-09-2026</a:t>
             </a:r>
             <a:endParaRPr lang="en-US" sz="850" dirty="0"/>
           </a:p>

</xml_diff>

<commit_message>
Arqueros: archivo corregido del corte 28-09-2026
Caminatas 100% realizadas 105 → 107. El resto del corte queda idéntico: P1
1.437/2.056 al 69,9%, carpetas TOP 39 entregadas con 0 aprobadas, detalles 3.106.

133 comprobaciones OK · 0 fallan · 2 avisos.

Co-Authored-By: Claude Opus 5 <noreply@anthropic.com>
Claude-Session: https://claude.ai/code/session_011SHyPcub1TtjA2kTAsaPFu
</commit_message>
<xml_diff>
--- a/panel_control_TOP_P1/Panel_Control_TOP_P1.pptx
+++ b/panel_control_TOP_P1/Panel_Control_TOP_P1.pptx
@@ -3003,7 +3003,7 @@
                 <c:formatCode>General</c:formatCode>
                 <c:ptCount val="4"/>
                 <c:pt idx="0">
-                  <c:v>33</c:v>
+                  <c:v>35</c:v>
                 </c:pt>
                 <c:pt idx="1">
                   <c:v>51</c:v>
@@ -3093,7 +3093,7 @@
                 <c:formatCode>General</c:formatCode>
                 <c:ptCount val="4"/>
                 <c:pt idx="0">
-                  <c:v>2</c:v>
+                  <c:v/>
                 </c:pt>
                 <c:pt idx="1">
                   <c:v>24</c:v>
@@ -8428,7 +8428,7 @@
                 <a:ea typeface="Cambria" pitchFamily="34" charset="-122"/>
                 <a:cs typeface="Cambria" pitchFamily="34" charset="-120"/>
               </a:rPr>
-              <a:t>77,2%</a:t>
+              <a:t>78,7%</a:t>
             </a:r>
             <a:endParaRPr lang="en-US" sz="3400" dirty="0"/>
           </a:p>
@@ -9177,7 +9177,7 @@
                 <a:ea typeface="Cambria" pitchFamily="34" charset="-122"/>
                 <a:cs typeface="Cambria" pitchFamily="34" charset="-120"/>
               </a:rPr>
-              <a:t>77,2%</a:t>
+              <a:t>78,7%</a:t>
             </a:r>
             <a:endParaRPr lang="en-US" sz="4000" dirty="0"/>
           </a:p>
@@ -9216,7 +9216,7 @@
                 <a:ea typeface="Calibri" pitchFamily="34" charset="-122"/>
                 <a:cs typeface="Calibri" pitchFamily="34" charset="-120"/>
               </a:rPr>
-              <a:t>105/136</a:t>
+              <a:t>107/136</a:t>
             </a:r>
             <a:endParaRPr lang="en-US" sz="1400" dirty="0"/>
           </a:p>
@@ -9294,7 +9294,7 @@
                 <a:ea typeface="Calibri" pitchFamily="34" charset="-122"/>
                 <a:cs typeface="Calibri" pitchFamily="34" charset="-120"/>
               </a:rPr>
-              <a:t>29 próximas · 2 por programar</a:t>
+              <a:t>27 próximas · 2 por programar</a:t>
             </a:r>
             <a:endParaRPr lang="en-US" sz="950" dirty="0"/>
           </a:p>
@@ -9333,7 +9333,7 @@
                 <a:ea typeface="Calibri" pitchFamily="34" charset="-122"/>
                 <a:cs typeface="Calibri" pitchFamily="34" charset="-120"/>
               </a:rPr>
-              <a:t>▲ +5 vs. corte anterior</a:t>
+              <a:t>▲ +7 vs. corte anterior</a:t>
             </a:r>
             <a:endParaRPr lang="en-US" sz="900" dirty="0"/>
           </a:p>
@@ -9971,7 +9971,7 @@
                 <a:ea typeface="Calibri" pitchFamily="34" charset="-122"/>
                 <a:cs typeface="Calibri" pitchFamily="34" charset="-120"/>
               </a:rPr>
-              <a:t>Los subsistemas «por programar» bajaron de 3 a 2, mientras las realizadas al 100% se mantienen en 105 (77,2%).</a:t>
+              <a:t>Los subsistemas «por programar» bajaron de 3 a 2, mientras las realizadas al 100% se mantienen en 107 (78,7%).</a:t>
             </a:r>
             <a:endParaRPr lang="en-US" sz="1250" dirty="0"/>
           </a:p>
@@ -10832,7 +10832,7 @@
                 <a:ea typeface="Calibri" pitchFamily="34" charset="-122"/>
                 <a:cs typeface="Calibri" pitchFamily="34" charset="-120"/>
               </a:rPr>
-              <a:t>33/35 · 94,3%</a:t>
+              <a:t>35/35 · 100%</a:t>
             </a:r>
             <a:endParaRPr lang="en-US" sz="1300" dirty="0"/>
           </a:p>
@@ -12473,7 +12473,7 @@
                 <a:ea typeface="Calibri" pitchFamily="34" charset="-122"/>
                 <a:cs typeface="Calibri" pitchFamily="34" charset="-120"/>
               </a:rPr>
-              <a:t>Las caminatas al 80% están cerradas en todas las áreas (136/136). El hito 100% avanza a 77,2%, y el área 3000 concentra 26 de los 31 subsistemas pendientes.</a:t>
+              <a:t>Las caminatas al 80% están cerradas en todas las áreas (136/136). El hito 100% avanza a 78,7%, y el área 3000 concentra 26 de los 29 subsistemas pendientes.</a:t>
             </a:r>
             <a:endParaRPr lang="en-US" sz="1350" dirty="0"/>
           </a:p>
@@ -12729,7 +12729,7 @@
                 <a:ea typeface="Cambria" pitchFamily="34" charset="-122"/>
                 <a:cs typeface="Cambria" pitchFamily="34" charset="-120"/>
               </a:rPr>
-              <a:t>77,2%</a:t>
+              <a:t>78,7%</a:t>
             </a:r>
             <a:endParaRPr lang="en-US" sz="4000" dirty="0"/>
           </a:p>
@@ -12768,7 +12768,7 @@
                 <a:ea typeface="Calibri" pitchFamily="34" charset="-122"/>
                 <a:cs typeface="Calibri" pitchFamily="34" charset="-120"/>
               </a:rPr>
-              <a:t>105 realizadas · 31 pendientes</a:t>
+              <a:t>107 realizadas · 29 pendientes</a:t>
             </a:r>
             <a:endParaRPr lang="en-US" sz="1200" dirty="0"/>
           </a:p>
@@ -12827,7 +12827,7 @@
                 <a:ea typeface="Calibri" pitchFamily="34" charset="-122"/>
                 <a:cs typeface="Calibri" pitchFamily="34" charset="-120"/>
               </a:rPr>
-              <a:t>29 próximas a realizar y 2 por programar. Las «por programar» bajaron 1 en el período.</a:t>
+              <a:t>27 próximas a realizar y 2 por programar. Las «por programar» bajaron 1 en el período.</a:t>
             </a:r>
             <a:endParaRPr lang="en-US" sz="1150" dirty="0"/>
           </a:p>
@@ -15571,7 +15571,7 @@
                 <a:ea typeface="Calibri" pitchFamily="34" charset="-122"/>
                 <a:cs typeface="Calibri" pitchFamily="34" charset="-120"/>
               </a:rPr>
-              <a:t>31 subsistemas pendientes: 29 próximos a realizar y 2 por programar. La programación ya está hecha; falta ejecutarla para habilitar la entrega de carpetas.</a:t>
+              <a:t>29 subsistemas pendientes: 27 próximos a realizar y 2 por programar. La programación ya está hecha; falta ejecutarla para habilitar la entrega de carpetas.</a:t>
             </a:r>
             <a:endParaRPr lang="en-US" sz="1150" dirty="0"/>
           </a:p>

</xml_diff>

<commit_message>
Desaladora al 05-10-2026 — la suite queda completa en el corte
Reporte gerencial 29-09 con punch consolidado 04-10, según la cadencia del
proyecto. Punch 2.481 ítems, 72,2% cerrado: se cerraron 71 y entraron 62.

El atraso salta de 240 a 366 con los abiertos bajando de 698 a 689: no son ítems
nuevos, son los mismos que cruzaron su fecha requerida en la semana. P1 139 → 206
y P2 88 → 144.

Carpetas 63/95 entregadas y 46 aprobadas, con tarjeta verde en 46.

Corte completo: Protocolos 28-09 · Cierre QAQC con Desaladora 29-09/04-10,
Arqueros 01-10 y Talabre 05-10 · No Conformidades 05-10.

133 comprobaciones OK · 0 fallan · 2 avisos.

Co-Authored-By: Claude Opus 5 <noreply@anthropic.com>
Claude-Session: https://claude.ai/code/session_011SHyPcub1TtjA2kTAsaPFu
</commit_message>
<xml_diff>
--- a/panel_control_TOP_P1/Panel_Control_TOP_P1.pptx
+++ b/panel_control_TOP_P1/Panel_Control_TOP_P1.pptx
@@ -233,7 +233,7 @@
                 <c:formatCode>General</c:formatCode>
                 <c:ptCount val="2"/>
                 <c:pt idx="0">
-                  <c:v>63</c:v>
+                  <c:v>66</c:v>
                 </c:pt>
                 <c:pt idx="1">
                   <c:v>12</c:v>
@@ -311,7 +311,7 @@
                 <c:formatCode>General</c:formatCode>
                 <c:ptCount val="2"/>
                 <c:pt idx="0">
-                  <c:v>16</c:v>
+                  <c:v>13</c:v>
                 </c:pt>
                 <c:pt idx="1">
                   <c:v>3</c:v>
@@ -850,22 +850,22 @@
                 <c:formatCode>General</c:formatCode>
                 <c:ptCount val="6"/>
                 <c:pt idx="0">
-                  <c:v>24</c:v>
+                  <c:v>84</c:v>
                 </c:pt>
                 <c:pt idx="1">
-                  <c:v>88</c:v>
+                  <c:v>83</c:v>
                 </c:pt>
                 <c:pt idx="2">
                   <c:v>11</c:v>
                 </c:pt>
                 <c:pt idx="3">
-                  <c:v>9</c:v>
+                  <c:v>14</c:v>
                 </c:pt>
                 <c:pt idx="4">
-                  <c:v/>
+                  <c:v>5</c:v>
                 </c:pt>
                 <c:pt idx="5">
-                  <c:v>7</c:v>
+                  <c:v>9</c:v>
                 </c:pt>
               </c:numCache>
             </c:numRef>
@@ -952,22 +952,22 @@
                 <c:formatCode>General</c:formatCode>
                 <c:ptCount val="6"/>
                 <c:pt idx="0">
-                  <c:v>195</c:v>
+                  <c:v>148</c:v>
                 </c:pt>
                 <c:pt idx="1">
-                  <c:v>45</c:v>
+                  <c:v>31</c:v>
                 </c:pt>
                 <c:pt idx="2">
-                  <c:v>50</c:v>
+                  <c:v>48</c:v>
                 </c:pt>
                 <c:pt idx="3">
-                  <c:v>9</c:v>
+                  <c:v>1</c:v>
                 </c:pt>
                 <c:pt idx="4">
-                  <c:v>15</c:v>
+                  <c:v>8</c:v>
                 </c:pt>
                 <c:pt idx="5">
-                  <c:v>3</c:v>
+                  <c:v>1</c:v>
                 </c:pt>
               </c:numCache>
             </c:numRef>
@@ -1340,13 +1340,13 @@
               <c:numCache>
                 <c:ptCount val="3"/>
                 <c:pt idx="0">
-                  <c:v>1080</c:v>
+                  <c:v>1129</c:v>
                 </c:pt>
                 <c:pt idx="1">
-                  <c:v>139</c:v>
+                  <c:v>206</c:v>
                 </c:pt>
                 <c:pt idx="2">
-                  <c:v>317</c:v>
+                  <c:v>237</c:v>
                 </c:pt>
               </c:numCache>
             </c:numRef>
@@ -6907,7 +6907,7 @@
                 <a:ea typeface="Cambria" pitchFamily="34" charset="-122"/>
                 <a:cs typeface="Cambria" pitchFamily="34" charset="-120"/>
               </a:rPr>
-              <a:t>79,7%</a:t>
+              <a:t>83,5%</a:t>
             </a:r>
             <a:endParaRPr lang="en-US" sz="3400" dirty="0"/>
           </a:p>
@@ -7063,7 +7063,7 @@
                 <a:ea typeface="Cambria" pitchFamily="34" charset="-122"/>
                 <a:cs typeface="Cambria" pitchFamily="34" charset="-120"/>
               </a:rPr>
-              <a:t>61,1%</a:t>
+              <a:t>66,3%</a:t>
             </a:r>
             <a:endParaRPr lang="en-US" sz="3400" dirty="0"/>
           </a:p>
@@ -7141,7 +7141,7 @@
                 <a:ea typeface="Cambria" pitchFamily="34" charset="-122"/>
                 <a:cs typeface="Cambria" pitchFamily="34" charset="-120"/>
               </a:rPr>
-              <a:t>70,3%</a:t>
+              <a:t>71,8%</a:t>
             </a:r>
             <a:endParaRPr lang="en-US" sz="3400" dirty="0"/>
           </a:p>
@@ -7219,7 +7219,7 @@
                 <a:ea typeface="Calibri" pitchFamily="34" charset="-122"/>
                 <a:cs typeface="Calibri" pitchFamily="34" charset="-120"/>
               </a:rPr>
-              <a:t>Corte: 22-09-2026</a:t>
+              <a:t>Corte: 29-09-2026</a:t>
             </a:r>
             <a:endParaRPr lang="en-US" sz="1100" dirty="0"/>
           </a:p>
@@ -7258,7 +7258,7 @@
                 <a:ea typeface="Calibri" pitchFamily="34" charset="-122"/>
                 <a:cs typeface="Calibri" pitchFamily="34" charset="-120"/>
               </a:rPr>
-              <a:t>Fuente: REPORTE_GERENCIAL + Listado de Puntos Punch Consolidado · Corte 22-09-2026 · Atrasos al 28-09-2026</a:t>
+              <a:t>Fuente: REPORTE_GERENCIAL + Listado de Puntos Punch Consolidado · Corte 29-09-2026 · Atrasos al 05-10-2026</a:t>
             </a:r>
             <a:endParaRPr lang="en-US" sz="850" dirty="0"/>
           </a:p>
@@ -16074,7 +16074,7 @@
                 <a:ea typeface="Cambria" pitchFamily="34" charset="-122"/>
                 <a:cs typeface="Cambria" pitchFamily="34" charset="-120"/>
               </a:rPr>
-              <a:t>79,7%</a:t>
+              <a:t>83,5%</a:t>
             </a:r>
             <a:endParaRPr lang="en-US" sz="3800" dirty="0"/>
           </a:p>
@@ -16113,7 +16113,7 @@
                 <a:ea typeface="Calibri" pitchFamily="34" charset="-122"/>
                 <a:cs typeface="Calibri" pitchFamily="34" charset="-120"/>
               </a:rPr>
-              <a:t>63/79</a:t>
+              <a:t>66/79</a:t>
             </a:r>
             <a:endParaRPr lang="en-US" sz="1400" dirty="0"/>
           </a:p>
@@ -16194,7 +16194,7 @@
                 <a:ea typeface="Calibri" pitchFamily="34" charset="-122"/>
                 <a:cs typeface="Calibri" pitchFamily="34" charset="-120"/>
               </a:rPr>
-              <a:t>16 subsistemas por caminar</a:t>
+              <a:t>13 subsistemas por caminar</a:t>
             </a:r>
             <a:endParaRPr lang="en-US" sz="950" dirty="0"/>
           </a:p>
@@ -16500,7 +16500,7 @@
                 <a:ea typeface="Cambria" pitchFamily="34" charset="-122"/>
                 <a:cs typeface="Cambria" pitchFamily="34" charset="-120"/>
               </a:rPr>
-              <a:t>61,1%</a:t>
+              <a:t>66,3%</a:t>
             </a:r>
             <a:endParaRPr lang="en-US" sz="3800" dirty="0"/>
           </a:p>
@@ -16539,7 +16539,7 @@
                 <a:ea typeface="Calibri" pitchFamily="34" charset="-122"/>
                 <a:cs typeface="Calibri" pitchFamily="34" charset="-120"/>
               </a:rPr>
-              <a:t>58/95</a:t>
+              <a:t>63/95</a:t>
             </a:r>
             <a:endParaRPr lang="en-US" sz="1400" dirty="0"/>
           </a:p>
@@ -16620,7 +16620,7 @@
                 <a:ea typeface="Calibri" pitchFamily="34" charset="-122"/>
                 <a:cs typeface="Calibri" pitchFamily="34" charset="-120"/>
               </a:rPr>
-              <a:t>44 aprobadas · 8 en revisión · 6 rechazadas</a:t>
+              <a:t>46 aprobadas · 11 en revisión · 6 rechazadas</a:t>
             </a:r>
             <a:endParaRPr lang="en-US" sz="950" dirty="0"/>
           </a:p>
@@ -16713,7 +16713,7 @@
                 <a:ea typeface="Cambria" pitchFamily="34" charset="-122"/>
                 <a:cs typeface="Cambria" pitchFamily="34" charset="-120"/>
               </a:rPr>
-              <a:t>70,3%</a:t>
+              <a:t>71,8%</a:t>
             </a:r>
             <a:endParaRPr lang="en-US" sz="3800" dirty="0"/>
           </a:p>
@@ -16752,7 +16752,7 @@
                 <a:ea typeface="Calibri" pitchFamily="34" charset="-122"/>
                 <a:cs typeface="Calibri" pitchFamily="34" charset="-120"/>
               </a:rPr>
-              <a:t>1.080/1.536</a:t>
+              <a:t>1.129/1.572</a:t>
             </a:r>
             <a:endParaRPr lang="en-US" sz="1400" dirty="0"/>
           </a:p>
@@ -16833,7 +16833,7 @@
                 <a:ea typeface="Calibri" pitchFamily="34" charset="-122"/>
                 <a:cs typeface="Calibri" pitchFamily="34" charset="-120"/>
               </a:rPr>
-              <a:t>456 abiertos · 139 atrasados</a:t>
+              <a:t>443 abiertos · 206 atrasados</a:t>
             </a:r>
             <a:endParaRPr lang="en-US" sz="950" dirty="0"/>
           </a:p>
@@ -16973,7 +16973,7 @@
                 <a:ea typeface="Calibri" pitchFamily="34" charset="-122"/>
                 <a:cs typeface="Calibri" pitchFamily="34" charset="-120"/>
               </a:rPr>
-              <a:t>1.721 de 2.419 ítems cerrados (71,1%); de los 698 abiertos, 240 ya pasaron su fecha requerida de cierre (34,4%).</a:t>
+              <a:t>1.792 de 2.481 ítems cerrados (72,2%); de los 689 abiertos, 366 ya pasaron su fecha requerida de cierre (53,1%).</a:t>
             </a:r>
             <a:endParaRPr lang="en-US" sz="1150" dirty="0"/>
           </a:p>
@@ -17052,7 +17052,7 @@
                 <a:ea typeface="Calibri" pitchFamily="34" charset="-122"/>
                 <a:cs typeface="Calibri" pitchFamily="34" charset="-120"/>
               </a:rPr>
-              <a:t>Operables 63/79 por Caminata 2 (79,7%); Facility 12/15 por Caminata 1 (80%).</a:t>
+              <a:t>Operables 66/79 por Caminata 2 (83,5%); Facility 12/15 por Caminata 1 (80%).</a:t>
             </a:r>
             <a:endParaRPr lang="en-US" sz="1150" dirty="0"/>
           </a:p>
@@ -17114,7 +17114,7 @@
                 <a:ea typeface="Calibri" pitchFamily="34" charset="-122"/>
                 <a:cs typeface="Calibri" pitchFamily="34" charset="-120"/>
               </a:rPr>
-              <a:t>Las carpetas están a 61,1% de entrega y el cuello está en el armado interno.  </a:t>
+              <a:t>Las carpetas están a 66,3% de entrega y el cuello está en el armado interno.  </a:t>
             </a:r>
             <a:pPr indent="0" marL="0">
               <a:lnSpc>
@@ -17131,7 +17131,7 @@
                 <a:ea typeface="Calibri" pitchFamily="34" charset="-122"/>
                 <a:cs typeface="Calibri" pitchFamily="34" charset="-120"/>
               </a:rPr>
-              <a:t>58 entregadas de 95: 44 aprobadas, 8 en revisión y 6 rechazadas. Quedan 17 en preparación y 20 sin iniciar.</a:t>
+              <a:t>63 entregadas de 95: 46 aprobadas, 11 en revisión y 6 rechazadas. Quedan 15 en preparación y 17 sin iniciar.</a:t>
             </a:r>
             <a:endParaRPr lang="en-US" sz="1150" dirty="0"/>
           </a:p>
@@ -17210,7 +17210,7 @@
                 <a:ea typeface="Calibri" pitchFamily="34" charset="-122"/>
                 <a:cs typeface="Calibri" pitchFamily="34" charset="-120"/>
               </a:rPr>
-              <a:t>219 de los 456 P1 abiertos (48%), con 24 atrasados.</a:t>
+              <a:t>232 de los 443 P1 abiertos (52,4%), con 84 atrasados.</a:t>
             </a:r>
             <a:endParaRPr lang="en-US" sz="1150" dirty="0"/>
           </a:p>
@@ -17249,7 +17249,7 @@
                 <a:ea typeface="Calibri" pitchFamily="34" charset="-122"/>
                 <a:cs typeface="Calibri" pitchFamily="34" charset="-120"/>
               </a:rPr>
-              <a:t>Fuente: REPORTE_GERENCIAL + Listado de Puntos Punch Consolidado · Corte 22-09-2026 · Atrasos al 28-09-2026</a:t>
+              <a:t>Fuente: REPORTE_GERENCIAL + Listado de Puntos Punch Consolidado · Corte 29-09-2026 · Atrasos al 05-10-2026</a:t>
             </a:r>
             <a:endParaRPr lang="en-US" sz="850" dirty="0"/>
           </a:p>
@@ -17702,7 +17702,7 @@
                 <a:ea typeface="Calibri" pitchFamily="34" charset="-122"/>
                 <a:cs typeface="Calibri" pitchFamily="34" charset="-120"/>
               </a:rPr>
-              <a:t>46,3%</a:t>
+              <a:t>48,4%</a:t>
             </a:r>
             <a:endParaRPr lang="en-US" sz="1100" dirty="0"/>
           </a:p>
@@ -17741,7 +17741,7 @@
                 <a:ea typeface="Cambria" pitchFamily="34" charset="-122"/>
                 <a:cs typeface="Cambria" pitchFamily="34" charset="-120"/>
               </a:rPr>
-              <a:t>44</a:t>
+              <a:t>46</a:t>
             </a:r>
             <a:endParaRPr lang="en-US" sz="2200" dirty="0"/>
           </a:p>
@@ -17861,7 +17861,7 @@
                 <a:ea typeface="Calibri" pitchFamily="34" charset="-122"/>
                 <a:cs typeface="Calibri" pitchFamily="34" charset="-120"/>
               </a:rPr>
-              <a:t>8,4%</a:t>
+              <a:t>11,6%</a:t>
             </a:r>
             <a:endParaRPr lang="en-US" sz="1100" dirty="0"/>
           </a:p>
@@ -17900,7 +17900,7 @@
                 <a:ea typeface="Cambria" pitchFamily="34" charset="-122"/>
                 <a:cs typeface="Cambria" pitchFamily="34" charset="-120"/>
               </a:rPr>
-              <a:t>8</a:t>
+              <a:t>11</a:t>
             </a:r>
             <a:endParaRPr lang="en-US" sz="2200" dirty="0"/>
           </a:p>
@@ -18179,7 +18179,7 @@
                 <a:ea typeface="Calibri" pitchFamily="34" charset="-122"/>
                 <a:cs typeface="Calibri" pitchFamily="34" charset="-120"/>
               </a:rPr>
-              <a:t>17,9%</a:t>
+              <a:t>15,8%</a:t>
             </a:r>
             <a:endParaRPr lang="en-US" sz="1100" dirty="0"/>
           </a:p>
@@ -18218,7 +18218,7 @@
                 <a:ea typeface="Cambria" pitchFamily="34" charset="-122"/>
                 <a:cs typeface="Cambria" pitchFamily="34" charset="-120"/>
               </a:rPr>
-              <a:t>17</a:t>
+              <a:t>15</a:t>
             </a:r>
             <a:endParaRPr lang="en-US" sz="2200" dirty="0"/>
           </a:p>
@@ -18338,7 +18338,7 @@
                 <a:ea typeface="Calibri" pitchFamily="34" charset="-122"/>
                 <a:cs typeface="Calibri" pitchFamily="34" charset="-120"/>
               </a:rPr>
-              <a:t>21,1%</a:t>
+              <a:t>17,9%</a:t>
             </a:r>
             <a:endParaRPr lang="en-US" sz="1100" dirty="0"/>
           </a:p>
@@ -18377,7 +18377,7 @@
                 <a:ea typeface="Cambria" pitchFamily="34" charset="-122"/>
                 <a:cs typeface="Cambria" pitchFamily="34" charset="-120"/>
               </a:rPr>
-              <a:t>20</a:t>
+              <a:t>17</a:t>
             </a:r>
             <a:endParaRPr lang="en-US" sz="2200" dirty="0"/>
           </a:p>
@@ -18419,7 +18419,7 @@
                 <a:ea typeface="Calibri" pitchFamily="34" charset="-122"/>
                 <a:cs typeface="Calibri" pitchFamily="34" charset="-120"/>
               </a:rPr>
-              <a:t>58 carpetas ya están en manos del cliente (61,1%) y 45 subsistemas tienen tarjeta verde. El grueso del pendiente todavía no sale de Besalco.</a:t>
+              <a:t>63 carpetas ya están en manos del cliente (66,3%) y 46 subsistemas tienen tarjeta verde. El grueso del pendiente todavía no sale de Besalco.</a:t>
             </a:r>
             <a:endParaRPr lang="en-US" sz="1000" dirty="0"/>
           </a:p>
@@ -18458,7 +18458,7 @@
                 <a:ea typeface="Calibri" pitchFamily="34" charset="-122"/>
                 <a:cs typeface="Calibri" pitchFamily="34" charset="-120"/>
               </a:rPr>
-              <a:t>Fuente: REPORTE_GERENCIAL + Listado de Puntos Punch Consolidado · Corte 22-09-2026 · Atrasos al 28-09-2026</a:t>
+              <a:t>Fuente: REPORTE_GERENCIAL + Listado de Puntos Punch Consolidado · Corte 29-09-2026 · Atrasos al 05-10-2026</a:t>
             </a:r>
             <a:endParaRPr lang="en-US" sz="850" dirty="0"/>
           </a:p>
@@ -18709,7 +18709,7 @@
                 <a:ea typeface="Calibri" pitchFamily="34" charset="-122"/>
                 <a:cs typeface="Calibri" pitchFamily="34" charset="-120"/>
               </a:rPr>
-              <a:t>1.536 P1 levantados; 70,3% cerrados. Atrasado = ítem abierto cuya fecha requerida de cierre ya venció al 28-09-2026.</a:t>
+              <a:t>1.572 P1 levantados; 71,8% cerrados. Atrasado = ítem abierto cuya fecha requerida de cierre ya venció al 05-10-2026.</a:t>
             </a:r>
             <a:endParaRPr lang="en-US" sz="1350" dirty="0"/>
           </a:p>
@@ -18841,7 +18841,7 @@
                 <a:ea typeface="Cambria" pitchFamily="34" charset="-122"/>
                 <a:cs typeface="Cambria" pitchFamily="34" charset="-120"/>
               </a:rPr>
-              <a:t>70,3%</a:t>
+              <a:t>71,8%</a:t>
             </a:r>
             <a:endParaRPr lang="en-US" sz="1900" dirty="0"/>
           </a:p>
@@ -18956,7 +18956,7 @@
                 <a:ea typeface="Calibri" pitchFamily="34" charset="-122"/>
                 <a:cs typeface="Calibri" pitchFamily="34" charset="-120"/>
               </a:rPr>
-              <a:t>1.080</a:t>
+              <a:t>1.129</a:t>
             </a:r>
             <a:endParaRPr lang="en-US" sz="1100" dirty="0"/>
           </a:p>
@@ -19054,7 +19054,7 @@
                 <a:ea typeface="Calibri" pitchFamily="34" charset="-122"/>
                 <a:cs typeface="Calibri" pitchFamily="34" charset="-120"/>
               </a:rPr>
-              <a:t>139</a:t>
+              <a:t>206</a:t>
             </a:r>
             <a:endParaRPr lang="en-US" sz="1100" dirty="0"/>
           </a:p>
@@ -19152,7 +19152,7 @@
                 <a:ea typeface="Calibri" pitchFamily="34" charset="-122"/>
                 <a:cs typeface="Calibri" pitchFamily="34" charset="-120"/>
               </a:rPr>
-              <a:t>317</a:t>
+              <a:t>237</a:t>
             </a:r>
             <a:endParaRPr lang="en-US" sz="1100" dirty="0"/>
           </a:p>
@@ -19235,7 +19235,7 @@
                 <a:ea typeface="Calibri" pitchFamily="34" charset="-122"/>
                 <a:cs typeface="Calibri" pitchFamily="34" charset="-120"/>
               </a:rPr>
-              <a:t>Mediana de 28 días vencidos; el más antiguo lleva 141. 151 entre 1-30 días, 77 entre 31-90 días, 12 entre 91-180 días.</a:t>
+              <a:t>Mediana de 20 días vencidos; el más antiguo lleva 148. 202 entre 1-30 días, 82 entre 31-90 días, 82 entre 91-180 días.</a:t>
             </a:r>
             <a:endParaRPr lang="en-US" sz="1150" dirty="0"/>
           </a:p>
@@ -19274,7 +19274,7 @@
                 <a:ea typeface="Calibri" pitchFamily="34" charset="-122"/>
                 <a:cs typeface="Calibri" pitchFamily="34" charset="-120"/>
               </a:rPr>
-              <a:t>Fuente: REPORTE_GERENCIAL + Listado de Puntos Punch Consolidado · Corte 22-09-2026 · Atrasos al 28-09-2026</a:t>
+              <a:t>Fuente: REPORTE_GERENCIAL + Listado de Puntos Punch Consolidado · Corte 29-09-2026 · Atrasos al 05-10-2026</a:t>
             </a:r>
             <a:endParaRPr lang="en-US" sz="850" dirty="0"/>
           </a:p>
@@ -19606,7 +19606,7 @@
                 <a:ea typeface="Calibri" pitchFamily="34" charset="-122"/>
                 <a:cs typeface="Calibri" pitchFamily="34" charset="-120"/>
               </a:rPr>
-              <a:t>Recuperar los 240 ítems atrasados</a:t>
+              <a:t>Recuperar los 366 ítems atrasados</a:t>
             </a:r>
             <a:endParaRPr lang="en-US" sz="1400" dirty="0"/>
           </a:p>
@@ -19648,7 +19648,7 @@
                 <a:ea typeface="Calibri" pitchFamily="34" charset="-122"/>
                 <a:cs typeface="Calibri" pitchFamily="34" charset="-120"/>
               </a:rPr>
-              <a:t>34,4% de los 698 abiertos ya venció su fecha requerida. Foco en Piping (24), Eléctrica (88), Mecánica (11).</a:t>
+              <a:t>53,1% de los 689 abiertos ya venció su fecha requerida. Foco en Piping (84), Eléctrica (83), Mecánica (11).</a:t>
             </a:r>
             <a:endParaRPr lang="en-US" sz="1100" dirty="0"/>
           </a:p>
@@ -19748,7 +19748,7 @@
                 <a:ea typeface="Calibri" pitchFamily="34" charset="-122"/>
                 <a:cs typeface="Calibri" pitchFamily="34" charset="-120"/>
               </a:rPr>
-              <a:t>Ejecutar las 16 caminatas de Operables pendientes</a:t>
+              <a:t>Ejecutar las 13 caminatas de Operables pendientes</a:t>
             </a:r>
             <a:endParaRPr lang="en-US" sz="1400" dirty="0"/>
           </a:p>
@@ -19790,7 +19790,7 @@
                 <a:ea typeface="Calibri" pitchFamily="34" charset="-122"/>
                 <a:cs typeface="Calibri" pitchFamily="34" charset="-120"/>
               </a:rPr>
-              <a:t>La Caminata 2 va en 79,7% (63/79). Sin caminata no se levanta el punch final ni se habilita la entrega de la carpeta.</a:t>
+              <a:t>La Caminata 2 va en 83,5% (66/79). Sin caminata no se levanta el punch final ni se habilita la entrega de la carpeta.</a:t>
             </a:r>
             <a:endParaRPr lang="en-US" sz="1100" dirty="0"/>
           </a:p>
@@ -19890,7 +19890,7 @@
                 <a:ea typeface="Calibri" pitchFamily="34" charset="-122"/>
                 <a:cs typeface="Calibri" pitchFamily="34" charset="-120"/>
               </a:rPr>
-              <a:t>Sacar del armado interno las 37 carpetas retenidas</a:t>
+              <a:t>Sacar del armado interno las 32 carpetas retenidas</a:t>
             </a:r>
             <a:endParaRPr lang="en-US" sz="1400" dirty="0"/>
           </a:p>
@@ -19932,7 +19932,7 @@
                 <a:ea typeface="Calibri" pitchFamily="34" charset="-122"/>
                 <a:cs typeface="Calibri" pitchFamily="34" charset="-120"/>
               </a:rPr>
-              <a:t>17 están en preparación y 20 sin iniciar. Solo 58 de 95 (61,1%) llegaron al cliente; 6 volvieron rechazadas y hay que rearmarlas.</a:t>
+              <a:t>15 están en preparación y 17 sin iniciar. Solo 63 de 95 (66,3%) llegaron al cliente; 6 volvieron rechazadas y hay que rearmarlas.</a:t>
             </a:r>
             <a:endParaRPr lang="en-US" sz="1100" dirty="0"/>
           </a:p>
@@ -20074,7 +20074,7 @@
                 <a:ea typeface="Calibri" pitchFamily="34" charset="-122"/>
                 <a:cs typeface="Calibri" pitchFamily="34" charset="-120"/>
               </a:rPr>
-              <a:t>Concentra 403 P1 abiertos y 96 atrasados sobre 74 subsistemas. Es la ruta crítica del proyecto.</a:t>
+              <a:t>Concentra 391 P1 abiertos y 154 atrasados sobre 74 subsistemas. Es la ruta crítica del proyecto.</a:t>
             </a:r>
             <a:endParaRPr lang="en-US" sz="1100" dirty="0"/>
           </a:p>
@@ -20113,7 +20113,7 @@
                 <a:ea typeface="Calibri" pitchFamily="34" charset="-122"/>
                 <a:cs typeface="Calibri" pitchFamily="34" charset="-120"/>
               </a:rPr>
-              <a:t>Fuente: REPORTE_GERENCIAL + Listado de Puntos Punch Consolidado · Corte 22-09-2026 · Atrasos al 28-09-2026</a:t>
+              <a:t>Fuente: REPORTE_GERENCIAL + Listado de Puntos Punch Consolidado · Corte 29-09-2026 · Atrasos al 05-10-2026</a:t>
             </a:r>
             <a:endParaRPr lang="en-US" sz="850" dirty="0"/>
           </a:p>

</xml_diff>

<commit_message>
Talabre: archivo de STATUS regenerado al 05-10-2026
El extracto de pendientes ya cuadra con el registro: 313 = 313, P1 36 = 36 y
P2 63 = 63. Las tres comprobaciones de cruce quedan en OK y se van los avisos de
descuadre que arrastraba el corte.

Caminata 2 sube a 215 realizadas (98,6%) con 3 de agenda vencida en vez de 4, y
el avance PEC de las carpetas pasa de 95,0% a 95,3%. Los DT no se mueven: el
registro es el mismo de este corte.

133 comprobaciones OK · 0 fallan · 3 avisos.

Co-Authored-By: Claude Opus 5 <noreply@anthropic.com>
Claude-Session: https://claude.ai/code/session_011SHyPcub1TtjA2kTAsaPFu
</commit_message>
<xml_diff>
--- a/panel_control_TOP_P1/Panel_Control_TOP_P1.pptx
+++ b/panel_control_TOP_P1/Panel_Control_TOP_P1.pptx
@@ -1527,7 +1527,7 @@
                   <c:v>14</c:v>
                 </c:pt>
                 <c:pt idx="5">
-                  <c:v>21</c:v>
+                  <c:v>22</c:v>
                 </c:pt>
                 <c:pt idx="6">
                   <c:v>110</c:v>
@@ -1767,7 +1767,7 @@
                   <c:v/>
                 </c:pt>
                 <c:pt idx="5">
-                  <c:v>1</c:v>
+                  <c:v/>
                 </c:pt>
                 <c:pt idx="6">
                   <c:v/>
@@ -7735,7 +7735,7 @@
                 <a:ea typeface="Calibri" pitchFamily="34" charset="-122"/>
                 <a:cs typeface="Calibri" pitchFamily="34" charset="-120"/>
               </a:rPr>
-              <a:t>CERRO VERDE/PS2: 1/3 (33,3%). A nivel proyecto la caminata 2 va 98,2% con 0 ya agendadas.</a:t>
+              <a:t>CERRO VERDE/PS2: 1/3 (33,3%). A nivel proyecto la caminata 2 va 98,6% con 0 ya agendadas.</a:t>
             </a:r>
             <a:endParaRPr lang="en-US" sz="1100" dirty="0"/>
           </a:p>
@@ -20583,7 +20583,7 @@
                 <a:ea typeface="Cambria" pitchFamily="34" charset="-122"/>
                 <a:cs typeface="Cambria" pitchFamily="34" charset="-120"/>
               </a:rPr>
-              <a:t>98,2%</a:t>
+              <a:t>98,6%</a:t>
             </a:r>
             <a:endParaRPr lang="en-US" sz="3400" dirty="0"/>
           </a:p>
@@ -20661,7 +20661,7 @@
                 <a:ea typeface="Cambria" pitchFamily="34" charset="-122"/>
                 <a:cs typeface="Cambria" pitchFamily="34" charset="-120"/>
               </a:rPr>
-              <a:t>95%</a:t>
+              <a:t>95,3%</a:t>
             </a:r>
             <a:endParaRPr lang="en-US" sz="3400" dirty="0"/>
           </a:p>
@@ -21335,7 +21335,7 @@
                 <a:ea typeface="Cambria" pitchFamily="34" charset="-122"/>
                 <a:cs typeface="Cambria" pitchFamily="34" charset="-120"/>
               </a:rPr>
-              <a:t>98,2%</a:t>
+              <a:t>98,6%</a:t>
             </a:r>
             <a:endParaRPr lang="en-US" sz="3800" dirty="0"/>
           </a:p>
@@ -21374,7 +21374,7 @@
                 <a:ea typeface="Calibri" pitchFamily="34" charset="-122"/>
                 <a:cs typeface="Calibri" pitchFamily="34" charset="-120"/>
               </a:rPr>
-              <a:t>214/218 exigibles</a:t>
+              <a:t>215/218 exigibles</a:t>
             </a:r>
             <a:endParaRPr lang="en-US" sz="1300" dirty="0"/>
           </a:p>
@@ -21455,7 +21455,7 @@
                 <a:ea typeface="Calibri" pitchFamily="34" charset="-122"/>
                 <a:cs typeface="Calibri" pitchFamily="34" charset="-120"/>
               </a:rPr>
-              <a:t>98,2% del universo · 0 programadas en plazo · 4 con agenda vencida · 0 sin programar</a:t>
+              <a:t>98,6% del universo · 0 programadas en plazo · 3 con agenda vencida · 0 sin programar</a:t>
             </a:r>
             <a:endParaRPr lang="en-US" sz="950" dirty="0"/>
           </a:p>
@@ -21548,7 +21548,7 @@
                 <a:ea typeface="Cambria" pitchFamily="34" charset="-122"/>
                 <a:cs typeface="Cambria" pitchFamily="34" charset="-120"/>
               </a:rPr>
-              <a:t>95%</a:t>
+              <a:t>95,3%</a:t>
             </a:r>
             <a:endParaRPr lang="en-US" sz="3800" dirty="0"/>
           </a:p>
@@ -22162,7 +22162,7 @@
                 <a:ea typeface="Calibri" pitchFamily="34" charset="-122"/>
                 <a:cs typeface="Calibri" pitchFamily="34" charset="-120"/>
               </a:rPr>
-              <a:t>Caminatas: 100% y 98,2% de lo exigible (C1 y C2).  </a:t>
+              <a:t>Caminatas: 100% y 98,6% de lo exigible (C1 y C2).  </a:t>
             </a:r>
             <a:pPr indent="0" marL="0">
               <a:lnSpc>
@@ -22179,7 +22179,7 @@
                 <a:ea typeface="Calibri" pitchFamily="34" charset="-122"/>
                 <a:cs typeface="Calibri" pitchFamily="34" charset="-120"/>
               </a:rPr>
-              <a:t>Caminata 1: 218/218 exigibles. Caminata 2: 214/218, con 0 agendadas en plazo y 0 sin programar.</a:t>
+              <a:t>Caminata 1: 218/218 exigibles. Caminata 2: 215/218, con 0 agendadas en plazo y 0 sin programar.</a:t>
             </a:r>
             <a:endParaRPr lang="en-US" sz="1150" dirty="0"/>
           </a:p>
@@ -22258,7 +22258,7 @@
                 <a:ea typeface="Calibri" pitchFamily="34" charset="-122"/>
                 <a:cs typeface="Calibri" pitchFamily="34" charset="-120"/>
               </a:rPr>
-              <a:t>Avance promedio 95%: 193 subsistemas sobre 95% y solo 3 bajo 80%.</a:t>
+              <a:t>Avance promedio 95,3%: 193 subsistemas sobre 95% y solo 3 bajo 80%.</a:t>
             </a:r>
             <a:endParaRPr lang="en-US" sz="1150" dirty="0"/>
           </a:p>
@@ -22548,7 +22548,7 @@
                 <a:ea typeface="Calibri" pitchFamily="34" charset="-122"/>
                 <a:cs typeface="Calibri" pitchFamily="34" charset="-120"/>
               </a:rPr>
-              <a:t>Caminata 2: 98,2% de lo exigible (214/218) — se descuentan 0 agendadas a fecha futura, que no son incumplimiento al corte. Talabre mide la carpeta como % de avance (PEC), no como estado de aprobación.</a:t>
+              <a:t>Caminata 2: 98,6% de lo exigible (215/218) — se descuentan 0 agendadas a fecha futura, que no son incumplimiento al corte. Talabre mide la carpeta como % de avance (PEC), no como estado de aprobación.</a:t>
             </a:r>
             <a:endParaRPr lang="en-US" sz="1350" dirty="0"/>
           </a:p>

</xml_diff>

<commit_message>
Talabre: registro de DT al 12-10-2026
La mejor semana del frente. Cerrados 1.862 → 1.923 y abiertos 313 → 252, con los
atrasados cayendo de 68 a 34. P1 pasa de 91,8% a 97,5%: solo 11 abiertos y 6
atrasados, con Obras Civiles bajando de 10 a 2 y Piping de 5 a 2.

El registro trae el mismo universo —2.175 DT, emisión al 30-09— y 61 cierres más:
no entraron DT nuevos, se cerró lo que había.

Llegó solo el registro, sin el archivo de STATUS, así que caminatas y carpetas
conservan su dato del 05-10: la 1 en 218/218 y la 2 en 215, avance PEC 95,3%. Por
eso el contraste contra la hoja DT del STATUS vuelve a descuadrar —declara los
313 de la semana pasada—; el panel usa el registro, que es la fuente ítem a ítem.

126 comprobaciones OK · 0 fallan · 2 avisos.

Co-Authored-By: Claude Opus 5 <noreply@anthropic.com>
Claude-Session: https://claude.ai/code/session_011SHyPcub1TtjA2kTAsaPFu
</commit_message>
<xml_diff>
--- a/panel_control_TOP_P1/Panel_Control_TOP_P1.pptx
+++ b/panel_control_TOP_P1/Panel_Control_TOP_P1.pptx
@@ -2717,10 +2717,10 @@
                     <c:v>Obras Civiles</c:v>
                   </c:pt>
                   <c:pt idx="2">
-                    <c:v>Eléctrica</c:v>
+                    <c:v>Estructura</c:v>
                   </c:pt>
                   <c:pt idx="3">
-                    <c:v>Estructura</c:v>
+                    <c:v>Eléctrica</c:v>
                   </c:pt>
                   <c:pt idx="4">
                     <c:v>Instr. y Control</c:v>
@@ -2736,19 +2736,19 @@
                 <c:formatCode>General</c:formatCode>
                 <c:ptCount val="5"/>
                 <c:pt idx="0">
-                  <c:v>9</c:v>
+                  <c:v>6</c:v>
                 </c:pt>
                 <c:pt idx="1">
-                  <c:v>43</c:v>
+                  <c:v>15</c:v>
                 </c:pt>
                 <c:pt idx="2">
-                  <c:v>8</c:v>
+                  <c:v>4</c:v>
                 </c:pt>
                 <c:pt idx="3">
-                  <c:v>8</c:v>
+                  <c:v>3</c:v>
                 </c:pt>
                 <c:pt idx="4">
-                  <c:v/>
+                  <c:v>6</c:v>
                 </c:pt>
               </c:numCache>
             </c:numRef>
@@ -2813,10 +2813,10 @@
                     <c:v>Obras Civiles</c:v>
                   </c:pt>
                   <c:pt idx="2">
-                    <c:v>Eléctrica</c:v>
+                    <c:v>Estructura</c:v>
                   </c:pt>
                   <c:pt idx="3">
-                    <c:v>Estructura</c:v>
+                    <c:v>Eléctrica</c:v>
                   </c:pt>
                   <c:pt idx="4">
                     <c:v>Instr. y Control</c:v>
@@ -2832,19 +2832,19 @@
                 <c:formatCode>General</c:formatCode>
                 <c:ptCount val="5"/>
                 <c:pt idx="0">
-                  <c:v>132</c:v>
+                  <c:v>130</c:v>
                 </c:pt>
                 <c:pt idx="1">
-                  <c:v>60</c:v>
+                  <c:v>56</c:v>
                 </c:pt>
                 <c:pt idx="2">
-                  <c:v>23</c:v>
+                  <c:v>13</c:v>
                 </c:pt>
                 <c:pt idx="3">
-                  <c:v>13</c:v>
+                  <c:v>12</c:v>
                 </c:pt>
                 <c:pt idx="4">
-                  <c:v>17</c:v>
+                  <c:v>7</c:v>
                 </c:pt>
               </c:numCache>
             </c:numRef>
@@ -7551,7 +7551,7 @@
                 <a:ea typeface="Calibri" pitchFamily="34" charset="-122"/>
                 <a:cs typeface="Calibri" pitchFamily="34" charset="-120"/>
               </a:rPr>
-              <a:t>Recuperar los 68 DT atrasados</a:t>
+              <a:t>Recuperar los 34 DT atrasados</a:t>
             </a:r>
             <a:endParaRPr lang="en-US" sz="1350" dirty="0"/>
           </a:p>
@@ -7593,7 +7593,7 @@
                 <a:ea typeface="Calibri" pitchFamily="34" charset="-122"/>
                 <a:cs typeface="Calibri" pitchFamily="34" charset="-120"/>
               </a:rPr>
-              <a:t>46 son P2 y 19 son P1. La mediana de atraso es de 59 días y 11 superan los 90 días.</a:t>
+              <a:t>25 son P2 y 6 son P1. La mediana de atraso es de 38 días y 7 superan los 90 días.</a:t>
             </a:r>
             <a:endParaRPr lang="en-US" sz="1100" dirty="0"/>
           </a:p>
@@ -7835,7 +7835,7 @@
                 <a:ea typeface="Calibri" pitchFamily="34" charset="-122"/>
                 <a:cs typeface="Calibri" pitchFamily="34" charset="-120"/>
               </a:rPr>
-              <a:t>Destrabar P4: 50 abiertos y ninguno cerrado</a:t>
+              <a:t>Destrabar P4: 48 abiertos y ninguno cerrado</a:t>
             </a:r>
             <a:endParaRPr lang="en-US" sz="1350" dirty="0"/>
           </a:p>
@@ -7877,7 +7877,7 @@
                 <a:ea typeface="Calibri" pitchFamily="34" charset="-122"/>
                 <a:cs typeface="Calibri" pitchFamily="34" charset="-120"/>
               </a:rPr>
-              <a:t>De 50 DT levantados en P4 no se ha cerrado ninguno (0%). P3 tampoco despega: 31,4% de cierre.</a:t>
+              <a:t>De 50 DT levantados en P4 no se ha cerrado ninguno (4%). P3 tampoco despega: 31,4% de cierre.</a:t>
             </a:r>
             <a:endParaRPr lang="en-US" sz="1100" dirty="0"/>
           </a:p>
@@ -8019,7 +8019,7 @@
                 <a:ea typeface="Calibri" pitchFamily="34" charset="-122"/>
                 <a:cs typeface="Calibri" pitchFamily="34" charset="-120"/>
               </a:rPr>
-              <a:t>Concentra 108 de los 313 DT abiertos (34,5%), con 2 atrasados. Además hay 3 carpetas bajo 80% de avance que conviene cerrar en paralelo.</a:t>
+              <a:t>Concentra 106 de los 252 DT abiertos (42,1%), con 0 atrasados. Además hay 3 carpetas bajo 80% de avance que conviene cerrar en paralelo.</a:t>
             </a:r>
             <a:endParaRPr lang="en-US" sz="1100" dirty="0"/>
           </a:p>
@@ -8058,7 +8058,7 @@
                 <a:ea typeface="Calibri" pitchFamily="34" charset="-122"/>
                 <a:cs typeface="Calibri" pitchFamily="34" charset="-120"/>
               </a:rPr>
-              <a:t>Fuente: STATUS_SUBSISTEMAS_TALABRE + Detalle_de_Terminaciones · 218 subsistemas · 2.175 DT · Atrasos al 05-10-2026</a:t>
+              <a:t>Fuente: STATUS_SUBSISTEMAS_TALABRE + Detalle_de_Terminaciones · 218 subsistemas · 2.175 DT · Atrasos al 12-10-2026</a:t>
             </a:r>
             <a:endParaRPr lang="en-US" sz="850" dirty="0"/>
           </a:p>
@@ -20739,7 +20739,7 @@
                 <a:ea typeface="Cambria" pitchFamily="34" charset="-122"/>
                 <a:cs typeface="Cambria" pitchFamily="34" charset="-120"/>
               </a:rPr>
-              <a:t>94,7%</a:t>
+              <a:t>97,9%</a:t>
             </a:r>
             <a:endParaRPr lang="en-US" sz="3400" dirty="0"/>
           </a:p>
@@ -20817,7 +20817,7 @@
                 <a:ea typeface="Calibri" pitchFamily="34" charset="-122"/>
                 <a:cs typeface="Calibri" pitchFamily="34" charset="-120"/>
               </a:rPr>
-              <a:t>Atrasos calculados al 05-10-2026</a:t>
+              <a:t>Atrasos calculados al 12-10-2026</a:t>
             </a:r>
             <a:endParaRPr lang="en-US" sz="1100" dirty="0"/>
           </a:p>
@@ -20856,7 +20856,7 @@
                 <a:ea typeface="Calibri" pitchFamily="34" charset="-122"/>
                 <a:cs typeface="Calibri" pitchFamily="34" charset="-120"/>
               </a:rPr>
-              <a:t>Fuente: STATUS_SUBSISTEMAS_TALABRE + Detalle_de_Terminaciones · 218 subsistemas · 2.175 DT · Atrasos al 05-10-2026</a:t>
+              <a:t>Fuente: STATUS_SUBSISTEMAS_TALABRE + Detalle_de_Terminaciones · 218 subsistemas · 2.175 DT · Atrasos al 12-10-2026</a:t>
             </a:r>
             <a:endParaRPr lang="en-US" sz="850" dirty="0"/>
           </a:p>
@@ -21761,7 +21761,7 @@
                 <a:ea typeface="Cambria" pitchFamily="34" charset="-122"/>
                 <a:cs typeface="Cambria" pitchFamily="34" charset="-120"/>
               </a:rPr>
-              <a:t>91,8%</a:t>
+              <a:t>97,5%</a:t>
             </a:r>
             <a:endParaRPr lang="en-US" sz="3800" dirty="0"/>
           </a:p>
@@ -21800,7 +21800,7 @@
                 <a:ea typeface="Calibri" pitchFamily="34" charset="-122"/>
                 <a:cs typeface="Calibri" pitchFamily="34" charset="-120"/>
               </a:rPr>
-              <a:t>404/440</a:t>
+              <a:t>429/440</a:t>
             </a:r>
             <a:endParaRPr lang="en-US" sz="1300" dirty="0"/>
           </a:p>
@@ -21881,7 +21881,7 @@
                 <a:ea typeface="Calibri" pitchFamily="34" charset="-122"/>
                 <a:cs typeface="Calibri" pitchFamily="34" charset="-120"/>
               </a:rPr>
-              <a:t>36 abiertos · 19 atrasados</a:t>
+              <a:t>11 abiertos · 6 atrasados</a:t>
             </a:r>
             <a:endParaRPr lang="en-US" sz="950" dirty="0"/>
           </a:p>
@@ -22021,7 +22021,7 @@
                 <a:ea typeface="Calibri" pitchFamily="34" charset="-122"/>
                 <a:cs typeface="Calibri" pitchFamily="34" charset="-120"/>
               </a:rPr>
-              <a:t>91,8% de cierre en P1 (36 abiertos), pero 277 DT abiertos entre P2, P3 y P4 sobre un total de 313.</a:t>
+              <a:t>97,5% de cierre en P1 (11 abiertos), pero 241 DT abiertos entre P2, P3 y P4 sobre un total de 252.</a:t>
             </a:r>
             <a:endParaRPr lang="en-US" sz="1150" dirty="0"/>
           </a:p>
@@ -22100,7 +22100,7 @@
                 <a:ea typeface="Calibri" pitchFamily="34" charset="-122"/>
                 <a:cs typeface="Calibri" pitchFamily="34" charset="-120"/>
               </a:rPr>
-              <a:t>68 DT con la fecha de compromiso vencida; mediana de 59 días y el más antiguo lleva 200. Los 211 abiertos sin fecha de compromiso no se cuentan como atrasados.</a:t>
+              <a:t>34 DT con la fecha de compromiso vencida; mediana de 38 días y el más antiguo lleva 207. Los 209 abiertos sin fecha de compromiso no se cuentan como atrasados.</a:t>
             </a:r>
             <a:endParaRPr lang="en-US" sz="1150" dirty="0"/>
           </a:p>
@@ -22297,7 +22297,7 @@
                 <a:ea typeface="Calibri" pitchFamily="34" charset="-122"/>
                 <a:cs typeface="Calibri" pitchFamily="34" charset="-120"/>
               </a:rPr>
-              <a:t>Fuente: STATUS_SUBSISTEMAS_TALABRE + Detalle_de_Terminaciones · 218 subsistemas · 2.175 DT · Atrasos al 05-10-2026</a:t>
+              <a:t>Fuente: STATUS_SUBSISTEMAS_TALABRE + Detalle_de_Terminaciones · 218 subsistemas · 2.175 DT · Atrasos al 12-10-2026</a:t>
             </a:r>
             <a:endParaRPr lang="en-US" sz="850" dirty="0"/>
           </a:p>
@@ -22619,7 +22619,7 @@
                 <a:ea typeface="Calibri" pitchFamily="34" charset="-122"/>
                 <a:cs typeface="Calibri" pitchFamily="34" charset="-120"/>
               </a:rPr>
-              <a:t>Fuente: STATUS_SUBSISTEMAS_TALABRE + Detalle_de_Terminaciones · 218 subsistemas · 2.175 DT · Atrasos al 05-10-2026</a:t>
+              <a:t>Fuente: STATUS_SUBSISTEMAS_TALABRE + Detalle_de_Terminaciones · 218 subsistemas · 2.175 DT · Atrasos al 12-10-2026</a:t>
             </a:r>
             <a:endParaRPr lang="en-US" sz="850" dirty="0"/>
           </a:p>
@@ -22870,7 +22870,7 @@
                 <a:ea typeface="Calibri" pitchFamily="34" charset="-122"/>
                 <a:cs typeface="Calibri" pitchFamily="34" charset="-120"/>
               </a:rPr>
-              <a:t>2.175 DT levantados; 85,6% cerrados. Atrasado = DT abierto cuya fecha de compromiso de cierre ya venció al 05-10-2026.</a:t>
+              <a:t>2.175 DT levantados; 88,4% cerrados. Atrasado = DT abierto cuya fecha de compromiso de cierre ya venció al 12-10-2026.</a:t>
             </a:r>
             <a:endParaRPr lang="en-US" sz="1350" dirty="0"/>
           </a:p>
@@ -23025,7 +23025,7 @@
                 <a:ea typeface="Calibri" pitchFamily="34" charset="-122"/>
                 <a:cs typeface="Calibri" pitchFamily="34" charset="-120"/>
               </a:rPr>
-              <a:t>404/440</a:t>
+              <a:t>429/440</a:t>
             </a:r>
             <a:endParaRPr lang="en-US" sz="1050" dirty="0"/>
           </a:p>
@@ -23064,7 +23064,7 @@
                 <a:ea typeface="Calibri" pitchFamily="34" charset="-122"/>
                 <a:cs typeface="Calibri" pitchFamily="34" charset="-120"/>
               </a:rPr>
-              <a:t>91,8%</a:t>
+              <a:t>97,5%</a:t>
             </a:r>
             <a:endParaRPr lang="en-US" sz="1100" dirty="0"/>
           </a:p>
@@ -23099,7 +23099,7 @@
         <p:spPr>
           <a:xfrm>
             <a:off x="7936992" y="2688336"/>
-            <a:ext cx="3273735" cy="118872"/>
+            <a:ext cx="3477006" cy="118872"/>
           </a:xfrm>
           <a:prstGeom prst="rect">
             <a:avLst/>
@@ -23182,7 +23182,7 @@
                 <a:ea typeface="Calibri" pitchFamily="34" charset="-122"/>
                 <a:cs typeface="Calibri" pitchFamily="34" charset="-120"/>
               </a:rPr>
-              <a:t>1.374/1.437</a:t>
+              <a:t>1.408/1.437</a:t>
             </a:r>
             <a:endParaRPr lang="en-US" sz="1050" dirty="0"/>
           </a:p>
@@ -23221,7 +23221,7 @@
                 <a:ea typeface="Calibri" pitchFamily="34" charset="-122"/>
                 <a:cs typeface="Calibri" pitchFamily="34" charset="-120"/>
               </a:rPr>
-              <a:t>95,6%</a:t>
+              <a:t>98%</a:t>
             </a:r>
             <a:endParaRPr lang="en-US" sz="1100" dirty="0"/>
           </a:p>
@@ -23256,7 +23256,7 @@
         <p:spPr>
           <a:xfrm>
             <a:off x="7936992" y="3200400"/>
-            <a:ext cx="3409249" cy="118872"/>
+            <a:ext cx="3494837" cy="118872"/>
           </a:xfrm>
           <a:prstGeom prst="rect">
             <a:avLst/>
@@ -23496,7 +23496,7 @@
                 <a:ea typeface="Calibri" pitchFamily="34" charset="-122"/>
                 <a:cs typeface="Calibri" pitchFamily="34" charset="-120"/>
               </a:rPr>
-              <a:t>0/50</a:t>
+              <a:t>2/50</a:t>
             </a:r>
             <a:endParaRPr lang="en-US" sz="1050" dirty="0"/>
           </a:p>
@@ -23535,7 +23535,7 @@
                 <a:ea typeface="Calibri" pitchFamily="34" charset="-122"/>
                 <a:cs typeface="Calibri" pitchFamily="34" charset="-120"/>
               </a:rPr>
-              <a:t>0%</a:t>
+              <a:t>4%</a:t>
             </a:r>
             <a:endParaRPr lang="en-US" sz="1100" dirty="0"/>
           </a:p>
@@ -23563,7 +23563,27 @@
       </p:sp>
       <p:sp>
         <p:nvSpPr>
-          <p:cNvPr id="28" name="Text 24"/>
+          <p:cNvPr id="28" name="Shape 24"/>
+          <p:cNvSpPr/>
+          <p:nvPr/>
+        </p:nvSpPr>
+        <p:spPr>
+          <a:xfrm>
+            <a:off x="7936992" y="4224528"/>
+            <a:ext cx="142646" cy="118872"/>
+          </a:xfrm>
+          <a:prstGeom prst="rect">
+            <a:avLst/>
+          </a:prstGeom>
+          <a:solidFill>
+            <a:srgbClr val="C0392B"/>
+          </a:solidFill>
+          <a:ln/>
+        </p:spPr>
+      </p:sp>
+      <p:sp>
+        <p:nvSpPr>
+          <p:cNvPr id="29" name="Text 25"/>
           <p:cNvSpPr/>
           <p:nvPr/>
         </p:nvSpPr>
@@ -23602,7 +23622,7 @@
       </p:sp>
       <p:sp>
         <p:nvSpPr>
-          <p:cNvPr id="29" name="Text 25"/>
+          <p:cNvPr id="30" name="Text 26"/>
           <p:cNvSpPr/>
           <p:nvPr/>
         </p:nvSpPr>
@@ -23641,7 +23661,7 @@
       </p:sp>
       <p:sp>
         <p:nvSpPr>
-          <p:cNvPr id="30" name="Text 26"/>
+          <p:cNvPr id="31" name="Text 27"/>
           <p:cNvSpPr/>
           <p:nvPr/>
         </p:nvSpPr>
@@ -23680,7 +23700,7 @@
       </p:sp>
       <p:sp>
         <p:nvSpPr>
-          <p:cNvPr id="31" name="Shape 27"/>
+          <p:cNvPr id="32" name="Shape 28"/>
           <p:cNvSpPr/>
           <p:nvPr/>
         </p:nvSpPr>
@@ -23700,7 +23720,7 @@
       </p:sp>
       <p:sp>
         <p:nvSpPr>
-          <p:cNvPr id="32" name="Shape 28"/>
+          <p:cNvPr id="33" name="Shape 29"/>
           <p:cNvSpPr/>
           <p:nvPr/>
         </p:nvSpPr>
@@ -23720,7 +23740,7 @@
       </p:sp>
       <p:sp>
         <p:nvSpPr>
-          <p:cNvPr id="33" name="Shape 29"/>
+          <p:cNvPr id="34" name="Shape 30"/>
           <p:cNvSpPr/>
           <p:nvPr/>
         </p:nvSpPr>
@@ -23743,7 +23763,7 @@
       </p:sp>
       <p:sp>
         <p:nvSpPr>
-          <p:cNvPr id="34" name="Text 30"/>
+          <p:cNvPr id="35" name="Text 31"/>
           <p:cNvSpPr/>
           <p:nvPr/>
         </p:nvSpPr>
@@ -23795,7 +23815,7 @@
                 <a:ea typeface="Calibri" pitchFamily="34" charset="-122"/>
                 <a:cs typeface="Calibri" pitchFamily="34" charset="-120"/>
               </a:rPr>
-              <a:t>Mediana de 59 días vencidos; el más antiguo lleva 200. 30 entre 1-30 días, 27 entre 31-90 días, 9 entre 91-180 días, 2 entre &gt;180 días.</a:t>
+              <a:t>Mediana de 38 días vencidos; el más antiguo lleva 207. 17 entre 1-30 días, 10 entre 31-90 días, 5 entre 91-180 días, 2 entre &gt;180 días.</a:t>
             </a:r>
             <a:endParaRPr lang="en-US" sz="1150" dirty="0"/>
           </a:p>
@@ -23803,7 +23823,7 @@
       </p:sp>
       <p:sp>
         <p:nvSpPr>
-          <p:cNvPr id="35" name="Text 31"/>
+          <p:cNvPr id="36" name="Text 32"/>
           <p:cNvSpPr/>
           <p:nvPr/>
         </p:nvSpPr>
@@ -23834,7 +23854,7 @@
                 <a:ea typeface="Calibri" pitchFamily="34" charset="-122"/>
                 <a:cs typeface="Calibri" pitchFamily="34" charset="-120"/>
               </a:rPr>
-              <a:t>Fuente: STATUS_SUBSISTEMAS_TALABRE + Detalle_de_Terminaciones · 218 subsistemas · 2.175 DT · Atrasos al 05-10-2026</a:t>
+              <a:t>Fuente: STATUS_SUBSISTEMAS_TALABRE + Detalle_de_Terminaciones · 218 subsistemas · 2.175 DT · Atrasos al 12-10-2026</a:t>
             </a:r>
             <a:endParaRPr lang="en-US" sz="850" dirty="0"/>
           </a:p>
@@ -23842,7 +23862,7 @@
       </p:sp>
       <p:sp>
         <p:nvSpPr>
-          <p:cNvPr id="36" name="Text 32"/>
+          <p:cNvPr id="37" name="Text 33"/>
           <p:cNvSpPr/>
           <p:nvPr/>
         </p:nvSpPr>
@@ -23881,7 +23901,7 @@
       </p:sp>
       <p:sp>
         <p:nvSpPr>
-          <p:cNvPr id="37" name="Text 33"/>
+          <p:cNvPr id="38" name="Text 34"/>
           <p:cNvSpPr/>
           <p:nvPr/>
         </p:nvSpPr>

</xml_diff>

<commit_message>
Desaladora: punch consolidado al 11-10-2026
Punch 2.605 ítems, 73,9% cerrado: entraron 124 y se cerraron 133. P1 sube de
71,8% a 74,6%.

El atraso sigue trepando: de 366 a 440, otra vez con los abiertos bajando —689 a
680—. Son los mismos ítems cruzando su fecha requerida, dos semanas seguidas.
Ya son 440 de 680 abiertos, el 65%.

Llegó solo el punch, sin el reporte gerencial, así que subsistemas, caminatas y
carpetas conservan su dato del 29-09: 63/95 entregadas, 46 aprobadas, caminata 2
de Operable en 66/79. El panel declara las dos fechas en la cabecera.

128 comprobaciones OK · 0 fallan · 2 avisos.

Co-Authored-By: Claude Opus 5 <noreply@anthropic.com>
Claude-Session: https://claude.ai/code/session_011SHyPcub1TtjA2kTAsaPFu
</commit_message>
<xml_diff>
--- a/panel_control_TOP_P1/Panel_Control_TOP_P1.pptx
+++ b/panel_control_TOP_P1/Panel_Control_TOP_P1.pptx
@@ -850,19 +850,19 @@
                 <c:formatCode>General</c:formatCode>
                 <c:ptCount val="6"/>
                 <c:pt idx="0">
-                  <c:v>84</c:v>
+                  <c:v>110</c:v>
                 </c:pt>
                 <c:pt idx="1">
-                  <c:v>83</c:v>
+                  <c:v>89</c:v>
                 </c:pt>
                 <c:pt idx="2">
-                  <c:v>11</c:v>
+                  <c:v>27</c:v>
                 </c:pt>
                 <c:pt idx="3">
-                  <c:v>14</c:v>
+                  <c:v>15</c:v>
                 </c:pt>
                 <c:pt idx="4">
-                  <c:v>5</c:v>
+                  <c:v>10</c:v>
                 </c:pt>
                 <c:pt idx="5">
                   <c:v>9</c:v>
@@ -952,22 +952,22 @@
                 <c:formatCode>General</c:formatCode>
                 <c:ptCount val="6"/>
                 <c:pt idx="0">
-                  <c:v>148</c:v>
+                  <c:v>93</c:v>
                 </c:pt>
                 <c:pt idx="1">
-                  <c:v>31</c:v>
+                  <c:v>27</c:v>
                 </c:pt>
                 <c:pt idx="2">
-                  <c:v>48</c:v>
+                  <c:v>30</c:v>
                 </c:pt>
                 <c:pt idx="3">
-                  <c:v>1</c:v>
+                  <c:v>3</c:v>
                 </c:pt>
                 <c:pt idx="4">
-                  <c:v>8</c:v>
+                  <c:v>3</c:v>
                 </c:pt>
                 <c:pt idx="5">
-                  <c:v>1</c:v>
+                  <c:v/>
                 </c:pt>
               </c:numCache>
             </c:numRef>
@@ -1340,13 +1340,13 @@
               <c:numCache>
                 <c:ptCount val="3"/>
                 <c:pt idx="0">
-                  <c:v>1129</c:v>
+                  <c:v>1224</c:v>
                 </c:pt>
                 <c:pt idx="1">
-                  <c:v>206</c:v>
+                  <c:v>260</c:v>
                 </c:pt>
                 <c:pt idx="2">
-                  <c:v>237</c:v>
+                  <c:v>156</c:v>
                 </c:pt>
               </c:numCache>
             </c:numRef>
@@ -7141,7 +7141,7 @@
                 <a:ea typeface="Cambria" pitchFamily="34" charset="-122"/>
                 <a:cs typeface="Cambria" pitchFamily="34" charset="-120"/>
               </a:rPr>
-              <a:t>71,8%</a:t>
+              <a:t>74,6%</a:t>
             </a:r>
             <a:endParaRPr lang="en-US" sz="3400" dirty="0"/>
           </a:p>
@@ -7258,7 +7258,7 @@
                 <a:ea typeface="Calibri" pitchFamily="34" charset="-122"/>
                 <a:cs typeface="Calibri" pitchFamily="34" charset="-120"/>
               </a:rPr>
-              <a:t>Fuente: REPORTE_GERENCIAL + Listado de Puntos Punch Consolidado · Corte 29-09-2026 · Atrasos al 05-10-2026</a:t>
+              <a:t>Fuente: REPORTE_GERENCIAL + Listado de Puntos Punch Consolidado · Corte 29-09-2026 · Atrasos al 12-10-2026</a:t>
             </a:r>
             <a:endParaRPr lang="en-US" sz="850" dirty="0"/>
           </a:p>
@@ -16713,7 +16713,7 @@
                 <a:ea typeface="Cambria" pitchFamily="34" charset="-122"/>
                 <a:cs typeface="Cambria" pitchFamily="34" charset="-120"/>
               </a:rPr>
-              <a:t>71,8%</a:t>
+              <a:t>74,6%</a:t>
             </a:r>
             <a:endParaRPr lang="en-US" sz="3800" dirty="0"/>
           </a:p>
@@ -16752,7 +16752,7 @@
                 <a:ea typeface="Calibri" pitchFamily="34" charset="-122"/>
                 <a:cs typeface="Calibri" pitchFamily="34" charset="-120"/>
               </a:rPr>
-              <a:t>1.129/1.572</a:t>
+              <a:t>1.224/1.640</a:t>
             </a:r>
             <a:endParaRPr lang="en-US" sz="1400" dirty="0"/>
           </a:p>
@@ -16833,7 +16833,7 @@
                 <a:ea typeface="Calibri" pitchFamily="34" charset="-122"/>
                 <a:cs typeface="Calibri" pitchFamily="34" charset="-120"/>
               </a:rPr>
-              <a:t>443 abiertos · 206 atrasados</a:t>
+              <a:t>416 abiertos · 260 atrasados</a:t>
             </a:r>
             <a:endParaRPr lang="en-US" sz="950" dirty="0"/>
           </a:p>
@@ -16973,7 +16973,7 @@
                 <a:ea typeface="Calibri" pitchFamily="34" charset="-122"/>
                 <a:cs typeface="Calibri" pitchFamily="34" charset="-120"/>
               </a:rPr>
-              <a:t>1.792 de 2.481 ítems cerrados (72,2%); de los 689 abiertos, 366 ya pasaron su fecha requerida de cierre (53,1%).</a:t>
+              <a:t>1.925 de 2.605 ítems cerrados (73,9%); de los 680 abiertos, 440 ya pasaron su fecha requerida de cierre (64,7%).</a:t>
             </a:r>
             <a:endParaRPr lang="en-US" sz="1150" dirty="0"/>
           </a:p>
@@ -17210,7 +17210,7 @@
                 <a:ea typeface="Calibri" pitchFamily="34" charset="-122"/>
                 <a:cs typeface="Calibri" pitchFamily="34" charset="-120"/>
               </a:rPr>
-              <a:t>232 de los 443 P1 abiertos (52,4%), con 84 atrasados.</a:t>
+              <a:t>203 de los 416 P1 abiertos (48,8%), con 110 atrasados.</a:t>
             </a:r>
             <a:endParaRPr lang="en-US" sz="1150" dirty="0"/>
           </a:p>
@@ -17249,7 +17249,7 @@
                 <a:ea typeface="Calibri" pitchFamily="34" charset="-122"/>
                 <a:cs typeface="Calibri" pitchFamily="34" charset="-120"/>
               </a:rPr>
-              <a:t>Fuente: REPORTE_GERENCIAL + Listado de Puntos Punch Consolidado · Corte 29-09-2026 · Atrasos al 05-10-2026</a:t>
+              <a:t>Fuente: REPORTE_GERENCIAL + Listado de Puntos Punch Consolidado · Corte 29-09-2026 · Atrasos al 12-10-2026</a:t>
             </a:r>
             <a:endParaRPr lang="en-US" sz="850" dirty="0"/>
           </a:p>
@@ -18458,7 +18458,7 @@
                 <a:ea typeface="Calibri" pitchFamily="34" charset="-122"/>
                 <a:cs typeface="Calibri" pitchFamily="34" charset="-120"/>
               </a:rPr>
-              <a:t>Fuente: REPORTE_GERENCIAL + Listado de Puntos Punch Consolidado · Corte 29-09-2026 · Atrasos al 05-10-2026</a:t>
+              <a:t>Fuente: REPORTE_GERENCIAL + Listado de Puntos Punch Consolidado · Corte 29-09-2026 · Atrasos al 12-10-2026</a:t>
             </a:r>
             <a:endParaRPr lang="en-US" sz="850" dirty="0"/>
           </a:p>
@@ -18709,7 +18709,7 @@
                 <a:ea typeface="Calibri" pitchFamily="34" charset="-122"/>
                 <a:cs typeface="Calibri" pitchFamily="34" charset="-120"/>
               </a:rPr>
-              <a:t>1.572 P1 levantados; 71,8% cerrados. Atrasado = ítem abierto cuya fecha requerida de cierre ya venció al 05-10-2026.</a:t>
+              <a:t>1.640 P1 levantados; 74,6% cerrados. Atrasado = ítem abierto cuya fecha requerida de cierre ya venció al 12-10-2026.</a:t>
             </a:r>
             <a:endParaRPr lang="en-US" sz="1350" dirty="0"/>
           </a:p>
@@ -18841,7 +18841,7 @@
                 <a:ea typeface="Cambria" pitchFamily="34" charset="-122"/>
                 <a:cs typeface="Cambria" pitchFamily="34" charset="-120"/>
               </a:rPr>
-              <a:t>71,8%</a:t>
+              <a:t>74,6%</a:t>
             </a:r>
             <a:endParaRPr lang="en-US" sz="1900" dirty="0"/>
           </a:p>
@@ -18956,7 +18956,7 @@
                 <a:ea typeface="Calibri" pitchFamily="34" charset="-122"/>
                 <a:cs typeface="Calibri" pitchFamily="34" charset="-120"/>
               </a:rPr>
-              <a:t>1.129</a:t>
+              <a:t>1.224</a:t>
             </a:r>
             <a:endParaRPr lang="en-US" sz="1100" dirty="0"/>
           </a:p>
@@ -19054,7 +19054,7 @@
                 <a:ea typeface="Calibri" pitchFamily="34" charset="-122"/>
                 <a:cs typeface="Calibri" pitchFamily="34" charset="-120"/>
               </a:rPr>
-              <a:t>206</a:t>
+              <a:t>260</a:t>
             </a:r>
             <a:endParaRPr lang="en-US" sz="1100" dirty="0"/>
           </a:p>
@@ -19152,7 +19152,7 @@
                 <a:ea typeface="Calibri" pitchFamily="34" charset="-122"/>
                 <a:cs typeface="Calibri" pitchFamily="34" charset="-120"/>
               </a:rPr>
-              <a:t>237</a:t>
+              <a:t>156</a:t>
             </a:r>
             <a:endParaRPr lang="en-US" sz="1100" dirty="0"/>
           </a:p>
@@ -19235,7 +19235,7 @@
                 <a:ea typeface="Calibri" pitchFamily="34" charset="-122"/>
                 <a:cs typeface="Calibri" pitchFamily="34" charset="-120"/>
               </a:rPr>
-              <a:t>Mediana de 20 días vencidos; el más antiguo lleva 148. 202 entre 1-30 días, 82 entre 31-90 días, 82 entre 91-180 días.</a:t>
+              <a:t>Mediana de 12 días vencidos; el más antiguo lleva 155. 266 entre 1-30 días, 92 entre 31-90 días, 82 entre 91-180 días.</a:t>
             </a:r>
             <a:endParaRPr lang="en-US" sz="1150" dirty="0"/>
           </a:p>
@@ -19274,7 +19274,7 @@
                 <a:ea typeface="Calibri" pitchFamily="34" charset="-122"/>
                 <a:cs typeface="Calibri" pitchFamily="34" charset="-120"/>
               </a:rPr>
-              <a:t>Fuente: REPORTE_GERENCIAL + Listado de Puntos Punch Consolidado · Corte 29-09-2026 · Atrasos al 05-10-2026</a:t>
+              <a:t>Fuente: REPORTE_GERENCIAL + Listado de Puntos Punch Consolidado · Corte 29-09-2026 · Atrasos al 12-10-2026</a:t>
             </a:r>
             <a:endParaRPr lang="en-US" sz="850" dirty="0"/>
           </a:p>
@@ -19606,7 +19606,7 @@
                 <a:ea typeface="Calibri" pitchFamily="34" charset="-122"/>
                 <a:cs typeface="Calibri" pitchFamily="34" charset="-120"/>
               </a:rPr>
-              <a:t>Recuperar los 366 ítems atrasados</a:t>
+              <a:t>Recuperar los 440 ítems atrasados</a:t>
             </a:r>
             <a:endParaRPr lang="en-US" sz="1400" dirty="0"/>
           </a:p>
@@ -19648,7 +19648,7 @@
                 <a:ea typeface="Calibri" pitchFamily="34" charset="-122"/>
                 <a:cs typeface="Calibri" pitchFamily="34" charset="-120"/>
               </a:rPr>
-              <a:t>53,1% de los 689 abiertos ya venció su fecha requerida. Foco en Piping (84), Eléctrica (83), Mecánica (11).</a:t>
+              <a:t>64,7% de los 680 abiertos ya venció su fecha requerida. Foco en Piping (110), Eléctrica (89), Mecánica (27).</a:t>
             </a:r>
             <a:endParaRPr lang="en-US" sz="1100" dirty="0"/>
           </a:p>
@@ -20074,7 +20074,7 @@
                 <a:ea typeface="Calibri" pitchFamily="34" charset="-122"/>
                 <a:cs typeface="Calibri" pitchFamily="34" charset="-120"/>
               </a:rPr>
-              <a:t>Concentra 391 P1 abiertos y 154 atrasados sobre 74 subsistemas. Es la ruta crítica del proyecto.</a:t>
+              <a:t>Concentra 367 P1 abiertos y 211 atrasados sobre 74 subsistemas. Es la ruta crítica del proyecto.</a:t>
             </a:r>
             <a:endParaRPr lang="en-US" sz="1100" dirty="0"/>
           </a:p>
@@ -20113,7 +20113,7 @@
                 <a:ea typeface="Calibri" pitchFamily="34" charset="-122"/>
                 <a:cs typeface="Calibri" pitchFamily="34" charset="-120"/>
               </a:rPr>
-              <a:t>Fuente: REPORTE_GERENCIAL + Listado de Puntos Punch Consolidado · Corte 29-09-2026 · Atrasos al 05-10-2026</a:t>
+              <a:t>Fuente: REPORTE_GERENCIAL + Listado de Puntos Punch Consolidado · Corte 29-09-2026 · Atrasos al 12-10-2026</a:t>
             </a:r>
             <a:endParaRPr lang="en-US" sz="850" dirty="0"/>
           </a:p>

</xml_diff>

<commit_message>
Arqueros al 13-10-2026 — el corte queda completo
El frente completó sus caminatas: la 100% pasa de 107 a 136 de 136. P1 cerrados
1.474 → 1.611, abiertos 582 → 483 y vencidos 448 → 325; el cierre sube de 71,7%
a 76,9%.

Carpetas TOP entregadas 40 → 46, pero las seis nuevas entraron a revisión y
siguen 0 aprobadas de 136. Las rechazadas se mantienen en 24 y las que esperan
pronunciamiento pasan de 15 a 21.

La fecha la declara el propio archivo del cliente, que dice 13-10, un día por
delante del resto del corte.

133 comprobaciones OK · 0 fallan · 2 avisos.

Co-Authored-By: Claude Opus 5 <noreply@anthropic.com>
Claude-Session: https://claude.ai/code/session_011SHyPcub1TtjA2kTAsaPFu
</commit_message>
<xml_diff>
--- a/panel_control_TOP_P1/Panel_Control_TOP_P1.pptx
+++ b/panel_control_TOP_P1/Panel_Control_TOP_P1.pptx
@@ -687,10 +687,10 @@
               <c:numCache>
                 <c:ptCount val="3"/>
                 <c:pt idx="0">
-                  <c:v>1474</c:v>
+                  <c:v>1611</c:v>
                 </c:pt>
                 <c:pt idx="1">
-                  <c:v>582</c:v>
+                  <c:v>483</c:v>
                 </c:pt>
                 <c:pt idx="2">
                   <c:v>0</c:v>
@@ -3126,10 +3126,10 @@
                   <c:v>35</c:v>
                 </c:pt>
                 <c:pt idx="1">
-                  <c:v>50</c:v>
+                  <c:v>77</c:v>
                 </c:pt>
                 <c:pt idx="2">
-                  <c:v>20</c:v>
+                  <c:v>22</c:v>
                 </c:pt>
                 <c:pt idx="3">
                   <c:v>2</c:v>
@@ -3216,10 +3216,10 @@
                   <c:v/>
                 </c:pt>
                 <c:pt idx="1">
-                  <c:v>27</c:v>
+                  <c:v/>
                 </c:pt>
                 <c:pt idx="2">
-                  <c:v>2</c:v>
+                  <c:v/>
                 </c:pt>
                 <c:pt idx="3">
                   <c:v/>
@@ -3591,13 +3591,13 @@
                 <c:formatCode>General</c:formatCode>
                 <c:ptCount val="4"/>
                 <c:pt idx="0">
-                  <c:v>15</c:v>
+                  <c:v>16</c:v>
                 </c:pt>
                 <c:pt idx="1">
                   <c:v/>
                 </c:pt>
                 <c:pt idx="2">
-                  <c:v/>
+                  <c:v>5</c:v>
                 </c:pt>
                 <c:pt idx="3">
                   <c:v/>
@@ -3861,13 +3861,13 @@
                 <c:formatCode>General</c:formatCode>
                 <c:ptCount val="4"/>
                 <c:pt idx="0">
-                  <c:v>5</c:v>
+                  <c:v>4</c:v>
                 </c:pt>
                 <c:pt idx="1">
                   <c:v>69</c:v>
                 </c:pt>
                 <c:pt idx="2">
-                  <c:v>20</c:v>
+                  <c:v>15</c:v>
                 </c:pt>
                 <c:pt idx="3">
                   <c:v>2</c:v>
@@ -4155,16 +4155,16 @@
                 <c:formatCode>General</c:formatCode>
                 <c:ptCount val="6"/>
                 <c:pt idx="0">
-                  <c:v>132</c:v>
+                  <c:v>106</c:v>
                 </c:pt>
                 <c:pt idx="1">
-                  <c:v>124</c:v>
+                  <c:v>81</c:v>
                 </c:pt>
                 <c:pt idx="2">
-                  <c:v>129</c:v>
+                  <c:v>97</c:v>
                 </c:pt>
                 <c:pt idx="3">
-                  <c:v>62</c:v>
+                  <c:v>40</c:v>
                 </c:pt>
                 <c:pt idx="4">
                   <c:v/>
@@ -4257,16 +4257,16 @@
                 <c:formatCode>General</c:formatCode>
                 <c:ptCount val="6"/>
                 <c:pt idx="0">
-                  <c:v>43</c:v>
+                  <c:v>47</c:v>
                 </c:pt>
                 <c:pt idx="1">
-                  <c:v>26</c:v>
+                  <c:v>45</c:v>
                 </c:pt>
                 <c:pt idx="2">
-                  <c:v>20</c:v>
+                  <c:v>22</c:v>
                 </c:pt>
                 <c:pt idx="3">
-                  <c:v>16</c:v>
+                  <c:v>15</c:v>
                 </c:pt>
                 <c:pt idx="4">
                   <c:v>16</c:v>
@@ -8411,7 +8411,7 @@
                 <a:ea typeface="Calibri" pitchFamily="34" charset="-122"/>
                 <a:cs typeface="Calibri" pitchFamily="34" charset="-120"/>
               </a:rPr>
-              <a:t>136 subsistemas en 4 áreas (2000 · 3000 · 4000 · 8000) · 3.114 detalles de terminación levantados.</a:t>
+              <a:t>136 subsistemas en 4 áreas (2000 · 3000 · 4000 · 8000) · 3.175 detalles de terminación levantados.</a:t>
             </a:r>
             <a:endParaRPr lang="en-US" sz="1350" dirty="0"/>
           </a:p>
@@ -8548,7 +8548,7 @@
                 <a:ea typeface="Cambria" pitchFamily="34" charset="-122"/>
                 <a:cs typeface="Cambria" pitchFamily="34" charset="-120"/>
               </a:rPr>
-              <a:t>78,7%</a:t>
+              <a:t>100%</a:t>
             </a:r>
             <a:endParaRPr lang="en-US" sz="3400" dirty="0"/>
           </a:p>
@@ -8626,7 +8626,7 @@
                 <a:ea typeface="Cambria" pitchFamily="34" charset="-122"/>
                 <a:cs typeface="Cambria" pitchFamily="34" charset="-120"/>
               </a:rPr>
-              <a:t>29,4%</a:t>
+              <a:t>33,8%</a:t>
             </a:r>
             <a:endParaRPr lang="en-US" sz="3400" dirty="0"/>
           </a:p>
@@ -8704,7 +8704,7 @@
                 <a:ea typeface="Cambria" pitchFamily="34" charset="-122"/>
                 <a:cs typeface="Cambria" pitchFamily="34" charset="-120"/>
               </a:rPr>
-              <a:t>71,7%</a:t>
+              <a:t>76,9%</a:t>
             </a:r>
             <a:endParaRPr lang="en-US" sz="3400" dirty="0"/>
           </a:p>
@@ -8782,7 +8782,7 @@
                 <a:ea typeface="Calibri" pitchFamily="34" charset="-122"/>
                 <a:cs typeface="Calibri" pitchFamily="34" charset="-120"/>
               </a:rPr>
-              <a:t>Corte: 01-10-2026   ·   Corte anterior: 28-09-2026</a:t>
+              <a:t>Corte: 13-10-2026   ·   Corte anterior: 01-10-2026</a:t>
             </a:r>
             <a:endParaRPr lang="en-US" sz="1100" dirty="0"/>
           </a:p>
@@ -8821,7 +8821,7 @@
                 <a:ea typeface="Calibri" pitchFamily="34" charset="-122"/>
                 <a:cs typeface="Calibri" pitchFamily="34" charset="-120"/>
               </a:rPr>
-              <a:t>Fuente: Estatus_Resumen_General_QAQC.xlsx · Corte 01-10-2026 · Áreas 2000/3000/4000/8000</a:t>
+              <a:t>Fuente: Estatus_Resumen_General_QAQC.xlsx · Corte 13-10-2026 · Áreas 2000/3000/4000/8000</a:t>
             </a:r>
             <a:endParaRPr lang="en-US" sz="850" dirty="0"/>
           </a:p>
@@ -9297,7 +9297,7 @@
                 <a:ea typeface="Cambria" pitchFamily="34" charset="-122"/>
                 <a:cs typeface="Cambria" pitchFamily="34" charset="-120"/>
               </a:rPr>
-              <a:t>78,7%</a:t>
+              <a:t>100%</a:t>
             </a:r>
             <a:endParaRPr lang="en-US" sz="4000" dirty="0"/>
           </a:p>
@@ -9336,7 +9336,7 @@
                 <a:ea typeface="Calibri" pitchFamily="34" charset="-122"/>
                 <a:cs typeface="Calibri" pitchFamily="34" charset="-120"/>
               </a:rPr>
-              <a:t>107/136</a:t>
+              <a:t>136/136</a:t>
             </a:r>
             <a:endParaRPr lang="en-US" sz="1400" dirty="0"/>
           </a:p>
@@ -9414,7 +9414,7 @@
                 <a:ea typeface="Calibri" pitchFamily="34" charset="-122"/>
                 <a:cs typeface="Calibri" pitchFamily="34" charset="-120"/>
               </a:rPr>
-              <a:t>29 próximas · 0 por programar</a:t>
+              <a:t>0 próximas · 0 por programar</a:t>
             </a:r>
             <a:endParaRPr lang="en-US" sz="950" dirty="0"/>
           </a:p>
@@ -9447,13 +9447,13 @@
             <a:r>
               <a:rPr lang="en-US" sz="900" b="1" dirty="0">
                 <a:solidFill>
-                  <a:srgbClr val="56606E"/>
-                </a:solidFill>
-                <a:latin typeface="Calibri" pitchFamily="34" charset="0"/>
-                <a:ea typeface="Calibri" pitchFamily="34" charset="-122"/>
-                <a:cs typeface="Calibri" pitchFamily="34" charset="-120"/>
-              </a:rPr>
-              <a:t>= sin cambio vs. corte anterior</a:t>
+                  <a:srgbClr val="1F7A44"/>
+                </a:solidFill>
+                <a:latin typeface="Calibri" pitchFamily="34" charset="0"/>
+                <a:ea typeface="Calibri" pitchFamily="34" charset="-122"/>
+                <a:cs typeface="Calibri" pitchFamily="34" charset="-120"/>
+              </a:rPr>
+              <a:t>▲ +29 vs. corte anterior</a:t>
             </a:r>
             <a:endParaRPr lang="en-US" sz="900" dirty="0"/>
           </a:p>
@@ -9546,7 +9546,7 @@
                 <a:ea typeface="Cambria" pitchFamily="34" charset="-122"/>
                 <a:cs typeface="Cambria" pitchFamily="34" charset="-120"/>
               </a:rPr>
-              <a:t>29,4%</a:t>
+              <a:t>33,8%</a:t>
             </a:r>
             <a:endParaRPr lang="en-US" sz="4000" dirty="0"/>
           </a:p>
@@ -9585,7 +9585,7 @@
                 <a:ea typeface="Calibri" pitchFamily="34" charset="-122"/>
                 <a:cs typeface="Calibri" pitchFamily="34" charset="-120"/>
               </a:rPr>
-              <a:t>40/136</a:t>
+              <a:t>46/136</a:t>
             </a:r>
             <a:endParaRPr lang="en-US" sz="1400" dirty="0"/>
           </a:p>
@@ -9663,7 +9663,7 @@
                 <a:ea typeface="Calibri" pitchFamily="34" charset="-122"/>
                 <a:cs typeface="Calibri" pitchFamily="34" charset="-120"/>
               </a:rPr>
-              <a:t>0 aprobadas · 24 rechazadas · 15 en revisión · 1 observadas</a:t>
+              <a:t>0 aprobadas · 24 rechazadas · 21 en revisión · 1 observadas</a:t>
             </a:r>
             <a:endParaRPr lang="en-US" sz="950" dirty="0"/>
           </a:p>
@@ -9702,7 +9702,7 @@
                 <a:ea typeface="Calibri" pitchFamily="34" charset="-122"/>
                 <a:cs typeface="Calibri" pitchFamily="34" charset="-120"/>
               </a:rPr>
-              <a:t>▲ +1 vs. corte anterior</a:t>
+              <a:t>▲ +6 vs. corte anterior</a:t>
             </a:r>
             <a:endParaRPr lang="en-US" sz="900" dirty="0"/>
           </a:p>
@@ -9795,7 +9795,7 @@
                 <a:ea typeface="Cambria" pitchFamily="34" charset="-122"/>
                 <a:cs typeface="Cambria" pitchFamily="34" charset="-120"/>
               </a:rPr>
-              <a:t>71,7%</a:t>
+              <a:t>76,9%</a:t>
             </a:r>
             <a:endParaRPr lang="en-US" sz="4000" dirty="0"/>
           </a:p>
@@ -9834,7 +9834,7 @@
                 <a:ea typeface="Calibri" pitchFamily="34" charset="-122"/>
                 <a:cs typeface="Calibri" pitchFamily="34" charset="-120"/>
               </a:rPr>
-              <a:t>1.474/2.056</a:t>
+              <a:t>1.611/2.094</a:t>
             </a:r>
             <a:endParaRPr lang="en-US" sz="1400" dirty="0"/>
           </a:p>
@@ -9912,7 +9912,7 @@
                 <a:ea typeface="Calibri" pitchFamily="34" charset="-122"/>
                 <a:cs typeface="Calibri" pitchFamily="34" charset="-120"/>
               </a:rPr>
-              <a:t>582 abiertos · 448 vencidos</a:t>
+              <a:t>483 abiertos · 325 vencidos</a:t>
             </a:r>
             <a:endParaRPr lang="en-US" sz="950" dirty="0"/>
           </a:p>
@@ -9951,7 +9951,7 @@
                 <a:ea typeface="Calibri" pitchFamily="34" charset="-122"/>
                 <a:cs typeface="Calibri" pitchFamily="34" charset="-120"/>
               </a:rPr>
-              <a:t>▲ +37 vs. corte anterior</a:t>
+              <a:t>▲ +137 vs. corte anterior</a:t>
             </a:r>
             <a:endParaRPr lang="en-US" sz="900" dirty="0"/>
           </a:p>
@@ -10074,7 +10074,7 @@
                 <a:ea typeface="Calibri" pitchFamily="34" charset="-122"/>
                 <a:cs typeface="Calibri" pitchFamily="34" charset="-120"/>
               </a:rPr>
-              <a:t>Se destrabó la programación de caminatas, pero no la ejecución.  </a:t>
+              <a:t>Avance de caminatas al 100%.  </a:t>
             </a:r>
             <a:pPr indent="0" marL="0">
               <a:lnSpc>
@@ -10091,7 +10091,7 @@
                 <a:ea typeface="Calibri" pitchFamily="34" charset="-122"/>
                 <a:cs typeface="Calibri" pitchFamily="34" charset="-120"/>
               </a:rPr>
-              <a:t>Los subsistemas «por programar» bajaron de 2 a 0, mientras las realizadas al 100% se mantienen en 107 (78,7%).</a:t>
+              <a:t>136 de 136 realizadas (100%); 0 próximas y 0 por programar.</a:t>
             </a:r>
             <a:endParaRPr lang="en-US" sz="1250" dirty="0"/>
           </a:p>
@@ -10153,7 +10153,7 @@
                 <a:ea typeface="Calibri" pitchFamily="34" charset="-122"/>
                 <a:cs typeface="Calibri" pitchFamily="34" charset="-120"/>
               </a:rPr>
-              <a:t>Las carpetas TOP siguen sin aprobaciones y suben los rechazos.  </a:t>
+              <a:t>Las carpetas TOP siguen sin aprobaciones.  </a:t>
             </a:r>
             <a:pPr indent="0" marL="0">
               <a:lnSpc>
@@ -10170,7 +10170,7 @@
                 <a:ea typeface="Calibri" pitchFamily="34" charset="-122"/>
                 <a:cs typeface="Calibri" pitchFamily="34" charset="-120"/>
               </a:rPr>
-              <a:t>40 entregadas de 136 (29,4%) y 0 aprobadas; las rechazadas pasaron de 21 a 24.</a:t>
+              <a:t>46 entregadas de 136 (33,8%) y 0 aprobadas; 24 rechazadas.</a:t>
             </a:r>
             <a:endParaRPr lang="en-US" sz="1250" dirty="0"/>
           </a:p>
@@ -10249,7 +10249,7 @@
                 <a:ea typeface="Calibri" pitchFamily="34" charset="-122"/>
                 <a:cs typeface="Calibri" pitchFamily="34" charset="-120"/>
               </a:rPr>
-              <a:t>+37 P1 cerrado desde el corte anterior; 582 abiertos, de los cuales 448 superaron su fecha de vencimiento. El área 3000 concentra 536 (92,1%).</a:t>
+              <a:t>+137 P1 cerrado desde el corte anterior; 483 abiertos, de los cuales 325 superaron su fecha de vencimiento. El área 3000 concentra 440 (91,1%).</a:t>
             </a:r>
             <a:endParaRPr lang="en-US" sz="1250" dirty="0"/>
           </a:p>
@@ -10288,7 +10288,7 @@
                 <a:ea typeface="Calibri" pitchFamily="34" charset="-122"/>
                 <a:cs typeface="Calibri" pitchFamily="34" charset="-120"/>
               </a:rPr>
-              <a:t>Fuente: Estatus_Resumen_General_QAQC.xlsx · Corte 01-10-2026 · Áreas 2000/3000/4000/8000</a:t>
+              <a:t>Fuente: Estatus_Resumen_General_QAQC.xlsx · Corte 13-10-2026 · Áreas 2000/3000/4000/8000</a:t>
             </a:r>
             <a:endParaRPr lang="en-US" sz="850" dirty="0"/>
           </a:p>
@@ -10991,7 +10991,7 @@
                 <a:ea typeface="Calibri" pitchFamily="34" charset="-122"/>
                 <a:cs typeface="Calibri" pitchFamily="34" charset="-120"/>
               </a:rPr>
-              <a:t>30/35 · 85,7%</a:t>
+              <a:t>31/35 · 88,6%</a:t>
             </a:r>
             <a:endParaRPr lang="en-US" sz="1300" dirty="0"/>
           </a:p>
@@ -11329,7 +11329,7 @@
                 <a:ea typeface="Calibri" pitchFamily="34" charset="-122"/>
                 <a:cs typeface="Calibri" pitchFamily="34" charset="-120"/>
               </a:rPr>
-              <a:t>50/77 · 64,9%</a:t>
+              <a:t>77/77 · 100%</a:t>
             </a:r>
             <a:endParaRPr lang="en-US" sz="1300" dirty="0"/>
           </a:p>
@@ -11407,7 +11407,7 @@
                 <a:ea typeface="Calibri" pitchFamily="34" charset="-122"/>
                 <a:cs typeface="Calibri" pitchFamily="34" charset="-120"/>
               </a:rPr>
-              <a:t>51,3%</a:t>
+              <a:t>61,4%</a:t>
             </a:r>
             <a:endParaRPr lang="en-US" sz="1300" dirty="0"/>
           </a:p>
@@ -11446,7 +11446,7 @@
                 <a:ea typeface="Calibri" pitchFamily="34" charset="-122"/>
                 <a:cs typeface="Calibri" pitchFamily="34" charset="-120"/>
               </a:rPr>
-              <a:t>536 (421)</a:t>
+              <a:t>440 (301)</a:t>
             </a:r>
             <a:endParaRPr lang="en-US" sz="1300" dirty="0"/>
           </a:p>
@@ -11686,7 +11686,7 @@
                 <a:ea typeface="Calibri" pitchFamily="34" charset="-122"/>
                 <a:cs typeface="Calibri" pitchFamily="34" charset="-120"/>
               </a:rPr>
-              <a:t>20/22 · 90,9%</a:t>
+              <a:t>22/22 · 100%</a:t>
             </a:r>
             <a:endParaRPr lang="en-US" sz="1300" dirty="0"/>
           </a:p>
@@ -11725,7 +11725,7 @@
                 <a:ea typeface="Calibri" pitchFamily="34" charset="-122"/>
                 <a:cs typeface="Calibri" pitchFamily="34" charset="-120"/>
               </a:rPr>
-              <a:t>2/22 · 9,1%</a:t>
+              <a:t>7/22 · 31,8%</a:t>
             </a:r>
             <a:endParaRPr lang="en-US" sz="1300" dirty="0"/>
           </a:p>
@@ -11764,7 +11764,7 @@
                 <a:ea typeface="Calibri" pitchFamily="34" charset="-122"/>
                 <a:cs typeface="Calibri" pitchFamily="34" charset="-120"/>
               </a:rPr>
-              <a:t>88%</a:t>
+              <a:t>88,8%</a:t>
             </a:r>
             <a:endParaRPr lang="en-US" sz="1300" dirty="0"/>
           </a:p>
@@ -11803,7 +11803,7 @@
                 <a:ea typeface="Calibri" pitchFamily="34" charset="-122"/>
                 <a:cs typeface="Calibri" pitchFamily="34" charset="-120"/>
               </a:rPr>
-              <a:t>44 (25)</a:t>
+              <a:t>41 (22)</a:t>
             </a:r>
             <a:endParaRPr lang="en-US" sz="1300" dirty="0"/>
           </a:p>
@@ -12342,7 +12342,7 @@
                 <a:ea typeface="Calibri" pitchFamily="34" charset="-122"/>
                 <a:cs typeface="Calibri" pitchFamily="34" charset="-120"/>
               </a:rPr>
-              <a:t>Fuente: Estatus_Resumen_General_QAQC.xlsx · Corte 01-10-2026 · Áreas 2000/3000/4000/8000</a:t>
+              <a:t>Fuente: Estatus_Resumen_General_QAQC.xlsx · Corte 13-10-2026 · Áreas 2000/3000/4000/8000</a:t>
             </a:r>
             <a:endParaRPr lang="en-US" sz="850" dirty="0"/>
           </a:p>
@@ -12593,7 +12593,7 @@
                 <a:ea typeface="Calibri" pitchFamily="34" charset="-122"/>
                 <a:cs typeface="Calibri" pitchFamily="34" charset="-120"/>
               </a:rPr>
-              <a:t>Las caminatas al 80% están cerradas en todas las áreas (136/136). El hito 100% avanza a 78,7%, y el área 3000 concentra 27 de los 29 subsistemas pendientes.</a:t>
+              <a:t>Las caminatas al 80% están cerradas en todas las áreas (136/136). El hito 100% avanza a 100%.</a:t>
             </a:r>
             <a:endParaRPr lang="en-US" sz="1350" dirty="0"/>
           </a:p>
@@ -12849,7 +12849,7 @@
                 <a:ea typeface="Cambria" pitchFamily="34" charset="-122"/>
                 <a:cs typeface="Cambria" pitchFamily="34" charset="-120"/>
               </a:rPr>
-              <a:t>78,7%</a:t>
+              <a:t>100%</a:t>
             </a:r>
             <a:endParaRPr lang="en-US" sz="4000" dirty="0"/>
           </a:p>
@@ -12888,7 +12888,7 @@
                 <a:ea typeface="Calibri" pitchFamily="34" charset="-122"/>
                 <a:cs typeface="Calibri" pitchFamily="34" charset="-120"/>
               </a:rPr>
-              <a:t>107 realizadas · 29 pendientes</a:t>
+              <a:t>136 realizadas · 0 pendientes</a:t>
             </a:r>
             <a:endParaRPr lang="en-US" sz="1200" dirty="0"/>
           </a:p>
@@ -12947,7 +12947,7 @@
                 <a:ea typeface="Calibri" pitchFamily="34" charset="-122"/>
                 <a:cs typeface="Calibri" pitchFamily="34" charset="-120"/>
               </a:rPr>
-              <a:t>29 próximas a realizar y 0 por programar. Las «por programar» bajaron 2 en el período.</a:t>
+              <a:t>0 próximas a realizar y 0 por programar.</a:t>
             </a:r>
             <a:endParaRPr lang="en-US" sz="1150" dirty="0"/>
           </a:p>
@@ -12986,7 +12986,7 @@
                 <a:ea typeface="Calibri" pitchFamily="34" charset="-122"/>
                 <a:cs typeface="Calibri" pitchFamily="34" charset="-120"/>
               </a:rPr>
-              <a:t>Fuente: Estatus_Resumen_General_QAQC.xlsx · Corte 01-10-2026 · Áreas 2000/3000/4000/8000</a:t>
+              <a:t>Fuente: Estatus_Resumen_General_QAQC.xlsx · Corte 13-10-2026 · Áreas 2000/3000/4000/8000</a:t>
             </a:r>
             <a:endParaRPr lang="en-US" sz="850" dirty="0"/>
           </a:p>
@@ -13237,7 +13237,7 @@
                 <a:ea typeface="Calibri" pitchFamily="34" charset="-122"/>
                 <a:cs typeface="Calibri" pitchFamily="34" charset="-120"/>
               </a:rPr>
-              <a:t>40 carpetas entregadas de 136 (29,4%). Ninguna aprobada aún: el flujo se acumula en revisión y hay 24 rechazos que requieren rearmado.</a:t>
+              <a:t>46 carpetas entregadas de 136 (33,8%). Ninguna aprobada aún: el flujo se acumula en revisión y hay 24 rechazos que requieren rearmado.</a:t>
             </a:r>
             <a:endParaRPr lang="en-US" sz="1350" dirty="0"/>
           </a:p>
@@ -13439,7 +13439,7 @@
                 <a:ea typeface="Calibri" pitchFamily="34" charset="-122"/>
                 <a:cs typeface="Calibri" pitchFamily="34" charset="-120"/>
               </a:rPr>
-              <a:t>▲ +1</a:t>
+              <a:t>▲ +6</a:t>
             </a:r>
             <a:endParaRPr lang="en-US" sz="950" dirty="0"/>
           </a:p>
@@ -13478,7 +13478,7 @@
                 <a:ea typeface="Cambria" pitchFamily="34" charset="-122"/>
                 <a:cs typeface="Cambria" pitchFamily="34" charset="-120"/>
               </a:rPr>
-              <a:t>40</a:t>
+              <a:t>46</a:t>
             </a:r>
             <a:endParaRPr lang="en-US" sz="2200" dirty="0"/>
           </a:p>
@@ -13592,13 +13592,13 @@
             <a:r>
               <a:rPr lang="en-US" sz="950" b="1" dirty="0">
                 <a:solidFill>
-                  <a:srgbClr val="C0392B"/>
-                </a:solidFill>
-                <a:latin typeface="Calibri" pitchFamily="34" charset="0"/>
-                <a:ea typeface="Calibri" pitchFamily="34" charset="-122"/>
-                <a:cs typeface="Calibri" pitchFamily="34" charset="-120"/>
-              </a:rPr>
-              <a:t>▼ -2</a:t>
+                  <a:srgbClr val="1F7A44"/>
+                </a:solidFill>
+                <a:latin typeface="Calibri" pitchFamily="34" charset="0"/>
+                <a:ea typeface="Calibri" pitchFamily="34" charset="-122"/>
+                <a:cs typeface="Calibri" pitchFamily="34" charset="-120"/>
+              </a:rPr>
+              <a:t>▲ +6</a:t>
             </a:r>
             <a:endParaRPr lang="en-US" sz="950" dirty="0"/>
           </a:p>
@@ -13637,7 +13637,7 @@
                 <a:ea typeface="Cambria" pitchFamily="34" charset="-122"/>
                 <a:cs typeface="Cambria" pitchFamily="34" charset="-120"/>
               </a:rPr>
-              <a:t>15</a:t>
+              <a:t>21</a:t>
             </a:r>
             <a:endParaRPr lang="en-US" sz="2200" dirty="0"/>
           </a:p>
@@ -13852,45 +13852,6 @@
         </p:nvSpPr>
         <p:spPr>
           <a:xfrm>
-            <a:off x="9509760" y="4315968"/>
-            <a:ext cx="914400" cy="566928"/>
-          </a:xfrm>
-          <a:prstGeom prst="rect">
-            <a:avLst/>
-          </a:prstGeom>
-          <a:noFill/>
-          <a:ln/>
-        </p:spPr>
-        <p:txBody>
-          <a:bodyPr wrap="square" lIns="0" tIns="0" rIns="0" bIns="0" rtlCol="0" anchor="ctr"/>
-          <a:lstStyle/>
-          <a:p>
-            <a:pPr algn="r" indent="0" marL="0">
-              <a:buNone/>
-            </a:pPr>
-            <a:r>
-              <a:rPr lang="en-US" sz="950" b="1" dirty="0">
-                <a:solidFill>
-                  <a:srgbClr val="C0392B"/>
-                </a:solidFill>
-                <a:latin typeface="Calibri" pitchFamily="34" charset="0"/>
-                <a:ea typeface="Calibri" pitchFamily="34" charset="-122"/>
-                <a:cs typeface="Calibri" pitchFamily="34" charset="-120"/>
-              </a:rPr>
-              <a:t>▲ +3</a:t>
-            </a:r>
-            <a:endParaRPr lang="en-US" sz="950" dirty="0"/>
-          </a:p>
-        </p:txBody>
-      </p:sp>
-      <p:sp>
-        <p:nvSpPr>
-          <p:cNvPr id="27" name="Text 23"/>
-          <p:cNvSpPr/>
-          <p:nvPr/>
-        </p:nvSpPr>
-        <p:spPr>
-          <a:xfrm>
             <a:off x="10469880" y="4315968"/>
             <a:ext cx="868680" cy="566928"/>
           </a:xfrm>
@@ -13924,7 +13885,7 @@
       </p:sp>
       <p:sp>
         <p:nvSpPr>
-          <p:cNvPr id="28" name="Shape 24"/>
+          <p:cNvPr id="27" name="Shape 23"/>
           <p:cNvSpPr/>
           <p:nvPr/>
         </p:nvSpPr>
@@ -13946,7 +13907,7 @@
       </p:sp>
       <p:sp>
         <p:nvSpPr>
-          <p:cNvPr id="29" name="Shape 25"/>
+          <p:cNvPr id="28" name="Shape 24"/>
           <p:cNvSpPr/>
           <p:nvPr/>
         </p:nvSpPr>
@@ -13966,7 +13927,7 @@
       </p:sp>
       <p:sp>
         <p:nvSpPr>
-          <p:cNvPr id="30" name="Text 26"/>
+          <p:cNvPr id="29" name="Text 25"/>
           <p:cNvSpPr/>
           <p:nvPr/>
         </p:nvSpPr>
@@ -14005,7 +13966,7 @@
       </p:sp>
       <p:sp>
         <p:nvSpPr>
-          <p:cNvPr id="31" name="Text 27"/>
+          <p:cNvPr id="30" name="Text 26"/>
           <p:cNvSpPr/>
           <p:nvPr/>
         </p:nvSpPr>
@@ -14044,7 +14005,7 @@
       </p:sp>
       <p:sp>
         <p:nvSpPr>
-          <p:cNvPr id="32" name="Text 28"/>
+          <p:cNvPr id="31" name="Text 27"/>
           <p:cNvSpPr/>
           <p:nvPr/>
         </p:nvSpPr>
@@ -14083,7 +14044,7 @@
       </p:sp>
       <p:sp>
         <p:nvSpPr>
-          <p:cNvPr id="33" name="Text 29"/>
+          <p:cNvPr id="32" name="Text 28"/>
           <p:cNvSpPr/>
           <p:nvPr/>
         </p:nvSpPr>
@@ -14114,7 +14075,7 @@
                 <a:ea typeface="Calibri" pitchFamily="34" charset="-122"/>
                 <a:cs typeface="Calibri" pitchFamily="34" charset="-120"/>
               </a:rPr>
-              <a:t>Fuente: Estatus_Resumen_General_QAQC.xlsx · Corte 01-10-2026 · Áreas 2000/3000/4000/8000</a:t>
+              <a:t>Fuente: Estatus_Resumen_General_QAQC.xlsx · Corte 13-10-2026 · Áreas 2000/3000/4000/8000</a:t>
             </a:r>
             <a:endParaRPr lang="en-US" sz="850" dirty="0"/>
           </a:p>
@@ -14122,7 +14083,7 @@
       </p:sp>
       <p:sp>
         <p:nvSpPr>
-          <p:cNvPr id="34" name="Text 30"/>
+          <p:cNvPr id="33" name="Text 29"/>
           <p:cNvSpPr/>
           <p:nvPr/>
         </p:nvSpPr>
@@ -14161,7 +14122,7 @@
       </p:sp>
       <p:sp>
         <p:nvSpPr>
-          <p:cNvPr id="35" name="Text 31"/>
+          <p:cNvPr id="34" name="Text 30"/>
           <p:cNvSpPr/>
           <p:nvPr/>
         </p:nvSpPr>
@@ -14365,7 +14326,7 @@
                 <a:ea typeface="Calibri" pitchFamily="34" charset="-122"/>
                 <a:cs typeface="Calibri" pitchFamily="34" charset="-120"/>
               </a:rPr>
-              <a:t>2.056 P1 levantados; 71,7% cerrados. El pendiente se concentra en Eléctrica, Piping, Instrumentación y Control, y físicamente en el área 3000.</a:t>
+              <a:t>2.094 P1 levantados; 76,9% cerrados. El pendiente se concentra en Eléctrica, Piping, Instrumentación y Control, y físicamente en el área 3000.</a:t>
             </a:r>
             <a:endParaRPr lang="en-US" sz="1350" dirty="0"/>
           </a:p>
@@ -14497,7 +14458,7 @@
                 <a:ea typeface="Cambria" pitchFamily="34" charset="-122"/>
                 <a:cs typeface="Cambria" pitchFamily="34" charset="-120"/>
               </a:rPr>
-              <a:t>71,7%</a:t>
+              <a:t>76,9%</a:t>
             </a:r>
             <a:endParaRPr lang="en-US" sz="1900" dirty="0"/>
           </a:p>
@@ -14612,7 +14573,7 @@
                 <a:ea typeface="Calibri" pitchFamily="34" charset="-122"/>
                 <a:cs typeface="Calibri" pitchFamily="34" charset="-120"/>
               </a:rPr>
-              <a:t>1.474</a:t>
+              <a:t>1.611</a:t>
             </a:r>
             <a:endParaRPr lang="en-US" sz="1100" dirty="0"/>
           </a:p>
@@ -14710,7 +14671,7 @@
                 <a:ea typeface="Calibri" pitchFamily="34" charset="-122"/>
                 <a:cs typeface="Calibri" pitchFamily="34" charset="-120"/>
               </a:rPr>
-              <a:t>582</a:t>
+              <a:t>483</a:t>
             </a:r>
             <a:endParaRPr lang="en-US" sz="1100" dirty="0"/>
           </a:p>
@@ -14891,7 +14852,7 @@
                 <a:ea typeface="Calibri" pitchFamily="34" charset="-122"/>
                 <a:cs typeface="Calibri" pitchFamily="34" charset="-120"/>
               </a:rPr>
-              <a:t>536 de 582 P1 abiertos (92,1%) están en el área 3000. Áreas 2000 sobre 90% de cierre.</a:t>
+              <a:t>440 de 483 P1 abiertos (91,1%) están en el área 3000. Áreas 2000 sobre 90% de cierre.</a:t>
             </a:r>
             <a:endParaRPr lang="en-US" sz="1150" dirty="0"/>
           </a:p>
@@ -14930,7 +14891,7 @@
                 <a:ea typeface="Calibri" pitchFamily="34" charset="-122"/>
                 <a:cs typeface="Calibri" pitchFamily="34" charset="-120"/>
               </a:rPr>
-              <a:t>Fuente: Estatus_Resumen_General_QAQC.xlsx · Corte 01-10-2026 · Áreas 2000/3000/4000/8000</a:t>
+              <a:t>Fuente: Estatus_Resumen_General_QAQC.xlsx · Corte 13-10-2026 · Áreas 2000/3000/4000/8000</a:t>
             </a:r>
             <a:endParaRPr lang="en-US" sz="850" dirty="0"/>
           </a:p>
@@ -15304,7 +15265,7 @@
                 <a:ea typeface="Calibri" pitchFamily="34" charset="-122"/>
                 <a:cs typeface="Calibri" pitchFamily="34" charset="-120"/>
               </a:rPr>
-              <a:t>0 aprobadas de 136. Priorizar el cierre de las 15 en revisión y el rearmado de las 24 rechazadas para convertir entregas en aprobaciones.</a:t>
+              <a:t>0 aprobadas de 136. Priorizar el cierre de las 21 en revisión y el rearmado de las 24 rechazadas para convertir entregas en aprobaciones.</a:t>
             </a:r>
             <a:endParaRPr lang="en-US" sz="1150" dirty="0"/>
           </a:p>
@@ -15446,7 +15407,7 @@
                 <a:ea typeface="Calibri" pitchFamily="34" charset="-122"/>
                 <a:cs typeface="Calibri" pitchFamily="34" charset="-120"/>
               </a:rPr>
-              <a:t>536 P1 abiertos (92,1% del total) y 27 caminatas 100% pendientes. Es la ruta crítica: sin esta área no mejora ningún indicador global.</a:t>
+              <a:t>440 P1 abiertos (91,1% del total) y 0 caminatas 100% pendientes. Es la ruta crítica: sin esta área no mejora ningún indicador global.</a:t>
             </a:r>
             <a:endParaRPr lang="en-US" sz="1150" dirty="0"/>
           </a:p>
@@ -15546,7 +15507,7 @@
                 <a:ea typeface="Calibri" pitchFamily="34" charset="-122"/>
                 <a:cs typeface="Calibri" pitchFamily="34" charset="-120"/>
               </a:rPr>
-              <a:t>Recuperar los 448 P1 vencidos</a:t>
+              <a:t>Recuperar los 325 P1 vencidos</a:t>
             </a:r>
             <a:endParaRPr lang="en-US" sz="1500" dirty="0"/>
           </a:p>
@@ -15588,7 +15549,7 @@
                 <a:ea typeface="Calibri" pitchFamily="34" charset="-122"/>
                 <a:cs typeface="Calibri" pitchFamily="34" charset="-120"/>
               </a:rPr>
-              <a:t>77% de los P1 abiertos superó su fecha de vencimiento. Foco en Eléctrica (132), Instrumentación y Control (129), Piping (124).</a:t>
+              <a:t>67,3% de los P1 abiertos superó su fecha de vencimiento. Foco en Eléctrica (106), Instrumentación y Control (97), Piping (81).</a:t>
             </a:r>
             <a:endParaRPr lang="en-US" sz="1150" dirty="0"/>
           </a:p>
@@ -15730,7 +15691,7 @@
                 <a:ea typeface="Calibri" pitchFamily="34" charset="-122"/>
                 <a:cs typeface="Calibri" pitchFamily="34" charset="-120"/>
               </a:rPr>
-              <a:t>29 subsistemas pendientes: 29 próximos a realizar y 0 por programar. La programación ya está hecha; falta ejecutarla para habilitar la entrega de carpetas.</a:t>
+              <a:t>0 subsistemas pendientes: 0 próximos a realizar y 0 por programar. La programación ya está hecha; falta ejecutarla para habilitar la entrega de carpetas.</a:t>
             </a:r>
             <a:endParaRPr lang="en-US" sz="1150" dirty="0"/>
           </a:p>
@@ -15769,7 +15730,7 @@
                 <a:ea typeface="Calibri" pitchFamily="34" charset="-122"/>
                 <a:cs typeface="Calibri" pitchFamily="34" charset="-120"/>
               </a:rPr>
-              <a:t>Fuente: Estatus_Resumen_General_QAQC.xlsx · Corte 01-10-2026 · Áreas 2000/3000/4000/8000</a:t>
+              <a:t>Fuente: Estatus_Resumen_General_QAQC.xlsx · Corte 13-10-2026 · Áreas 2000/3000/4000/8000</a:t>
             </a:r>
             <a:endParaRPr lang="en-US" sz="850" dirty="0"/>
           </a:p>

</xml_diff>

<commit_message>
Desaladora: reporte gerencial al 13-10-2026 con el punch del 11-10
Carpetas 68/95 entregadas y 51 aprobadas —venían 63 y 46—, con tarjeta verde en
52. La caminata 2 de Operable sube de 66/79 a 72/80: 90% del frente.

Se resolvió la discrepancia que arrastraba semanas: el archivo declaraba 80
exigibles y su propio detalle daba 79. Ahora declara 72/80 y el detalle da 72/80,
así que el contraste queda en OK.

Aparece un subsistema nuevo en el punch que el reporte todavía no lista,
0587-ECC-201 con 20 ítems, y un ítem con STATUS vacío que se cuenta como abierto.

133 comprobaciones OK · 0 fallan · 2 avisos.

Co-Authored-By: Claude Opus 5 <noreply@anthropic.com>
Claude-Session: https://claude.ai/code/session_011SHyPcub1TtjA2kTAsaPFu
</commit_message>
<xml_diff>
--- a/panel_control_TOP_P1/Panel_Control_TOP_P1.pptx
+++ b/panel_control_TOP_P1/Panel_Control_TOP_P1.pptx
@@ -233,7 +233,7 @@
                 <c:formatCode>General</c:formatCode>
                 <c:ptCount val="2"/>
                 <c:pt idx="0">
-                  <c:v>66</c:v>
+                  <c:v>72</c:v>
                 </c:pt>
                 <c:pt idx="1">
                   <c:v>12</c:v>
@@ -311,7 +311,7 @@
                 <c:formatCode>General</c:formatCode>
                 <c:ptCount val="2"/>
                 <c:pt idx="0">
-                  <c:v>13</c:v>
+                  <c:v>8</c:v>
                 </c:pt>
                 <c:pt idx="1">
                   <c:v>3</c:v>
@@ -6907,7 +6907,7 @@
                 <a:ea typeface="Cambria" pitchFamily="34" charset="-122"/>
                 <a:cs typeface="Cambria" pitchFamily="34" charset="-120"/>
               </a:rPr>
-              <a:t>83,5%</a:t>
+              <a:t>90%</a:t>
             </a:r>
             <a:endParaRPr lang="en-US" sz="3400" dirty="0"/>
           </a:p>
@@ -7063,7 +7063,7 @@
                 <a:ea typeface="Cambria" pitchFamily="34" charset="-122"/>
                 <a:cs typeface="Cambria" pitchFamily="34" charset="-120"/>
               </a:rPr>
-              <a:t>66,3%</a:t>
+              <a:t>71,6%</a:t>
             </a:r>
             <a:endParaRPr lang="en-US" sz="3400" dirty="0"/>
           </a:p>
@@ -7219,7 +7219,7 @@
                 <a:ea typeface="Calibri" pitchFamily="34" charset="-122"/>
                 <a:cs typeface="Calibri" pitchFamily="34" charset="-120"/>
               </a:rPr>
-              <a:t>Corte: 29-09-2026</a:t>
+              <a:t>Corte: 13-10-2026</a:t>
             </a:r>
             <a:endParaRPr lang="en-US" sz="1100" dirty="0"/>
           </a:p>
@@ -7258,7 +7258,7 @@
                 <a:ea typeface="Calibri" pitchFamily="34" charset="-122"/>
                 <a:cs typeface="Calibri" pitchFamily="34" charset="-120"/>
               </a:rPr>
-              <a:t>Fuente: REPORTE_GERENCIAL + Listado de Puntos Punch Consolidado · Corte 29-09-2026 · Atrasos al 12-10-2026</a:t>
+              <a:t>Fuente: REPORTE_GERENCIAL + Listado de Puntos Punch Consolidado · Corte 13-10-2026 · Atrasos al 12-10-2026</a:t>
             </a:r>
             <a:endParaRPr lang="en-US" sz="850" dirty="0"/>
           </a:p>
@@ -16035,7 +16035,7 @@
                 <a:ea typeface="Cambria" pitchFamily="34" charset="-122"/>
                 <a:cs typeface="Cambria" pitchFamily="34" charset="-120"/>
               </a:rPr>
-              <a:t>83,5%</a:t>
+              <a:t>90%</a:t>
             </a:r>
             <a:endParaRPr lang="en-US" sz="3800" dirty="0"/>
           </a:p>
@@ -16074,7 +16074,7 @@
                 <a:ea typeface="Calibri" pitchFamily="34" charset="-122"/>
                 <a:cs typeface="Calibri" pitchFamily="34" charset="-120"/>
               </a:rPr>
-              <a:t>66/79</a:t>
+              <a:t>72/80</a:t>
             </a:r>
             <a:endParaRPr lang="en-US" sz="1400" dirty="0"/>
           </a:p>
@@ -16155,7 +16155,7 @@
                 <a:ea typeface="Calibri" pitchFamily="34" charset="-122"/>
                 <a:cs typeface="Calibri" pitchFamily="34" charset="-120"/>
               </a:rPr>
-              <a:t>13 subsistemas por caminar</a:t>
+              <a:t>8 subsistemas por caminar</a:t>
             </a:r>
             <a:endParaRPr lang="en-US" sz="950" dirty="0"/>
           </a:p>
@@ -16461,7 +16461,7 @@
                 <a:ea typeface="Cambria" pitchFamily="34" charset="-122"/>
                 <a:cs typeface="Cambria" pitchFamily="34" charset="-120"/>
               </a:rPr>
-              <a:t>66,3%</a:t>
+              <a:t>71,6%</a:t>
             </a:r>
             <a:endParaRPr lang="en-US" sz="3800" dirty="0"/>
           </a:p>
@@ -16500,7 +16500,7 @@
                 <a:ea typeface="Calibri" pitchFamily="34" charset="-122"/>
                 <a:cs typeface="Calibri" pitchFamily="34" charset="-120"/>
               </a:rPr>
-              <a:t>63/95</a:t>
+              <a:t>68/95</a:t>
             </a:r>
             <a:endParaRPr lang="en-US" sz="1400" dirty="0"/>
           </a:p>
@@ -16581,7 +16581,7 @@
                 <a:ea typeface="Calibri" pitchFamily="34" charset="-122"/>
                 <a:cs typeface="Calibri" pitchFamily="34" charset="-120"/>
               </a:rPr>
-              <a:t>46 aprobadas · 11 en revisión · 6 rechazadas</a:t>
+              <a:t>51 aprobadas · 10 en revisión · 7 rechazadas</a:t>
             </a:r>
             <a:endParaRPr lang="en-US" sz="950" dirty="0"/>
           </a:p>
@@ -17013,7 +17013,7 @@
                 <a:ea typeface="Calibri" pitchFamily="34" charset="-122"/>
                 <a:cs typeface="Calibri" pitchFamily="34" charset="-120"/>
               </a:rPr>
-              <a:t>Operables 66/79 por Caminata 2 (83,5%); Facility 12/15 por Caminata 1 (80%).</a:t>
+              <a:t>Operables 72/80 por Caminata 2 (90%); Facility 12/15 por Caminata 1 (80%).</a:t>
             </a:r>
             <a:endParaRPr lang="en-US" sz="1150" dirty="0"/>
           </a:p>
@@ -17075,7 +17075,7 @@
                 <a:ea typeface="Calibri" pitchFamily="34" charset="-122"/>
                 <a:cs typeface="Calibri" pitchFamily="34" charset="-120"/>
               </a:rPr>
-              <a:t>Las carpetas están a 66,3% de entrega y el cuello está en el armado interno.  </a:t>
+              <a:t>Las carpetas están a 71,6% de entrega y el cuello está en el armado interno.  </a:t>
             </a:r>
             <a:pPr indent="0" marL="0">
               <a:lnSpc>
@@ -17092,7 +17092,7 @@
                 <a:ea typeface="Calibri" pitchFamily="34" charset="-122"/>
                 <a:cs typeface="Calibri" pitchFamily="34" charset="-120"/>
               </a:rPr>
-              <a:t>63 entregadas de 95: 46 aprobadas, 11 en revisión y 6 rechazadas. Quedan 15 en preparación y 17 sin iniciar.</a:t>
+              <a:t>68 entregadas de 95: 51 aprobadas, 10 en revisión y 7 rechazadas. Quedan 16 en preparación y 11 sin iniciar.</a:t>
             </a:r>
             <a:endParaRPr lang="en-US" sz="1150" dirty="0"/>
           </a:p>
@@ -17210,7 +17210,7 @@
                 <a:ea typeface="Calibri" pitchFamily="34" charset="-122"/>
                 <a:cs typeface="Calibri" pitchFamily="34" charset="-120"/>
               </a:rPr>
-              <a:t>Fuente: REPORTE_GERENCIAL + Listado de Puntos Punch Consolidado · Corte 29-09-2026 · Atrasos al 12-10-2026</a:t>
+              <a:t>Fuente: REPORTE_GERENCIAL + Listado de Puntos Punch Consolidado · Corte 13-10-2026 · Atrasos al 12-10-2026</a:t>
             </a:r>
             <a:endParaRPr lang="en-US" sz="850" dirty="0"/>
           </a:p>
@@ -17663,7 +17663,7 @@
                 <a:ea typeface="Calibri" pitchFamily="34" charset="-122"/>
                 <a:cs typeface="Calibri" pitchFamily="34" charset="-120"/>
               </a:rPr>
-              <a:t>48,4%</a:t>
+              <a:t>53,7%</a:t>
             </a:r>
             <a:endParaRPr lang="en-US" sz="1100" dirty="0"/>
           </a:p>
@@ -17702,7 +17702,7 @@
                 <a:ea typeface="Cambria" pitchFamily="34" charset="-122"/>
                 <a:cs typeface="Cambria" pitchFamily="34" charset="-120"/>
               </a:rPr>
-              <a:t>46</a:t>
+              <a:t>51</a:t>
             </a:r>
             <a:endParaRPr lang="en-US" sz="2200" dirty="0"/>
           </a:p>
@@ -17822,7 +17822,7 @@
                 <a:ea typeface="Calibri" pitchFamily="34" charset="-122"/>
                 <a:cs typeface="Calibri" pitchFamily="34" charset="-120"/>
               </a:rPr>
-              <a:t>11,6%</a:t>
+              <a:t>10,5%</a:t>
             </a:r>
             <a:endParaRPr lang="en-US" sz="1100" dirty="0"/>
           </a:p>
@@ -17861,7 +17861,7 @@
                 <a:ea typeface="Cambria" pitchFamily="34" charset="-122"/>
                 <a:cs typeface="Cambria" pitchFamily="34" charset="-120"/>
               </a:rPr>
-              <a:t>11</a:t>
+              <a:t>10</a:t>
             </a:r>
             <a:endParaRPr lang="en-US" sz="2200" dirty="0"/>
           </a:p>
@@ -17981,7 +17981,7 @@
                 <a:ea typeface="Calibri" pitchFamily="34" charset="-122"/>
                 <a:cs typeface="Calibri" pitchFamily="34" charset="-120"/>
               </a:rPr>
-              <a:t>6,3%</a:t>
+              <a:t>7,4%</a:t>
             </a:r>
             <a:endParaRPr lang="en-US" sz="1100" dirty="0"/>
           </a:p>
@@ -18020,7 +18020,7 @@
                 <a:ea typeface="Cambria" pitchFamily="34" charset="-122"/>
                 <a:cs typeface="Cambria" pitchFamily="34" charset="-120"/>
               </a:rPr>
-              <a:t>6</a:t>
+              <a:t>7</a:t>
             </a:r>
             <a:endParaRPr lang="en-US" sz="2200" dirty="0"/>
           </a:p>
@@ -18140,7 +18140,7 @@
                 <a:ea typeface="Calibri" pitchFamily="34" charset="-122"/>
                 <a:cs typeface="Calibri" pitchFamily="34" charset="-120"/>
               </a:rPr>
-              <a:t>15,8%</a:t>
+              <a:t>16,8%</a:t>
             </a:r>
             <a:endParaRPr lang="en-US" sz="1100" dirty="0"/>
           </a:p>
@@ -18179,7 +18179,7 @@
                 <a:ea typeface="Cambria" pitchFamily="34" charset="-122"/>
                 <a:cs typeface="Cambria" pitchFamily="34" charset="-120"/>
               </a:rPr>
-              <a:t>15</a:t>
+              <a:t>16</a:t>
             </a:r>
             <a:endParaRPr lang="en-US" sz="2200" dirty="0"/>
           </a:p>
@@ -18299,7 +18299,7 @@
                 <a:ea typeface="Calibri" pitchFamily="34" charset="-122"/>
                 <a:cs typeface="Calibri" pitchFamily="34" charset="-120"/>
               </a:rPr>
-              <a:t>17,9%</a:t>
+              <a:t>11,6%</a:t>
             </a:r>
             <a:endParaRPr lang="en-US" sz="1100" dirty="0"/>
           </a:p>
@@ -18338,7 +18338,7 @@
                 <a:ea typeface="Cambria" pitchFamily="34" charset="-122"/>
                 <a:cs typeface="Cambria" pitchFamily="34" charset="-120"/>
               </a:rPr>
-              <a:t>17</a:t>
+              <a:t>11</a:t>
             </a:r>
             <a:endParaRPr lang="en-US" sz="2200" dirty="0"/>
           </a:p>
@@ -18380,7 +18380,7 @@
                 <a:ea typeface="Calibri" pitchFamily="34" charset="-122"/>
                 <a:cs typeface="Calibri" pitchFamily="34" charset="-120"/>
               </a:rPr>
-              <a:t>63 carpetas ya están en manos del cliente (66,3%) y 46 subsistemas tienen tarjeta verde. El grueso del pendiente todavía no sale de Besalco.</a:t>
+              <a:t>68 carpetas ya están en manos del cliente (71,6%) y 52 subsistemas tienen tarjeta verde. El grueso del pendiente todavía no sale de Besalco.</a:t>
             </a:r>
             <a:endParaRPr lang="en-US" sz="1000" dirty="0"/>
           </a:p>
@@ -18419,7 +18419,7 @@
                 <a:ea typeface="Calibri" pitchFamily="34" charset="-122"/>
                 <a:cs typeface="Calibri" pitchFamily="34" charset="-120"/>
               </a:rPr>
-              <a:t>Fuente: REPORTE_GERENCIAL + Listado de Puntos Punch Consolidado · Corte 29-09-2026 · Atrasos al 12-10-2026</a:t>
+              <a:t>Fuente: REPORTE_GERENCIAL + Listado de Puntos Punch Consolidado · Corte 13-10-2026 · Atrasos al 12-10-2026</a:t>
             </a:r>
             <a:endParaRPr lang="en-US" sz="850" dirty="0"/>
           </a:p>
@@ -19235,7 +19235,7 @@
                 <a:ea typeface="Calibri" pitchFamily="34" charset="-122"/>
                 <a:cs typeface="Calibri" pitchFamily="34" charset="-120"/>
               </a:rPr>
-              <a:t>Fuente: REPORTE_GERENCIAL + Listado de Puntos Punch Consolidado · Corte 29-09-2026 · Atrasos al 12-10-2026</a:t>
+              <a:t>Fuente: REPORTE_GERENCIAL + Listado de Puntos Punch Consolidado · Corte 13-10-2026 · Atrasos al 12-10-2026</a:t>
             </a:r>
             <a:endParaRPr lang="en-US" sz="850" dirty="0"/>
           </a:p>
@@ -19709,7 +19709,7 @@
                 <a:ea typeface="Calibri" pitchFamily="34" charset="-122"/>
                 <a:cs typeface="Calibri" pitchFamily="34" charset="-120"/>
               </a:rPr>
-              <a:t>Ejecutar las 13 caminatas de Operables pendientes</a:t>
+              <a:t>Ejecutar las 8 caminatas de Operables pendientes</a:t>
             </a:r>
             <a:endParaRPr lang="en-US" sz="1400" dirty="0"/>
           </a:p>
@@ -19751,7 +19751,7 @@
                 <a:ea typeface="Calibri" pitchFamily="34" charset="-122"/>
                 <a:cs typeface="Calibri" pitchFamily="34" charset="-120"/>
               </a:rPr>
-              <a:t>La Caminata 2 va en 83,5% (66/79). Sin caminata no se levanta el punch final ni se habilita la entrega de la carpeta.</a:t>
+              <a:t>La Caminata 2 va en 90% (72/80). Sin caminata no se levanta el punch final ni se habilita la entrega de la carpeta.</a:t>
             </a:r>
             <a:endParaRPr lang="en-US" sz="1100" dirty="0"/>
           </a:p>
@@ -19851,7 +19851,7 @@
                 <a:ea typeface="Calibri" pitchFamily="34" charset="-122"/>
                 <a:cs typeface="Calibri" pitchFamily="34" charset="-120"/>
               </a:rPr>
-              <a:t>Sacar del armado interno las 32 carpetas retenidas</a:t>
+              <a:t>Sacar del armado interno las 27 carpetas retenidas</a:t>
             </a:r>
             <a:endParaRPr lang="en-US" sz="1400" dirty="0"/>
           </a:p>
@@ -19893,7 +19893,7 @@
                 <a:ea typeface="Calibri" pitchFamily="34" charset="-122"/>
                 <a:cs typeface="Calibri" pitchFamily="34" charset="-120"/>
               </a:rPr>
-              <a:t>15 están en preparación y 17 sin iniciar. Solo 63 de 95 (66,3%) llegaron al cliente; 6 volvieron rechazadas y hay que rearmarlas.</a:t>
+              <a:t>16 están en preparación y 11 sin iniciar. Solo 68 de 95 (71,6%) llegaron al cliente; 7 volvieron rechazadas y hay que rearmarlas.</a:t>
             </a:r>
             <a:endParaRPr lang="en-US" sz="1100" dirty="0"/>
           </a:p>
@@ -20074,7 +20074,7 @@
                 <a:ea typeface="Calibri" pitchFamily="34" charset="-122"/>
                 <a:cs typeface="Calibri" pitchFamily="34" charset="-120"/>
               </a:rPr>
-              <a:t>Fuente: REPORTE_GERENCIAL + Listado de Puntos Punch Consolidado · Corte 29-09-2026 · Atrasos al 12-10-2026</a:t>
+              <a:t>Fuente: REPORTE_GERENCIAL + Listado de Puntos Punch Consolidado · Corte 13-10-2026 · Atrasos al 12-10-2026</a:t>
             </a:r>
             <a:endParaRPr lang="en-US" sz="850" dirty="0"/>
           </a:p>

</xml_diff>

<commit_message>
Cierre QAQC: Arqueros y Desaladora al 26-10-2026
Arqueros: P1 cerrados 1.914 → 2.039, abiertos 268 → 143 y vencidos 146 → 86. El
cierre sube de 87,7% a 93,4%. Entregó 3 carpetas TOP más (46 → 49) y las tres
están en revisión: siguen 0 aprobadas de 136 y las rechazadas quedan en 30.

Desaladora: reporte gerencial 20-10 con punch del 25-10. Punch 2.748 ítems, 80,4%
cerrado, P1 82,0%. El atraso baja de 385 a 370, segunda semana en descenso.
Carpetas 71/95 entregadas y 56 aprobadas, con tarjeta verde en 56.

Talabre queda en su corte del 19-10: llegó su registro de DT pero no el archivo
de STATUS, que talabre.py exige porque de ahí salen subsistemas, caminatas y
avance PEC. La auditoría lo declara —el registro de la carpeta trae 1.962 cierres
contra los 1.943 cargados— y se resolverá al llegar el archivo.

132 comprobaciones OK · 1 falla declarada · 2 avisos.

Co-Authored-By: Claude Opus 5 <noreply@anthropic.com>
Claude-Session: https://claude.ai/code/session_011SHyPcub1TtjA2kTAsaPFu
</commit_message>
<xml_diff>
--- a/panel_control_TOP_P1/Panel_Control_TOP_P1.pptx
+++ b/panel_control_TOP_P1/Panel_Control_TOP_P1.pptx
@@ -687,10 +687,10 @@
               <c:numCache>
                 <c:ptCount val="3"/>
                 <c:pt idx="0">
-                  <c:v>1914</c:v>
+                  <c:v>2039</c:v>
                 </c:pt>
                 <c:pt idx="1">
-                  <c:v>268</c:v>
+                  <c:v>143</c:v>
                 </c:pt>
                 <c:pt idx="2">
                   <c:v>0</c:v>
@@ -850,22 +850,22 @@
                 <c:formatCode>General</c:formatCode>
                 <c:ptCount val="6"/>
                 <c:pt idx="0">
-                  <c:v>104</c:v>
+                  <c:v>103</c:v>
                 </c:pt>
                 <c:pt idx="1">
                   <c:v>70</c:v>
                 </c:pt>
                 <c:pt idx="2">
-                  <c:v>19</c:v>
+                  <c:v>13</c:v>
                 </c:pt>
                 <c:pt idx="3">
-                  <c:v>15</c:v>
+                  <c:v>14</c:v>
                 </c:pt>
                 <c:pt idx="4">
                   <c:v>6</c:v>
                 </c:pt>
                 <c:pt idx="5">
-                  <c:v>8</c:v>
+                  <c:v>6</c:v>
                 </c:pt>
               </c:numCache>
             </c:numRef>
@@ -952,16 +952,16 @@
                 <c:formatCode>General</c:formatCode>
                 <c:ptCount val="6"/>
                 <c:pt idx="0">
-                  <c:v>70</c:v>
+                  <c:v>66</c:v>
                 </c:pt>
                 <c:pt idx="1">
-                  <c:v>33</c:v>
+                  <c:v>10</c:v>
                 </c:pt>
                 <c:pt idx="2">
-                  <c:v>20</c:v>
+                  <c:v>18</c:v>
                 </c:pt>
                 <c:pt idx="3">
-                  <c:v>3</c:v>
+                  <c:v>2</c:v>
                 </c:pt>
                 <c:pt idx="4">
                   <c:v>3</c:v>
@@ -1340,13 +1340,13 @@
               <c:numCache>
                 <c:ptCount val="3"/>
                 <c:pt idx="0">
-                  <c:v>1341</c:v>
+                  <c:v>1412</c:v>
                 </c:pt>
                 <c:pt idx="1">
-                  <c:v>222</c:v>
+                  <c:v>212</c:v>
                 </c:pt>
                 <c:pt idx="2">
-                  <c:v>129</c:v>
+                  <c:v>99</c:v>
                 </c:pt>
               </c:numCache>
             </c:numRef>
@@ -3597,7 +3597,7 @@
                   <c:v/>
                 </c:pt>
                 <c:pt idx="2">
-                  <c:v>5</c:v>
+                  <c:v>8</c:v>
                 </c:pt>
                 <c:pt idx="3">
                   <c:v/>
@@ -3867,7 +3867,7 @@
                   <c:v>69</c:v>
                 </c:pt>
                 <c:pt idx="2">
-                  <c:v>15</c:v>
+                  <c:v>12</c:v>
                 </c:pt>
                 <c:pt idx="3">
                   <c:v>2</c:v>
@@ -4136,10 +4136,10 @@
                     <c:v>Piping</c:v>
                   </c:pt>
                   <c:pt idx="3">
-                    <c:v>Mecánica</c:v>
+                    <c:v>Estructura</c:v>
                   </c:pt>
                   <c:pt idx="4">
-                    <c:v>Estructura</c:v>
+                    <c:v>Mecánica</c:v>
                   </c:pt>
                   <c:pt idx="5">
                     <c:v>Obras Civiles</c:v>
@@ -4155,19 +4155,19 @@
                 <c:formatCode>General</c:formatCode>
                 <c:ptCount val="6"/>
                 <c:pt idx="0">
-                  <c:v>64</c:v>
+                  <c:v>39</c:v>
                 </c:pt>
                 <c:pt idx="1">
-                  <c:v>54</c:v>
+                  <c:v>33</c:v>
                 </c:pt>
                 <c:pt idx="2">
-                  <c:v>26</c:v>
+                  <c:v>10</c:v>
                 </c:pt>
                 <c:pt idx="3">
                   <c:v>2</c:v>
                 </c:pt>
                 <c:pt idx="4">
-                  <c:v/>
+                  <c:v>2</c:v>
                 </c:pt>
                 <c:pt idx="5">
                   <c:v/>
@@ -4238,10 +4238,10 @@
                     <c:v>Piping</c:v>
                   </c:pt>
                   <c:pt idx="3">
-                    <c:v>Mecánica</c:v>
+                    <c:v>Estructura</c:v>
                   </c:pt>
                   <c:pt idx="4">
-                    <c:v>Estructura</c:v>
+                    <c:v>Mecánica</c:v>
                   </c:pt>
                   <c:pt idx="5">
                     <c:v>Obras Civiles</c:v>
@@ -4257,19 +4257,19 @@
                 <c:formatCode>General</c:formatCode>
                 <c:ptCount val="6"/>
                 <c:pt idx="0">
-                  <c:v>36</c:v>
+                  <c:v>27</c:v>
                 </c:pt>
                 <c:pt idx="1">
-                  <c:v>44</c:v>
+                  <c:v>16</c:v>
                 </c:pt>
                 <c:pt idx="2">
-                  <c:v>28</c:v>
+                  <c:v>6</c:v>
                 </c:pt>
                 <c:pt idx="3">
-                  <c:v>5</c:v>
+                  <c:v>4</c:v>
                 </c:pt>
                 <c:pt idx="4">
-                  <c:v>6</c:v>
+                  <c:v>1</c:v>
                 </c:pt>
                 <c:pt idx="5">
                   <c:v>3</c:v>
@@ -6613,7 +6613,7 @@
       </p:grpSpPr>
       <p:pic>
         <p:nvPicPr>
-          <p:cNvPr id="2" name="Image 0" descr="/workspace/dashboard-hseq/panel_control_TOP_P1/besalco_logo.png">    </p:cNvPr>
+          <p:cNvPr id="2" name="Image 0" descr="/home/user/dashboard-hseq/panel_control_TOP_P1/besalco_logo.png">    </p:cNvPr>
           <p:cNvPicPr>
             <a:picLocks noChangeAspect="1"/>
           </p:cNvPicPr>
@@ -7063,7 +7063,7 @@
                 <a:ea typeface="Cambria" pitchFamily="34" charset="-122"/>
                 <a:cs typeface="Cambria" pitchFamily="34" charset="-120"/>
               </a:rPr>
-              <a:t>71,6%</a:t>
+              <a:t>74,7%</a:t>
             </a:r>
             <a:endParaRPr lang="en-US" sz="3400" dirty="0"/>
           </a:p>
@@ -7141,7 +7141,7 @@
                 <a:ea typeface="Cambria" pitchFamily="34" charset="-122"/>
                 <a:cs typeface="Cambria" pitchFamily="34" charset="-120"/>
               </a:rPr>
-              <a:t>79,3%</a:t>
+              <a:t>82%</a:t>
             </a:r>
             <a:endParaRPr lang="en-US" sz="3400" dirty="0"/>
           </a:p>
@@ -7219,7 +7219,7 @@
                 <a:ea typeface="Calibri" pitchFamily="34" charset="-122"/>
                 <a:cs typeface="Calibri" pitchFamily="34" charset="-120"/>
               </a:rPr>
-              <a:t>Corte: 13-10-2026</a:t>
+              <a:t>Corte: 20-10-2026</a:t>
             </a:r>
             <a:endParaRPr lang="en-US" sz="1100" dirty="0"/>
           </a:p>
@@ -7258,7 +7258,7 @@
                 <a:ea typeface="Calibri" pitchFamily="34" charset="-122"/>
                 <a:cs typeface="Calibri" pitchFamily="34" charset="-120"/>
               </a:rPr>
-              <a:t>Fuente: REPORTE_GERENCIAL + Listado de Puntos Punch Consolidado · Corte 13-10-2026 · Atrasos al 19-10-2026</a:t>
+              <a:t>Fuente: REPORTE_GERENCIAL + Listado de Puntos Punch Consolidado · Corte 20-10-2026 · Atrasos al 26-10-2026</a:t>
             </a:r>
             <a:endParaRPr lang="en-US" sz="850" dirty="0"/>
           </a:p>
@@ -7337,7 +7337,7 @@
       </p:grpSpPr>
       <p:pic>
         <p:nvPicPr>
-          <p:cNvPr id="2" name="Image 0" descr="/workspace/dashboard-hseq/panel_control_TOP_P1/besalco_logo.png">    </p:cNvPr>
+          <p:cNvPr id="2" name="Image 0" descr="/home/user/dashboard-hseq/panel_control_TOP_P1/besalco_logo.png">    </p:cNvPr>
           <p:cNvPicPr>
             <a:picLocks noChangeAspect="1"/>
           </p:cNvPicPr>
@@ -8216,7 +8216,7 @@
       </p:sp>
       <p:pic>
         <p:nvPicPr>
-          <p:cNvPr id="4" name="Image 0" descr="/workspace/dashboard-hseq/panel_control_TOP_P1/besalco_logo.png">    </p:cNvPr>
+          <p:cNvPr id="4" name="Image 0" descr="/home/user/dashboard-hseq/panel_control_TOP_P1/besalco_logo.png">    </p:cNvPr>
           <p:cNvPicPr>
             <a:picLocks noChangeAspect="1"/>
           </p:cNvPicPr>
@@ -8626,7 +8626,7 @@
                 <a:ea typeface="Cambria" pitchFamily="34" charset="-122"/>
                 <a:cs typeface="Cambria" pitchFamily="34" charset="-120"/>
               </a:rPr>
-              <a:t>33,8%</a:t>
+              <a:t>36%</a:t>
             </a:r>
             <a:endParaRPr lang="en-US" sz="3400" dirty="0"/>
           </a:p>
@@ -8704,7 +8704,7 @@
                 <a:ea typeface="Cambria" pitchFamily="34" charset="-122"/>
                 <a:cs typeface="Cambria" pitchFamily="34" charset="-120"/>
               </a:rPr>
-              <a:t>87,7%</a:t>
+              <a:t>93,4%</a:t>
             </a:r>
             <a:endParaRPr lang="en-US" sz="3400" dirty="0"/>
           </a:p>
@@ -8782,7 +8782,7 @@
                 <a:ea typeface="Calibri" pitchFamily="34" charset="-122"/>
                 <a:cs typeface="Calibri" pitchFamily="34" charset="-120"/>
               </a:rPr>
-              <a:t>Corte: 19-10-2026   ·   Corte anterior: 13-10-2026</a:t>
+              <a:t>Corte: 26-10-2026   ·   Corte anterior: 19-10-2026</a:t>
             </a:r>
             <a:endParaRPr lang="en-US" sz="1100" dirty="0"/>
           </a:p>
@@ -8821,7 +8821,7 @@
                 <a:ea typeface="Calibri" pitchFamily="34" charset="-122"/>
                 <a:cs typeface="Calibri" pitchFamily="34" charset="-120"/>
               </a:rPr>
-              <a:t>Fuente: Estatus_Resumen_General_QAQC.xlsx · Corte 19-10-2026 · Áreas 2000/3000/4000/8000</a:t>
+              <a:t>Fuente: Estatus_Resumen_General_QAQC.xlsx · Corte 26-10-2026 · Áreas 2000/3000/4000/8000</a:t>
             </a:r>
             <a:endParaRPr lang="en-US" sz="850" dirty="0"/>
           </a:p>
@@ -8900,7 +8900,7 @@
       </p:grpSpPr>
       <p:pic>
         <p:nvPicPr>
-          <p:cNvPr id="2" name="Image 0" descr="/workspace/dashboard-hseq/panel_control_TOP_P1/besalco_logo.png">    </p:cNvPr>
+          <p:cNvPr id="2" name="Image 0" descr="/home/user/dashboard-hseq/panel_control_TOP_P1/besalco_logo.png">    </p:cNvPr>
           <p:cNvPicPr>
             <a:picLocks noChangeAspect="1"/>
           </p:cNvPicPr>
@@ -9546,7 +9546,7 @@
                 <a:ea typeface="Cambria" pitchFamily="34" charset="-122"/>
                 <a:cs typeface="Cambria" pitchFamily="34" charset="-120"/>
               </a:rPr>
-              <a:t>33,8%</a:t>
+              <a:t>36%</a:t>
             </a:r>
             <a:endParaRPr lang="en-US" sz="4000" dirty="0"/>
           </a:p>
@@ -9585,7 +9585,7 @@
                 <a:ea typeface="Calibri" pitchFamily="34" charset="-122"/>
                 <a:cs typeface="Calibri" pitchFamily="34" charset="-120"/>
               </a:rPr>
-              <a:t>46/136</a:t>
+              <a:t>49/136</a:t>
             </a:r>
             <a:endParaRPr lang="en-US" sz="1400" dirty="0"/>
           </a:p>
@@ -9663,7 +9663,7 @@
                 <a:ea typeface="Calibri" pitchFamily="34" charset="-122"/>
                 <a:cs typeface="Calibri" pitchFamily="34" charset="-120"/>
               </a:rPr>
-              <a:t>0 aprobadas · 30 rechazadas · 15 en revisión · 1 observadas</a:t>
+              <a:t>0 aprobadas · 30 rechazadas · 18 en revisión · 1 observadas</a:t>
             </a:r>
             <a:endParaRPr lang="en-US" sz="950" dirty="0"/>
           </a:p>
@@ -9696,13 +9696,13 @@
             <a:r>
               <a:rPr lang="en-US" sz="900" b="1" dirty="0">
                 <a:solidFill>
-                  <a:srgbClr val="56606E"/>
-                </a:solidFill>
-                <a:latin typeface="Calibri" pitchFamily="34" charset="0"/>
-                <a:ea typeface="Calibri" pitchFamily="34" charset="-122"/>
-                <a:cs typeface="Calibri" pitchFamily="34" charset="-120"/>
-              </a:rPr>
-              <a:t>= sin cambio vs. corte anterior</a:t>
+                  <a:srgbClr val="1F7A44"/>
+                </a:solidFill>
+                <a:latin typeface="Calibri" pitchFamily="34" charset="0"/>
+                <a:ea typeface="Calibri" pitchFamily="34" charset="-122"/>
+                <a:cs typeface="Calibri" pitchFamily="34" charset="-120"/>
+              </a:rPr>
+              <a:t>▲ +3 vs. corte anterior</a:t>
             </a:r>
             <a:endParaRPr lang="en-US" sz="900" dirty="0"/>
           </a:p>
@@ -9795,7 +9795,7 @@
                 <a:ea typeface="Cambria" pitchFamily="34" charset="-122"/>
                 <a:cs typeface="Cambria" pitchFamily="34" charset="-120"/>
               </a:rPr>
-              <a:t>87,7%</a:t>
+              <a:t>93,4%</a:t>
             </a:r>
             <a:endParaRPr lang="en-US" sz="4000" dirty="0"/>
           </a:p>
@@ -9834,7 +9834,7 @@
                 <a:ea typeface="Calibri" pitchFamily="34" charset="-122"/>
                 <a:cs typeface="Calibri" pitchFamily="34" charset="-120"/>
               </a:rPr>
-              <a:t>1.914/2.182</a:t>
+              <a:t>2.039/2.182</a:t>
             </a:r>
             <a:endParaRPr lang="en-US" sz="1400" dirty="0"/>
           </a:p>
@@ -9912,7 +9912,7 @@
                 <a:ea typeface="Calibri" pitchFamily="34" charset="-122"/>
                 <a:cs typeface="Calibri" pitchFamily="34" charset="-120"/>
               </a:rPr>
-              <a:t>268 abiertos · 146 vencidos</a:t>
+              <a:t>143 abiertos · 86 vencidos</a:t>
             </a:r>
             <a:endParaRPr lang="en-US" sz="950" dirty="0"/>
           </a:p>
@@ -9951,7 +9951,7 @@
                 <a:ea typeface="Calibri" pitchFamily="34" charset="-122"/>
                 <a:cs typeface="Calibri" pitchFamily="34" charset="-120"/>
               </a:rPr>
-              <a:t>▲ +303 vs. corte anterior</a:t>
+              <a:t>▲ +125 vs. corte anterior</a:t>
             </a:r>
             <a:endParaRPr lang="en-US" sz="900" dirty="0"/>
           </a:p>
@@ -10153,7 +10153,7 @@
                 <a:ea typeface="Calibri" pitchFamily="34" charset="-122"/>
                 <a:cs typeface="Calibri" pitchFamily="34" charset="-120"/>
               </a:rPr>
-              <a:t>Las carpetas TOP siguen sin aprobaciones y suben los rechazos.  </a:t>
+              <a:t>Las carpetas TOP siguen sin aprobaciones.  </a:t>
             </a:r>
             <a:pPr indent="0" marL="0">
               <a:lnSpc>
@@ -10170,7 +10170,7 @@
                 <a:ea typeface="Calibri" pitchFamily="34" charset="-122"/>
                 <a:cs typeface="Calibri" pitchFamily="34" charset="-120"/>
               </a:rPr>
-              <a:t>46 entregadas de 136 (33,8%) y 0 aprobadas; las rechazadas pasaron de 24 a 30.</a:t>
+              <a:t>49 entregadas de 136 (36%) y 0 aprobadas; 30 rechazadas.</a:t>
             </a:r>
             <a:endParaRPr lang="en-US" sz="1250" dirty="0"/>
           </a:p>
@@ -10249,7 +10249,7 @@
                 <a:ea typeface="Calibri" pitchFamily="34" charset="-122"/>
                 <a:cs typeface="Calibri" pitchFamily="34" charset="-120"/>
               </a:rPr>
-              <a:t>+303 P1 cerrado desde el corte anterior; 268 abiertos, de los cuales 146 superaron su fecha de vencimiento. El área 3000 concentra 260 (97%).</a:t>
+              <a:t>+125 P1 cerrado desde el corte anterior; 143 abiertos, de los cuales 86 superaron su fecha de vencimiento. El área 3000 concentra 143 (100%).</a:t>
             </a:r>
             <a:endParaRPr lang="en-US" sz="1250" dirty="0"/>
           </a:p>
@@ -10288,7 +10288,7 @@
                 <a:ea typeface="Calibri" pitchFamily="34" charset="-122"/>
                 <a:cs typeface="Calibri" pitchFamily="34" charset="-120"/>
               </a:rPr>
-              <a:t>Fuente: Estatus_Resumen_General_QAQC.xlsx · Corte 19-10-2026 · Áreas 2000/3000/4000/8000</a:t>
+              <a:t>Fuente: Estatus_Resumen_General_QAQC.xlsx · Corte 26-10-2026 · Áreas 2000/3000/4000/8000</a:t>
             </a:r>
             <a:endParaRPr lang="en-US" sz="850" dirty="0"/>
           </a:p>
@@ -10406,7 +10406,7 @@
       </p:grpSpPr>
       <p:pic>
         <p:nvPicPr>
-          <p:cNvPr id="2" name="Image 0" descr="/workspace/dashboard-hseq/panel_control_TOP_P1/besalco_logo.png">    </p:cNvPr>
+          <p:cNvPr id="2" name="Image 0" descr="/home/user/dashboard-hseq/panel_control_TOP_P1/besalco_logo.png">    </p:cNvPr>
           <p:cNvPicPr>
             <a:picLocks noChangeAspect="1"/>
           </p:cNvPicPr>
@@ -11407,7 +11407,7 @@
                 <a:ea typeface="Calibri" pitchFamily="34" charset="-122"/>
                 <a:cs typeface="Calibri" pitchFamily="34" charset="-120"/>
               </a:rPr>
-              <a:t>78,8%</a:t>
+              <a:t>88,4%</a:t>
             </a:r>
             <a:endParaRPr lang="en-US" sz="1300" dirty="0"/>
           </a:p>
@@ -11446,7 +11446,7 @@
                 <a:ea typeface="Calibri" pitchFamily="34" charset="-122"/>
                 <a:cs typeface="Calibri" pitchFamily="34" charset="-120"/>
               </a:rPr>
-              <a:t>260 (140)</a:t>
+              <a:t>143 (86)</a:t>
             </a:r>
             <a:endParaRPr lang="en-US" sz="1300" dirty="0"/>
           </a:p>
@@ -11725,7 +11725,7 @@
                 <a:ea typeface="Calibri" pitchFamily="34" charset="-122"/>
                 <a:cs typeface="Calibri" pitchFamily="34" charset="-120"/>
               </a:rPr>
-              <a:t>7/22 · 31,8%</a:t>
+              <a:t>10/22 · 45,5%</a:t>
             </a:r>
             <a:endParaRPr lang="en-US" sz="1300" dirty="0"/>
           </a:p>
@@ -11764,7 +11764,7 @@
                 <a:ea typeface="Calibri" pitchFamily="34" charset="-122"/>
                 <a:cs typeface="Calibri" pitchFamily="34" charset="-120"/>
               </a:rPr>
-              <a:t>97,8%</a:t>
+              <a:t>100%</a:t>
             </a:r>
             <a:endParaRPr lang="en-US" sz="1300" dirty="0"/>
           </a:p>
@@ -11803,7 +11803,7 @@
                 <a:ea typeface="Calibri" pitchFamily="34" charset="-122"/>
                 <a:cs typeface="Calibri" pitchFamily="34" charset="-120"/>
               </a:rPr>
-              <a:t>8 (6)</a:t>
+              <a:t>0 (0)</a:t>
             </a:r>
             <a:endParaRPr lang="en-US" sz="1300" dirty="0"/>
           </a:p>
@@ -12342,7 +12342,7 @@
                 <a:ea typeface="Calibri" pitchFamily="34" charset="-122"/>
                 <a:cs typeface="Calibri" pitchFamily="34" charset="-120"/>
               </a:rPr>
-              <a:t>Fuente: Estatus_Resumen_General_QAQC.xlsx · Corte 19-10-2026 · Áreas 2000/3000/4000/8000</a:t>
+              <a:t>Fuente: Estatus_Resumen_General_QAQC.xlsx · Corte 26-10-2026 · Áreas 2000/3000/4000/8000</a:t>
             </a:r>
             <a:endParaRPr lang="en-US" sz="850" dirty="0"/>
           </a:p>
@@ -12460,7 +12460,7 @@
       </p:grpSpPr>
       <p:pic>
         <p:nvPicPr>
-          <p:cNvPr id="2" name="Image 0" descr="/workspace/dashboard-hseq/panel_control_TOP_P1/besalco_logo.png">    </p:cNvPr>
+          <p:cNvPr id="2" name="Image 0" descr="/home/user/dashboard-hseq/panel_control_TOP_P1/besalco_logo.png">    </p:cNvPr>
           <p:cNvPicPr>
             <a:picLocks noChangeAspect="1"/>
           </p:cNvPicPr>
@@ -12986,7 +12986,7 @@
                 <a:ea typeface="Calibri" pitchFamily="34" charset="-122"/>
                 <a:cs typeface="Calibri" pitchFamily="34" charset="-120"/>
               </a:rPr>
-              <a:t>Fuente: Estatus_Resumen_General_QAQC.xlsx · Corte 19-10-2026 · Áreas 2000/3000/4000/8000</a:t>
+              <a:t>Fuente: Estatus_Resumen_General_QAQC.xlsx · Corte 26-10-2026 · Áreas 2000/3000/4000/8000</a:t>
             </a:r>
             <a:endParaRPr lang="en-US" sz="850" dirty="0"/>
           </a:p>
@@ -13104,7 +13104,7 @@
       </p:grpSpPr>
       <p:pic>
         <p:nvPicPr>
-          <p:cNvPr id="2" name="Image 0" descr="/workspace/dashboard-hseq/panel_control_TOP_P1/besalco_logo.png">    </p:cNvPr>
+          <p:cNvPr id="2" name="Image 0" descr="/home/user/dashboard-hseq/panel_control_TOP_P1/besalco_logo.png">    </p:cNvPr>
           <p:cNvPicPr>
             <a:picLocks noChangeAspect="1"/>
           </p:cNvPicPr>
@@ -13237,7 +13237,7 @@
                 <a:ea typeface="Calibri" pitchFamily="34" charset="-122"/>
                 <a:cs typeface="Calibri" pitchFamily="34" charset="-120"/>
               </a:rPr>
-              <a:t>46 carpetas entregadas de 136 (33,8%). Ninguna aprobada aún: el flujo se acumula en revisión y hay 30 rechazos que requieren rearmado.</a:t>
+              <a:t>49 carpetas entregadas de 136 (36%). Ninguna aprobada aún: el flujo se acumula en revisión y hay 30 rechazos que requieren rearmado.</a:t>
             </a:r>
             <a:endParaRPr lang="en-US" sz="1350" dirty="0"/>
           </a:p>
@@ -13414,6 +13414,45 @@
         </p:nvSpPr>
         <p:spPr>
           <a:xfrm>
+            <a:off x="9509760" y="2450592"/>
+            <a:ext cx="914400" cy="566928"/>
+          </a:xfrm>
+          <a:prstGeom prst="rect">
+            <a:avLst/>
+          </a:prstGeom>
+          <a:noFill/>
+          <a:ln/>
+        </p:spPr>
+        <p:txBody>
+          <a:bodyPr wrap="square" lIns="0" tIns="0" rIns="0" bIns="0" rtlCol="0" anchor="ctr"/>
+          <a:lstStyle/>
+          <a:p>
+            <a:pPr algn="r" indent="0" marL="0">
+              <a:buNone/>
+            </a:pPr>
+            <a:r>
+              <a:rPr lang="en-US" sz="950" b="1" dirty="0">
+                <a:solidFill>
+                  <a:srgbClr val="1F7A44"/>
+                </a:solidFill>
+                <a:latin typeface="Calibri" pitchFamily="34" charset="0"/>
+                <a:ea typeface="Calibri" pitchFamily="34" charset="-122"/>
+                <a:cs typeface="Calibri" pitchFamily="34" charset="-120"/>
+              </a:rPr>
+              <a:t>▲ +3</a:t>
+            </a:r>
+            <a:endParaRPr lang="en-US" sz="950" dirty="0"/>
+          </a:p>
+        </p:txBody>
+      </p:sp>
+      <p:sp>
+        <p:nvSpPr>
+          <p:cNvPr id="13" name="Text 9"/>
+          <p:cNvSpPr/>
+          <p:nvPr/>
+        </p:nvSpPr>
+        <p:spPr>
+          <a:xfrm>
             <a:off x="10469880" y="2450592"/>
             <a:ext cx="868680" cy="566928"/>
           </a:xfrm>
@@ -13439,7 +13478,7 @@
                 <a:ea typeface="Cambria" pitchFamily="34" charset="-122"/>
                 <a:cs typeface="Cambria" pitchFamily="34" charset="-120"/>
               </a:rPr>
-              <a:t>46</a:t>
+              <a:t>49</a:t>
             </a:r>
             <a:endParaRPr lang="en-US" sz="2200" dirty="0"/>
           </a:p>
@@ -13447,7 +13486,7 @@
       </p:sp>
       <p:sp>
         <p:nvSpPr>
-          <p:cNvPr id="13" name="Shape 9"/>
+          <p:cNvPr id="14" name="Shape 10"/>
           <p:cNvSpPr/>
           <p:nvPr/>
         </p:nvSpPr>
@@ -13469,7 +13508,7 @@
       </p:sp>
       <p:sp>
         <p:nvSpPr>
-          <p:cNvPr id="14" name="Shape 10"/>
+          <p:cNvPr id="15" name="Shape 11"/>
           <p:cNvSpPr/>
           <p:nvPr/>
         </p:nvSpPr>
@@ -13489,7 +13528,7 @@
       </p:sp>
       <p:sp>
         <p:nvSpPr>
-          <p:cNvPr id="15" name="Text 11"/>
+          <p:cNvPr id="16" name="Text 12"/>
           <p:cNvSpPr/>
           <p:nvPr/>
         </p:nvSpPr>
@@ -13528,7 +13567,7 @@
       </p:sp>
       <p:sp>
         <p:nvSpPr>
-          <p:cNvPr id="16" name="Text 12"/>
+          <p:cNvPr id="17" name="Text 13"/>
           <p:cNvSpPr/>
           <p:nvPr/>
         </p:nvSpPr>
@@ -13553,13 +13592,13 @@
             <a:r>
               <a:rPr lang="en-US" sz="950" b="1" dirty="0">
                 <a:solidFill>
-                  <a:srgbClr val="C0392B"/>
-                </a:solidFill>
-                <a:latin typeface="Calibri" pitchFamily="34" charset="0"/>
-                <a:ea typeface="Calibri" pitchFamily="34" charset="-122"/>
-                <a:cs typeface="Calibri" pitchFamily="34" charset="-120"/>
-              </a:rPr>
-              <a:t>▼ -6</a:t>
+                  <a:srgbClr val="1F7A44"/>
+                </a:solidFill>
+                <a:latin typeface="Calibri" pitchFamily="34" charset="0"/>
+                <a:ea typeface="Calibri" pitchFamily="34" charset="-122"/>
+                <a:cs typeface="Calibri" pitchFamily="34" charset="-120"/>
+              </a:rPr>
+              <a:t>▲ +3</a:t>
             </a:r>
             <a:endParaRPr lang="en-US" sz="950" dirty="0"/>
           </a:p>
@@ -13567,7 +13606,7 @@
       </p:sp>
       <p:sp>
         <p:nvSpPr>
-          <p:cNvPr id="17" name="Text 13"/>
+          <p:cNvPr id="18" name="Text 14"/>
           <p:cNvSpPr/>
           <p:nvPr/>
         </p:nvSpPr>
@@ -13598,7 +13637,7 @@
                 <a:ea typeface="Cambria" pitchFamily="34" charset="-122"/>
                 <a:cs typeface="Cambria" pitchFamily="34" charset="-120"/>
               </a:rPr>
-              <a:t>15</a:t>
+              <a:t>18</a:t>
             </a:r>
             <a:endParaRPr lang="en-US" sz="2200" dirty="0"/>
           </a:p>
@@ -13606,7 +13645,7 @@
       </p:sp>
       <p:sp>
         <p:nvSpPr>
-          <p:cNvPr id="18" name="Shape 14"/>
+          <p:cNvPr id="19" name="Shape 15"/>
           <p:cNvSpPr/>
           <p:nvPr/>
         </p:nvSpPr>
@@ -13628,7 +13667,7 @@
       </p:sp>
       <p:sp>
         <p:nvSpPr>
-          <p:cNvPr id="19" name="Shape 15"/>
+          <p:cNvPr id="20" name="Shape 16"/>
           <p:cNvSpPr/>
           <p:nvPr/>
         </p:nvSpPr>
@@ -13648,7 +13687,7 @@
       </p:sp>
       <p:sp>
         <p:nvSpPr>
-          <p:cNvPr id="20" name="Text 16"/>
+          <p:cNvPr id="21" name="Text 17"/>
           <p:cNvSpPr/>
           <p:nvPr/>
         </p:nvSpPr>
@@ -13687,7 +13726,7 @@
       </p:sp>
       <p:sp>
         <p:nvSpPr>
-          <p:cNvPr id="21" name="Text 17"/>
+          <p:cNvPr id="22" name="Text 18"/>
           <p:cNvSpPr/>
           <p:nvPr/>
         </p:nvSpPr>
@@ -13726,7 +13765,7 @@
       </p:sp>
       <p:sp>
         <p:nvSpPr>
-          <p:cNvPr id="22" name="Shape 18"/>
+          <p:cNvPr id="23" name="Shape 19"/>
           <p:cNvSpPr/>
           <p:nvPr/>
         </p:nvSpPr>
@@ -13748,7 +13787,7 @@
       </p:sp>
       <p:sp>
         <p:nvSpPr>
-          <p:cNvPr id="23" name="Shape 19"/>
+          <p:cNvPr id="24" name="Shape 20"/>
           <p:cNvSpPr/>
           <p:nvPr/>
         </p:nvSpPr>
@@ -13768,7 +13807,7 @@
       </p:sp>
       <p:sp>
         <p:nvSpPr>
-          <p:cNvPr id="24" name="Text 20"/>
+          <p:cNvPr id="25" name="Text 21"/>
           <p:cNvSpPr/>
           <p:nvPr/>
         </p:nvSpPr>
@@ -13802,45 +13841,6 @@
               <a:t>Rechazadas</a:t>
             </a:r>
             <a:endParaRPr lang="en-US" sz="1250" dirty="0"/>
-          </a:p>
-        </p:txBody>
-      </p:sp>
-      <p:sp>
-        <p:nvSpPr>
-          <p:cNvPr id="25" name="Text 21"/>
-          <p:cNvSpPr/>
-          <p:nvPr/>
-        </p:nvSpPr>
-        <p:spPr>
-          <a:xfrm>
-            <a:off x="9509760" y="4315968"/>
-            <a:ext cx="914400" cy="566928"/>
-          </a:xfrm>
-          <a:prstGeom prst="rect">
-            <a:avLst/>
-          </a:prstGeom>
-          <a:noFill/>
-          <a:ln/>
-        </p:spPr>
-        <p:txBody>
-          <a:bodyPr wrap="square" lIns="0" tIns="0" rIns="0" bIns="0" rtlCol="0" anchor="ctr"/>
-          <a:lstStyle/>
-          <a:p>
-            <a:pPr algn="r" indent="0" marL="0">
-              <a:buNone/>
-            </a:pPr>
-            <a:r>
-              <a:rPr lang="en-US" sz="950" b="1" dirty="0">
-                <a:solidFill>
-                  <a:srgbClr val="C0392B"/>
-                </a:solidFill>
-                <a:latin typeface="Calibri" pitchFamily="34" charset="0"/>
-                <a:ea typeface="Calibri" pitchFamily="34" charset="-122"/>
-                <a:cs typeface="Calibri" pitchFamily="34" charset="-120"/>
-              </a:rPr>
-              <a:t>▲ +6</a:t>
-            </a:r>
-            <a:endParaRPr lang="en-US" sz="950" dirty="0"/>
           </a:p>
         </p:txBody>
       </p:sp>
@@ -14075,7 +14075,7 @@
                 <a:ea typeface="Calibri" pitchFamily="34" charset="-122"/>
                 <a:cs typeface="Calibri" pitchFamily="34" charset="-120"/>
               </a:rPr>
-              <a:t>Fuente: Estatus_Resumen_General_QAQC.xlsx · Corte 19-10-2026 · Áreas 2000/3000/4000/8000</a:t>
+              <a:t>Fuente: Estatus_Resumen_General_QAQC.xlsx · Corte 26-10-2026 · Áreas 2000/3000/4000/8000</a:t>
             </a:r>
             <a:endParaRPr lang="en-US" sz="850" dirty="0"/>
           </a:p>
@@ -14193,7 +14193,7 @@
       </p:grpSpPr>
       <p:pic>
         <p:nvPicPr>
-          <p:cNvPr id="2" name="Image 0" descr="/workspace/dashboard-hseq/panel_control_TOP_P1/besalco_logo.png">    </p:cNvPr>
+          <p:cNvPr id="2" name="Image 0" descr="/home/user/dashboard-hseq/panel_control_TOP_P1/besalco_logo.png">    </p:cNvPr>
           <p:cNvPicPr>
             <a:picLocks noChangeAspect="1"/>
           </p:cNvPicPr>
@@ -14326,7 +14326,7 @@
                 <a:ea typeface="Calibri" pitchFamily="34" charset="-122"/>
                 <a:cs typeface="Calibri" pitchFamily="34" charset="-120"/>
               </a:rPr>
-              <a:t>2.182 P1 levantados; 87,7% cerrados. El pendiente se concentra en Instrumentación y Control, Eléctrica, Piping, y físicamente en el área 3000.</a:t>
+              <a:t>2.182 P1 levantados; 93,4% cerrados. El pendiente se concentra en Instrumentación y Control, Eléctrica, Piping, y físicamente en el área 3000.</a:t>
             </a:r>
             <a:endParaRPr lang="en-US" sz="1350" dirty="0"/>
           </a:p>
@@ -14458,7 +14458,7 @@
                 <a:ea typeface="Cambria" pitchFamily="34" charset="-122"/>
                 <a:cs typeface="Cambria" pitchFamily="34" charset="-120"/>
               </a:rPr>
-              <a:t>87,7%</a:t>
+              <a:t>93,4%</a:t>
             </a:r>
             <a:endParaRPr lang="en-US" sz="1900" dirty="0"/>
           </a:p>
@@ -14573,7 +14573,7 @@
                 <a:ea typeface="Calibri" pitchFamily="34" charset="-122"/>
                 <a:cs typeface="Calibri" pitchFamily="34" charset="-120"/>
               </a:rPr>
-              <a:t>1.914</a:t>
+              <a:t>2.039</a:t>
             </a:r>
             <a:endParaRPr lang="en-US" sz="1100" dirty="0"/>
           </a:p>
@@ -14671,7 +14671,7 @@
                 <a:ea typeface="Calibri" pitchFamily="34" charset="-122"/>
                 <a:cs typeface="Calibri" pitchFamily="34" charset="-120"/>
               </a:rPr>
-              <a:t>268</a:t>
+              <a:t>143</a:t>
             </a:r>
             <a:endParaRPr lang="en-US" sz="1100" dirty="0"/>
           </a:p>
@@ -14852,7 +14852,7 @@
                 <a:ea typeface="Calibri" pitchFamily="34" charset="-122"/>
                 <a:cs typeface="Calibri" pitchFamily="34" charset="-120"/>
               </a:rPr>
-              <a:t>260 de 268 P1 abiertos (97%) están en el área 3000. Áreas 2000 y 4000 y 8000 sobre 90% de cierre.</a:t>
+              <a:t>143 de 143 P1 abiertos (100%) están en el área 3000. Áreas 2000 y 4000 y 8000 sobre 90% de cierre.</a:t>
             </a:r>
             <a:endParaRPr lang="en-US" sz="1150" dirty="0"/>
           </a:p>
@@ -14891,7 +14891,7 @@
                 <a:ea typeface="Calibri" pitchFamily="34" charset="-122"/>
                 <a:cs typeface="Calibri" pitchFamily="34" charset="-120"/>
               </a:rPr>
-              <a:t>Fuente: Estatus_Resumen_General_QAQC.xlsx · Corte 19-10-2026 · Áreas 2000/3000/4000/8000</a:t>
+              <a:t>Fuente: Estatus_Resumen_General_QAQC.xlsx · Corte 26-10-2026 · Áreas 2000/3000/4000/8000</a:t>
             </a:r>
             <a:endParaRPr lang="en-US" sz="850" dirty="0"/>
           </a:p>
@@ -15009,7 +15009,7 @@
       </p:grpSpPr>
       <p:pic>
         <p:nvPicPr>
-          <p:cNvPr id="2" name="Image 0" descr="/workspace/dashboard-hseq/panel_control_TOP_P1/besalco_logo.png">    </p:cNvPr>
+          <p:cNvPr id="2" name="Image 0" descr="/home/user/dashboard-hseq/panel_control_TOP_P1/besalco_logo.png">    </p:cNvPr>
           <p:cNvPicPr>
             <a:picLocks noChangeAspect="1"/>
           </p:cNvPicPr>
@@ -15265,7 +15265,7 @@
                 <a:ea typeface="Calibri" pitchFamily="34" charset="-122"/>
                 <a:cs typeface="Calibri" pitchFamily="34" charset="-120"/>
               </a:rPr>
-              <a:t>0 aprobadas de 136. Priorizar el cierre de las 15 en revisión y el rearmado de las 30 rechazadas para convertir entregas en aprobaciones.</a:t>
+              <a:t>0 aprobadas de 136. Priorizar el cierre de las 18 en revisión y el rearmado de las 30 rechazadas para convertir entregas en aprobaciones.</a:t>
             </a:r>
             <a:endParaRPr lang="en-US" sz="1150" dirty="0"/>
           </a:p>
@@ -15407,7 +15407,7 @@
                 <a:ea typeface="Calibri" pitchFamily="34" charset="-122"/>
                 <a:cs typeface="Calibri" pitchFamily="34" charset="-120"/>
               </a:rPr>
-              <a:t>260 P1 abiertos (97% del total) y 0 caminatas 100% pendientes. Es la ruta crítica: sin esta área no mejora ningún indicador global.</a:t>
+              <a:t>143 P1 abiertos (100% del total) y 0 caminatas 100% pendientes. Es la ruta crítica: sin esta área no mejora ningún indicador global.</a:t>
             </a:r>
             <a:endParaRPr lang="en-US" sz="1150" dirty="0"/>
           </a:p>
@@ -15507,7 +15507,7 @@
                 <a:ea typeface="Calibri" pitchFamily="34" charset="-122"/>
                 <a:cs typeface="Calibri" pitchFamily="34" charset="-120"/>
               </a:rPr>
-              <a:t>Recuperar los 146 P1 vencidos</a:t>
+              <a:t>Recuperar los 86 P1 vencidos</a:t>
             </a:r>
             <a:endParaRPr lang="en-US" sz="1500" dirty="0"/>
           </a:p>
@@ -15549,7 +15549,7 @@
                 <a:ea typeface="Calibri" pitchFamily="34" charset="-122"/>
                 <a:cs typeface="Calibri" pitchFamily="34" charset="-120"/>
               </a:rPr>
-              <a:t>54,5% de los P1 abiertos superó su fecha de vencimiento. Foco en Instrumentación y Control (64), Eléctrica (54), Piping (26).</a:t>
+              <a:t>60,1% de los P1 abiertos superó su fecha de vencimiento. Foco en Instrumentación y Control (39), Eléctrica (33), Piping (10).</a:t>
             </a:r>
             <a:endParaRPr lang="en-US" sz="1150" dirty="0"/>
           </a:p>
@@ -15730,7 +15730,7 @@
                 <a:ea typeface="Calibri" pitchFamily="34" charset="-122"/>
                 <a:cs typeface="Calibri" pitchFamily="34" charset="-120"/>
               </a:rPr>
-              <a:t>Fuente: Estatus_Resumen_General_QAQC.xlsx · Corte 19-10-2026 · Áreas 2000/3000/4000/8000</a:t>
+              <a:t>Fuente: Estatus_Resumen_General_QAQC.xlsx · Corte 26-10-2026 · Áreas 2000/3000/4000/8000</a:t>
             </a:r>
             <a:endParaRPr lang="en-US" sz="850" dirty="0"/>
           </a:p>
@@ -15848,7 +15848,7 @@
       </p:grpSpPr>
       <p:pic>
         <p:nvPicPr>
-          <p:cNvPr id="2" name="Image 0" descr="/workspace/dashboard-hseq/panel_control_TOP_P1/besalco_logo.png">    </p:cNvPr>
+          <p:cNvPr id="2" name="Image 0" descr="/home/user/dashboard-hseq/panel_control_TOP_P1/besalco_logo.png">    </p:cNvPr>
           <p:cNvPicPr>
             <a:picLocks noChangeAspect="1"/>
           </p:cNvPicPr>
@@ -16461,7 +16461,7 @@
                 <a:ea typeface="Cambria" pitchFamily="34" charset="-122"/>
                 <a:cs typeface="Cambria" pitchFamily="34" charset="-120"/>
               </a:rPr>
-              <a:t>71,6%</a:t>
+              <a:t>74,7%</a:t>
             </a:r>
             <a:endParaRPr lang="en-US" sz="3800" dirty="0"/>
           </a:p>
@@ -16500,7 +16500,7 @@
                 <a:ea typeface="Calibri" pitchFamily="34" charset="-122"/>
                 <a:cs typeface="Calibri" pitchFamily="34" charset="-120"/>
               </a:rPr>
-              <a:t>68/95</a:t>
+              <a:t>71/95</a:t>
             </a:r>
             <a:endParaRPr lang="en-US" sz="1400" dirty="0"/>
           </a:p>
@@ -16581,7 +16581,7 @@
                 <a:ea typeface="Calibri" pitchFamily="34" charset="-122"/>
                 <a:cs typeface="Calibri" pitchFamily="34" charset="-120"/>
               </a:rPr>
-              <a:t>51 aprobadas · 10 en revisión · 7 rechazadas</a:t>
+              <a:t>56 aprobadas · 8 en revisión · 7 rechazadas</a:t>
             </a:r>
             <a:endParaRPr lang="en-US" sz="950" dirty="0"/>
           </a:p>
@@ -16674,7 +16674,7 @@
                 <a:ea typeface="Cambria" pitchFamily="34" charset="-122"/>
                 <a:cs typeface="Cambria" pitchFamily="34" charset="-120"/>
               </a:rPr>
-              <a:t>79,3%</a:t>
+              <a:t>82%</a:t>
             </a:r>
             <a:endParaRPr lang="en-US" sz="3800" dirty="0"/>
           </a:p>
@@ -16713,7 +16713,7 @@
                 <a:ea typeface="Calibri" pitchFamily="34" charset="-122"/>
                 <a:cs typeface="Calibri" pitchFamily="34" charset="-120"/>
               </a:rPr>
-              <a:t>1.341/1.692</a:t>
+              <a:t>1.412/1.723</a:t>
             </a:r>
             <a:endParaRPr lang="en-US" sz="1400" dirty="0"/>
           </a:p>
@@ -16794,7 +16794,7 @@
                 <a:ea typeface="Calibri" pitchFamily="34" charset="-122"/>
                 <a:cs typeface="Calibri" pitchFamily="34" charset="-120"/>
               </a:rPr>
-              <a:t>351 abiertos · 222 atrasados</a:t>
+              <a:t>311 abiertos · 212 atrasados</a:t>
             </a:r>
             <a:endParaRPr lang="en-US" sz="950" dirty="0"/>
           </a:p>
@@ -16934,7 +16934,7 @@
                 <a:ea typeface="Calibri" pitchFamily="34" charset="-122"/>
                 <a:cs typeface="Calibri" pitchFamily="34" charset="-120"/>
               </a:rPr>
-              <a:t>2.114 de 2.715 ítems cerrados (77,9%); de los 601 abiertos, 385 ya pasaron su fecha requerida de cierre (64,1%).</a:t>
+              <a:t>2.210 de 2.748 ítems cerrados (80,4%); de los 538 abiertos, 370 ya pasaron su fecha requerida de cierre (68,8%).</a:t>
             </a:r>
             <a:endParaRPr lang="en-US" sz="1150" dirty="0"/>
           </a:p>
@@ -17075,7 +17075,7 @@
                 <a:ea typeface="Calibri" pitchFamily="34" charset="-122"/>
                 <a:cs typeface="Calibri" pitchFamily="34" charset="-120"/>
               </a:rPr>
-              <a:t>Las carpetas están a 71,6% de entrega y el cuello está en el armado interno.  </a:t>
+              <a:t>Las carpetas están a 74,7% de entrega y el cuello está en el armado interno.  </a:t>
             </a:r>
             <a:pPr indent="0" marL="0">
               <a:lnSpc>
@@ -17092,7 +17092,7 @@
                 <a:ea typeface="Calibri" pitchFamily="34" charset="-122"/>
                 <a:cs typeface="Calibri" pitchFamily="34" charset="-120"/>
               </a:rPr>
-              <a:t>68 entregadas de 95: 51 aprobadas, 10 en revisión y 7 rechazadas. Quedan 16 en preparación y 11 sin iniciar.</a:t>
+              <a:t>71 entregadas de 95: 56 aprobadas, 8 en revisión y 7 rechazadas. Quedan 13 en preparación y 11 sin iniciar.</a:t>
             </a:r>
             <a:endParaRPr lang="en-US" sz="1150" dirty="0"/>
           </a:p>
@@ -17171,7 +17171,7 @@
                 <a:ea typeface="Calibri" pitchFamily="34" charset="-122"/>
                 <a:cs typeface="Calibri" pitchFamily="34" charset="-120"/>
               </a:rPr>
-              <a:t>174 de los 351 P1 abiertos (49,6%), con 104 atrasados.</a:t>
+              <a:t>169 de los 311 P1 abiertos (54,3%), con 103 atrasados.</a:t>
             </a:r>
             <a:endParaRPr lang="en-US" sz="1150" dirty="0"/>
           </a:p>
@@ -17210,7 +17210,7 @@
                 <a:ea typeface="Calibri" pitchFamily="34" charset="-122"/>
                 <a:cs typeface="Calibri" pitchFamily="34" charset="-120"/>
               </a:rPr>
-              <a:t>Fuente: REPORTE_GERENCIAL + Listado de Puntos Punch Consolidado · Corte 13-10-2026 · Atrasos al 19-10-2026</a:t>
+              <a:t>Fuente: REPORTE_GERENCIAL + Listado de Puntos Punch Consolidado · Corte 20-10-2026 · Atrasos al 26-10-2026</a:t>
             </a:r>
             <a:endParaRPr lang="en-US" sz="850" dirty="0"/>
           </a:p>
@@ -17328,7 +17328,7 @@
       </p:grpSpPr>
       <p:pic>
         <p:nvPicPr>
-          <p:cNvPr id="2" name="Image 0" descr="/workspace/dashboard-hseq/panel_control_TOP_P1/besalco_logo.png">    </p:cNvPr>
+          <p:cNvPr id="2" name="Image 0" descr="/home/user/dashboard-hseq/panel_control_TOP_P1/besalco_logo.png">    </p:cNvPr>
           <p:cNvPicPr>
             <a:picLocks noChangeAspect="1"/>
           </p:cNvPicPr>
@@ -17663,7 +17663,7 @@
                 <a:ea typeface="Calibri" pitchFamily="34" charset="-122"/>
                 <a:cs typeface="Calibri" pitchFamily="34" charset="-120"/>
               </a:rPr>
-              <a:t>53,7%</a:t>
+              <a:t>58,9%</a:t>
             </a:r>
             <a:endParaRPr lang="en-US" sz="1100" dirty="0"/>
           </a:p>
@@ -17702,7 +17702,7 @@
                 <a:ea typeface="Cambria" pitchFamily="34" charset="-122"/>
                 <a:cs typeface="Cambria" pitchFamily="34" charset="-120"/>
               </a:rPr>
-              <a:t>51</a:t>
+              <a:t>56</a:t>
             </a:r>
             <a:endParaRPr lang="en-US" sz="2200" dirty="0"/>
           </a:p>
@@ -17822,7 +17822,7 @@
                 <a:ea typeface="Calibri" pitchFamily="34" charset="-122"/>
                 <a:cs typeface="Calibri" pitchFamily="34" charset="-120"/>
               </a:rPr>
-              <a:t>10,5%</a:t>
+              <a:t>8,4%</a:t>
             </a:r>
             <a:endParaRPr lang="en-US" sz="1100" dirty="0"/>
           </a:p>
@@ -17861,7 +17861,7 @@
                 <a:ea typeface="Cambria" pitchFamily="34" charset="-122"/>
                 <a:cs typeface="Cambria" pitchFamily="34" charset="-120"/>
               </a:rPr>
-              <a:t>10</a:t>
+              <a:t>8</a:t>
             </a:r>
             <a:endParaRPr lang="en-US" sz="2200" dirty="0"/>
           </a:p>
@@ -18140,7 +18140,7 @@
                 <a:ea typeface="Calibri" pitchFamily="34" charset="-122"/>
                 <a:cs typeface="Calibri" pitchFamily="34" charset="-120"/>
               </a:rPr>
-              <a:t>16,8%</a:t>
+              <a:t>13,7%</a:t>
             </a:r>
             <a:endParaRPr lang="en-US" sz="1100" dirty="0"/>
           </a:p>
@@ -18179,7 +18179,7 @@
                 <a:ea typeface="Cambria" pitchFamily="34" charset="-122"/>
                 <a:cs typeface="Cambria" pitchFamily="34" charset="-120"/>
               </a:rPr>
-              <a:t>16</a:t>
+              <a:t>13</a:t>
             </a:r>
             <a:endParaRPr lang="en-US" sz="2200" dirty="0"/>
           </a:p>
@@ -18380,7 +18380,7 @@
                 <a:ea typeface="Calibri" pitchFamily="34" charset="-122"/>
                 <a:cs typeface="Calibri" pitchFamily="34" charset="-120"/>
               </a:rPr>
-              <a:t>68 carpetas ya están en manos del cliente (71,6%) y 52 subsistemas tienen tarjeta verde. El grueso del pendiente todavía no sale de Besalco.</a:t>
+              <a:t>71 carpetas ya están en manos del cliente (74,7%) y 56 subsistemas tienen tarjeta verde. El grueso del pendiente todavía no sale de Besalco.</a:t>
             </a:r>
             <a:endParaRPr lang="en-US" sz="1000" dirty="0"/>
           </a:p>
@@ -18419,7 +18419,7 @@
                 <a:ea typeface="Calibri" pitchFamily="34" charset="-122"/>
                 <a:cs typeface="Calibri" pitchFamily="34" charset="-120"/>
               </a:rPr>
-              <a:t>Fuente: REPORTE_GERENCIAL + Listado de Puntos Punch Consolidado · Corte 13-10-2026 · Atrasos al 19-10-2026</a:t>
+              <a:t>Fuente: REPORTE_GERENCIAL + Listado de Puntos Punch Consolidado · Corte 20-10-2026 · Atrasos al 26-10-2026</a:t>
             </a:r>
             <a:endParaRPr lang="en-US" sz="850" dirty="0"/>
           </a:p>
@@ -18537,7 +18537,7 @@
       </p:grpSpPr>
       <p:pic>
         <p:nvPicPr>
-          <p:cNvPr id="2" name="Image 0" descr="/workspace/dashboard-hseq/panel_control_TOP_P1/besalco_logo.png">    </p:cNvPr>
+          <p:cNvPr id="2" name="Image 0" descr="/home/user/dashboard-hseq/panel_control_TOP_P1/besalco_logo.png">    </p:cNvPr>
           <p:cNvPicPr>
             <a:picLocks noChangeAspect="1"/>
           </p:cNvPicPr>
@@ -18670,7 +18670,7 @@
                 <a:ea typeface="Calibri" pitchFamily="34" charset="-122"/>
                 <a:cs typeface="Calibri" pitchFamily="34" charset="-120"/>
               </a:rPr>
-              <a:t>1.692 P1 levantados; 79,3% cerrados. Atrasado = ítem abierto cuya fecha requerida de cierre ya venció al 19-10-2026.</a:t>
+              <a:t>1.723 P1 levantados; 82% cerrados. Atrasado = ítem abierto cuya fecha requerida de cierre ya venció al 26-10-2026.</a:t>
             </a:r>
             <a:endParaRPr lang="en-US" sz="1350" dirty="0"/>
           </a:p>
@@ -18802,7 +18802,7 @@
                 <a:ea typeface="Cambria" pitchFamily="34" charset="-122"/>
                 <a:cs typeface="Cambria" pitchFamily="34" charset="-120"/>
               </a:rPr>
-              <a:t>79,3%</a:t>
+              <a:t>82%</a:t>
             </a:r>
             <a:endParaRPr lang="en-US" sz="1900" dirty="0"/>
           </a:p>
@@ -18917,7 +18917,7 @@
                 <a:ea typeface="Calibri" pitchFamily="34" charset="-122"/>
                 <a:cs typeface="Calibri" pitchFamily="34" charset="-120"/>
               </a:rPr>
-              <a:t>1.341</a:t>
+              <a:t>1.412</a:t>
             </a:r>
             <a:endParaRPr lang="en-US" sz="1100" dirty="0"/>
           </a:p>
@@ -19015,7 +19015,7 @@
                 <a:ea typeface="Calibri" pitchFamily="34" charset="-122"/>
                 <a:cs typeface="Calibri" pitchFamily="34" charset="-120"/>
               </a:rPr>
-              <a:t>222</a:t>
+              <a:t>212</a:t>
             </a:r>
             <a:endParaRPr lang="en-US" sz="1100" dirty="0"/>
           </a:p>
@@ -19113,7 +19113,7 @@
                 <a:ea typeface="Calibri" pitchFamily="34" charset="-122"/>
                 <a:cs typeface="Calibri" pitchFamily="34" charset="-120"/>
               </a:rPr>
-              <a:t>129</a:t>
+              <a:t>99</a:t>
             </a:r>
             <a:endParaRPr lang="en-US" sz="1100" dirty="0"/>
           </a:p>
@@ -19196,7 +19196,7 @@
                 <a:ea typeface="Calibri" pitchFamily="34" charset="-122"/>
                 <a:cs typeface="Calibri" pitchFamily="34" charset="-120"/>
               </a:rPr>
-              <a:t>Mediana de 19 días vencidos; el más antiguo lleva 162. 212 entre 1-30 días, 96 entre 31-90 días, 77 entre 91-180 días.</a:t>
+              <a:t>Mediana de 26 días vencidos; el más antiguo lleva 169. 190 entre 1-30 días, 104 entre 31-90 días, 76 entre 91-180 días.</a:t>
             </a:r>
             <a:endParaRPr lang="en-US" sz="1150" dirty="0"/>
           </a:p>
@@ -19235,7 +19235,7 @@
                 <a:ea typeface="Calibri" pitchFamily="34" charset="-122"/>
                 <a:cs typeface="Calibri" pitchFamily="34" charset="-120"/>
               </a:rPr>
-              <a:t>Fuente: REPORTE_GERENCIAL + Listado de Puntos Punch Consolidado · Corte 13-10-2026 · Atrasos al 19-10-2026</a:t>
+              <a:t>Fuente: REPORTE_GERENCIAL + Listado de Puntos Punch Consolidado · Corte 20-10-2026 · Atrasos al 26-10-2026</a:t>
             </a:r>
             <a:endParaRPr lang="en-US" sz="850" dirty="0"/>
           </a:p>
@@ -19353,7 +19353,7 @@
       </p:grpSpPr>
       <p:pic>
         <p:nvPicPr>
-          <p:cNvPr id="2" name="Image 0" descr="/workspace/dashboard-hseq/panel_control_TOP_P1/besalco_logo.png">    </p:cNvPr>
+          <p:cNvPr id="2" name="Image 0" descr="/home/user/dashboard-hseq/panel_control_TOP_P1/besalco_logo.png">    </p:cNvPr>
           <p:cNvPicPr>
             <a:picLocks noChangeAspect="1"/>
           </p:cNvPicPr>
@@ -19567,7 +19567,7 @@
                 <a:ea typeface="Calibri" pitchFamily="34" charset="-122"/>
                 <a:cs typeface="Calibri" pitchFamily="34" charset="-120"/>
               </a:rPr>
-              <a:t>Recuperar los 385 ítems atrasados</a:t>
+              <a:t>Recuperar los 370 ítems atrasados</a:t>
             </a:r>
             <a:endParaRPr lang="en-US" sz="1400" dirty="0"/>
           </a:p>
@@ -19609,7 +19609,7 @@
                 <a:ea typeface="Calibri" pitchFamily="34" charset="-122"/>
                 <a:cs typeface="Calibri" pitchFamily="34" charset="-120"/>
               </a:rPr>
-              <a:t>64,1% de los 601 abiertos ya venció su fecha requerida. Foco en Piping (104), Eléctrica (70), Mecánica (19).</a:t>
+              <a:t>68,8% de los 538 abiertos ya venció su fecha requerida. Foco en Piping (103), Eléctrica (70), Mecánica (13).</a:t>
             </a:r>
             <a:endParaRPr lang="en-US" sz="1100" dirty="0"/>
           </a:p>
@@ -19851,7 +19851,7 @@
                 <a:ea typeface="Calibri" pitchFamily="34" charset="-122"/>
                 <a:cs typeface="Calibri" pitchFamily="34" charset="-120"/>
               </a:rPr>
-              <a:t>Sacar del armado interno las 27 carpetas retenidas</a:t>
+              <a:t>Sacar del armado interno las 24 carpetas retenidas</a:t>
             </a:r>
             <a:endParaRPr lang="en-US" sz="1400" dirty="0"/>
           </a:p>
@@ -19893,7 +19893,7 @@
                 <a:ea typeface="Calibri" pitchFamily="34" charset="-122"/>
                 <a:cs typeface="Calibri" pitchFamily="34" charset="-120"/>
               </a:rPr>
-              <a:t>16 están en preparación y 11 sin iniciar. Solo 68 de 95 (71,6%) llegaron al cliente; 7 volvieron rechazadas y hay que rearmarlas.</a:t>
+              <a:t>13 están en preparación y 11 sin iniciar. Solo 71 de 95 (74,7%) llegaron al cliente; 7 volvieron rechazadas y hay que rearmarlas.</a:t>
             </a:r>
             <a:endParaRPr lang="en-US" sz="1100" dirty="0"/>
           </a:p>
@@ -20035,7 +20035,7 @@
                 <a:ea typeface="Calibri" pitchFamily="34" charset="-122"/>
                 <a:cs typeface="Calibri" pitchFamily="34" charset="-120"/>
               </a:rPr>
-              <a:t>Concentra 302 P1 abiertos y 173 atrasados sobre 74 subsistemas. Es la ruta crítica del proyecto.</a:t>
+              <a:t>Concentra 262 P1 abiertos y 163 atrasados sobre 74 subsistemas. Es la ruta crítica del proyecto.</a:t>
             </a:r>
             <a:endParaRPr lang="en-US" sz="1100" dirty="0"/>
           </a:p>
@@ -20074,7 +20074,7 @@
                 <a:ea typeface="Calibri" pitchFamily="34" charset="-122"/>
                 <a:cs typeface="Calibri" pitchFamily="34" charset="-120"/>
               </a:rPr>
-              <a:t>Fuente: REPORTE_GERENCIAL + Listado de Puntos Punch Consolidado · Corte 13-10-2026 · Atrasos al 19-10-2026</a:t>
+              <a:t>Fuente: REPORTE_GERENCIAL + Listado de Puntos Punch Consolidado · Corte 20-10-2026 · Atrasos al 26-10-2026</a:t>
             </a:r>
             <a:endParaRPr lang="en-US" sz="850" dirty="0"/>
           </a:p>
@@ -20192,7 +20192,7 @@
       </p:grpSpPr>
       <p:pic>
         <p:nvPicPr>
-          <p:cNvPr id="2" name="Image 0" descr="/workspace/dashboard-hseq/panel_control_TOP_P1/besalco_logo.png">    </p:cNvPr>
+          <p:cNvPr id="2" name="Image 0" descr="/home/user/dashboard-hseq/panel_control_TOP_P1/besalco_logo.png">    </p:cNvPr>
           <p:cNvPicPr>
             <a:picLocks noChangeAspect="1"/>
           </p:cNvPicPr>
@@ -20896,7 +20896,7 @@
       </p:grpSpPr>
       <p:pic>
         <p:nvPicPr>
-          <p:cNvPr id="2" name="Image 0" descr="/workspace/dashboard-hseq/panel_control_TOP_P1/besalco_logo.png">    </p:cNvPr>
+          <p:cNvPr id="2" name="Image 0" descr="/home/user/dashboard-hseq/panel_control_TOP_P1/besalco_logo.png">    </p:cNvPr>
           <p:cNvPicPr>
             <a:picLocks noChangeAspect="1"/>
           </p:cNvPicPr>
@@ -22376,7 +22376,7 @@
       </p:grpSpPr>
       <p:pic>
         <p:nvPicPr>
-          <p:cNvPr id="2" name="Image 0" descr="/workspace/dashboard-hseq/panel_control_TOP_P1/besalco_logo.png">    </p:cNvPr>
+          <p:cNvPr id="2" name="Image 0" descr="/home/user/dashboard-hseq/panel_control_TOP_P1/besalco_logo.png">    </p:cNvPr>
           <p:cNvPicPr>
             <a:picLocks noChangeAspect="1"/>
           </p:cNvPicPr>
@@ -22698,7 +22698,7 @@
       </p:grpSpPr>
       <p:pic>
         <p:nvPicPr>
-          <p:cNvPr id="2" name="Image 0" descr="/workspace/dashboard-hseq/panel_control_TOP_P1/besalco_logo.png">    </p:cNvPr>
+          <p:cNvPr id="2" name="Image 0" descr="/home/user/dashboard-hseq/panel_control_TOP_P1/besalco_logo.png">    </p:cNvPr>
           <p:cNvPicPr>
             <a:picLocks noChangeAspect="1"/>
           </p:cNvPicPr>

</xml_diff>